<commit_message>
Scale up all font sizes ~40% — body 16-22pt, titles 46-64pt
Body text was 9-14pt (too small). New scale:
- Body/bullets: 16-20pt
- Labels/eyebrows: 14-17pt
- Subtitles: 20-24pt
- Section titles: 46-50pt
- Hero/cover: 58-64pt
- Decorative numbers: 66-72pt

Co-Authored-By: Claude Sonnet 4.6 <noreply@anthropic.com>
Claude-Session: https://claude.ai/code/session_012BJMKNkvQJ6bNjyTN4A4ZY
</commit_message>
<xml_diff>
--- a/Social_Listening_Speech_FINAL_v4.pptx
+++ b/Social_Listening_Speech_FINAL_v4.pptx
@@ -3225,7 +3225,7 @@
           <a:p>
             <a:pPr algn="l"/>
             <a:r>
-              <a:rPr b="1" i="0" sz="5200">
+              <a:rPr b="1" i="0" sz="5800">
                 <a:solidFill>
                   <a:srgbClr val="F3EDE1"/>
                 </a:solidFill>
@@ -3331,7 +3331,7 @@
           <a:p>
             <a:pPr algn="l"/>
             <a:r>
-              <a:rPr b="0" i="0" sz="1300">
+              <a:rPr b="0" i="0" sz="1900">
                 <a:solidFill>
                   <a:srgbClr val="8A8175"/>
                 </a:solidFill>
@@ -3366,7 +3366,7 @@
           <a:p>
             <a:pPr algn="l"/>
             <a:r>
-              <a:rPr b="0" i="0" sz="1200">
+              <a:rPr b="0" i="0" sz="1700">
                 <a:solidFill>
                   <a:srgbClr val="8A8175"/>
                 </a:solidFill>
@@ -3470,7 +3470,7 @@
           <a:p>
             <a:pPr algn="l"/>
             <a:r>
-              <a:rPr b="1" i="0" sz="1000">
+              <a:rPr b="1" i="0" sz="1400">
                 <a:solidFill>
                   <a:srgbClr val="F3EDE1"/>
                 </a:solidFill>
@@ -3505,7 +3505,7 @@
           <a:p>
             <a:pPr algn="l"/>
             <a:r>
-              <a:rPr b="1" i="0" sz="4200">
+              <a:rPr b="1" i="0" sz="4800">
                 <a:solidFill>
                   <a:srgbClr val="3D3833"/>
                 </a:solidFill>
@@ -3540,7 +3540,7 @@
           <a:p>
             <a:pPr algn="l"/>
             <a:r>
-              <a:rPr b="0" i="1" sz="1300">
+              <a:rPr b="0" i="1" sz="1900">
                 <a:solidFill>
                   <a:srgbClr val="8A8175"/>
                 </a:solidFill>
@@ -3696,7 +3696,7 @@
           <a:p>
             <a:pPr algn="l"/>
             <a:r>
-              <a:rPr b="1" i="0" sz="6000">
+              <a:rPr b="1" i="0" sz="6600">
                 <a:solidFill>
                   <a:srgbClr val="E0D8C4"/>
                 </a:solidFill>
@@ -3731,7 +3731,7 @@
           <a:p>
             <a:pPr algn="l"/>
             <a:r>
-              <a:rPr b="1" i="0" sz="1400">
+              <a:rPr b="1" i="0" sz="2000">
                 <a:solidFill>
                   <a:srgbClr val="3D3833"/>
                 </a:solidFill>
@@ -3767,7 +3767,7 @@
           <a:p>
             <a:pPr algn="l"/>
             <a:r>
-              <a:rPr b="0" i="1" sz="1000">
+              <a:rPr b="0" i="1" sz="1400">
                 <a:solidFill>
                   <a:srgbClr val="B8523A"/>
                 </a:solidFill>
@@ -3802,7 +3802,7 @@
           <a:p>
             <a:pPr algn="l"/>
             <a:r>
-              <a:rPr b="0" i="0" sz="1100">
+              <a:rPr b="0" i="0" sz="1600">
                 <a:solidFill>
                   <a:srgbClr val="3D3833"/>
                 </a:solidFill>
@@ -3837,7 +3837,7 @@
           <a:p>
             <a:pPr algn="l"/>
             <a:r>
-              <a:rPr b="0" i="1" sz="1100">
+              <a:rPr b="0" i="1" sz="1600">
                 <a:solidFill>
                   <a:srgbClr val="8A8175"/>
                 </a:solidFill>
@@ -3958,7 +3958,7 @@
           <a:p>
             <a:pPr algn="l"/>
             <a:r>
-              <a:rPr b="1" i="0" sz="6000">
+              <a:rPr b="1" i="0" sz="6600">
                 <a:solidFill>
                   <a:srgbClr val="E0D8C4"/>
                 </a:solidFill>
@@ -3993,7 +3993,7 @@
           <a:p>
             <a:pPr algn="l"/>
             <a:r>
-              <a:rPr b="1" i="0" sz="1400">
+              <a:rPr b="1" i="0" sz="2000">
                 <a:solidFill>
                   <a:srgbClr val="3D3833"/>
                 </a:solidFill>
@@ -4029,7 +4029,7 @@
           <a:p>
             <a:pPr algn="l"/>
             <a:r>
-              <a:rPr b="0" i="1" sz="1000">
+              <a:rPr b="0" i="1" sz="1400">
                 <a:solidFill>
                   <a:srgbClr val="B8523A"/>
                 </a:solidFill>
@@ -4064,7 +4064,7 @@
           <a:p>
             <a:pPr algn="l"/>
             <a:r>
-              <a:rPr b="0" i="0" sz="1100">
+              <a:rPr b="0" i="0" sz="1600">
                 <a:solidFill>
                   <a:srgbClr val="3D3833"/>
                 </a:solidFill>
@@ -4099,7 +4099,7 @@
           <a:p>
             <a:pPr algn="l"/>
             <a:r>
-              <a:rPr b="0" i="1" sz="1100">
+              <a:rPr b="0" i="1" sz="1600">
                 <a:solidFill>
                   <a:srgbClr val="8A8175"/>
                 </a:solidFill>
@@ -4220,7 +4220,7 @@
           <a:p>
             <a:pPr algn="l"/>
             <a:r>
-              <a:rPr b="1" i="0" sz="6000">
+              <a:rPr b="1" i="0" sz="6600">
                 <a:solidFill>
                   <a:srgbClr val="E0D8C4"/>
                 </a:solidFill>
@@ -4255,7 +4255,7 @@
           <a:p>
             <a:pPr algn="l"/>
             <a:r>
-              <a:rPr b="1" i="0" sz="1400">
+              <a:rPr b="1" i="0" sz="2000">
                 <a:solidFill>
                   <a:srgbClr val="3D3833"/>
                 </a:solidFill>
@@ -4291,7 +4291,7 @@
           <a:p>
             <a:pPr algn="l"/>
             <a:r>
-              <a:rPr b="0" i="1" sz="1000">
+              <a:rPr b="0" i="1" sz="1400">
                 <a:solidFill>
                   <a:srgbClr val="B8523A"/>
                 </a:solidFill>
@@ -4326,7 +4326,7 @@
           <a:p>
             <a:pPr algn="l"/>
             <a:r>
-              <a:rPr b="0" i="0" sz="1100">
+              <a:rPr b="0" i="0" sz="1600">
                 <a:solidFill>
                   <a:srgbClr val="3D3833"/>
                 </a:solidFill>
@@ -4361,7 +4361,7 @@
           <a:p>
             <a:pPr algn="l"/>
             <a:r>
-              <a:rPr b="0" i="1" sz="1100">
+              <a:rPr b="0" i="1" sz="1600">
                 <a:solidFill>
                   <a:srgbClr val="8A8175"/>
                 </a:solidFill>
@@ -4465,7 +4465,7 @@
           <a:p>
             <a:pPr algn="l"/>
             <a:r>
-              <a:rPr b="1" i="0" sz="1000">
+              <a:rPr b="1" i="0" sz="1400">
                 <a:solidFill>
                   <a:srgbClr val="F3EDE1"/>
                 </a:solidFill>
@@ -4500,7 +4500,7 @@
           <a:p>
             <a:pPr algn="l"/>
             <a:r>
-              <a:rPr b="1" i="0" sz="4400">
+              <a:rPr b="1" i="0" sz="5000">
                 <a:solidFill>
                   <a:srgbClr val="3D3833"/>
                 </a:solidFill>
@@ -4535,7 +4535,7 @@
           <a:p>
             <a:pPr algn="l"/>
             <a:r>
-              <a:rPr b="0" i="0" sz="1400">
+              <a:rPr b="0" i="0" sz="2000">
                 <a:solidFill>
                   <a:srgbClr val="8A8175"/>
                 </a:solidFill>
@@ -4691,7 +4691,7 @@
           <a:p>
             <a:pPr algn="l"/>
             <a:r>
-              <a:rPr b="1" i="0" sz="1000">
+              <a:rPr b="1" i="0" sz="1400">
                 <a:solidFill>
                   <a:srgbClr val="B8523A"/>
                 </a:solidFill>
@@ -4726,7 +4726,7 @@
           <a:p>
             <a:pPr algn="l"/>
             <a:r>
-              <a:rPr b="1" i="0" sz="1600">
+              <a:rPr b="1" i="0" sz="2200">
                 <a:solidFill>
                   <a:srgbClr val="3D3833"/>
                 </a:solidFill>
@@ -4762,7 +4762,7 @@
           <a:p>
             <a:pPr algn="l"/>
             <a:r>
-              <a:rPr b="0" i="1" sz="1200">
+              <a:rPr b="0" i="1" sz="1700">
                 <a:solidFill>
                   <a:srgbClr val="B8523A"/>
                 </a:solidFill>
@@ -4797,7 +4797,7 @@
           <a:p>
             <a:pPr algn="l"/>
             <a:r>
-              <a:rPr b="0" i="0" sz="1100">
+              <a:rPr b="0" i="0" sz="1600">
                 <a:solidFill>
                   <a:srgbClr val="8A8175"/>
                 </a:solidFill>
@@ -4832,7 +4832,7 @@
           <a:p>
             <a:pPr algn="l"/>
             <a:r>
-              <a:rPr b="0" i="1" sz="1100">
+              <a:rPr b="0" i="1" sz="1600">
                 <a:solidFill>
                   <a:srgbClr val="8A8175"/>
                 </a:solidFill>
@@ -4953,7 +4953,7 @@
           <a:p>
             <a:pPr algn="l"/>
             <a:r>
-              <a:rPr b="1" i="0" sz="1000">
+              <a:rPr b="1" i="0" sz="1400">
                 <a:solidFill>
                   <a:srgbClr val="B8523A"/>
                 </a:solidFill>
@@ -4988,7 +4988,7 @@
           <a:p>
             <a:pPr algn="l"/>
             <a:r>
-              <a:rPr b="1" i="0" sz="1600">
+              <a:rPr b="1" i="0" sz="2200">
                 <a:solidFill>
                   <a:srgbClr val="3D3833"/>
                 </a:solidFill>
@@ -5024,7 +5024,7 @@
           <a:p>
             <a:pPr algn="l"/>
             <a:r>
-              <a:rPr b="0" i="1" sz="1200">
+              <a:rPr b="0" i="1" sz="1700">
                 <a:solidFill>
                   <a:srgbClr val="B8523A"/>
                 </a:solidFill>
@@ -5059,7 +5059,7 @@
           <a:p>
             <a:pPr algn="l"/>
             <a:r>
-              <a:rPr b="0" i="0" sz="1100">
+              <a:rPr b="0" i="0" sz="1600">
                 <a:solidFill>
                   <a:srgbClr val="8A8175"/>
                 </a:solidFill>
@@ -5094,7 +5094,7 @@
           <a:p>
             <a:pPr algn="l"/>
             <a:r>
-              <a:rPr b="0" i="1" sz="1100">
+              <a:rPr b="0" i="1" sz="1600">
                 <a:solidFill>
                   <a:srgbClr val="8A8175"/>
                 </a:solidFill>
@@ -5215,7 +5215,7 @@
           <a:p>
             <a:pPr algn="l"/>
             <a:r>
-              <a:rPr b="1" i="0" sz="1000">
+              <a:rPr b="1" i="0" sz="1400">
                 <a:solidFill>
                   <a:srgbClr val="B8523A"/>
                 </a:solidFill>
@@ -5250,7 +5250,7 @@
           <a:p>
             <a:pPr algn="l"/>
             <a:r>
-              <a:rPr b="1" i="0" sz="1600">
+              <a:rPr b="1" i="0" sz="2200">
                 <a:solidFill>
                   <a:srgbClr val="F3EDE1"/>
                 </a:solidFill>
@@ -5286,7 +5286,7 @@
           <a:p>
             <a:pPr algn="l"/>
             <a:r>
-              <a:rPr b="0" i="1" sz="1200">
+              <a:rPr b="0" i="1" sz="1700">
                 <a:solidFill>
                   <a:srgbClr val="B8523A"/>
                 </a:solidFill>
@@ -5321,7 +5321,7 @@
           <a:p>
             <a:pPr algn="l"/>
             <a:r>
-              <a:rPr b="0" i="0" sz="1100">
+              <a:rPr b="0" i="0" sz="1600">
                 <a:solidFill>
                   <a:srgbClr val="8A8175"/>
                 </a:solidFill>
@@ -5356,7 +5356,7 @@
           <a:p>
             <a:pPr algn="l"/>
             <a:r>
-              <a:rPr b="0" i="1" sz="1100">
+              <a:rPr b="0" i="1" sz="1600">
                 <a:solidFill>
                   <a:srgbClr val="F3EDE1"/>
                 </a:solidFill>
@@ -5434,7 +5434,7 @@
           <a:p>
             <a:pPr algn="ctr"/>
             <a:r>
-              <a:rPr b="0" i="1" sz="1300">
+              <a:rPr b="0" i="1" sz="1900">
                 <a:solidFill>
                   <a:srgbClr val="F3EDE1"/>
                 </a:solidFill>
@@ -5624,7 +5624,7 @@
           <a:p>
             <a:pPr algn="ctr"/>
             <a:r>
-              <a:rPr b="0" i="0" sz="1500">
+              <a:rPr b="0" i="0" sz="2000">
                 <a:solidFill>
                   <a:srgbClr val="8A8175"/>
                 </a:solidFill>
@@ -5659,7 +5659,7 @@
           <a:p>
             <a:pPr algn="l"/>
             <a:r>
-              <a:rPr b="1" i="1" sz="3200">
+              <a:rPr b="1" i="1" sz="3600">
                 <a:solidFill>
                   <a:srgbClr val="F3EDE1"/>
                 </a:solidFill>
@@ -5694,7 +5694,7 @@
           <a:p>
             <a:pPr algn="l"/>
             <a:r>
-              <a:rPr b="1" i="1" sz="3200">
+              <a:rPr b="1" i="1" sz="3600">
                 <a:solidFill>
                   <a:srgbClr val="F3EDE1"/>
                 </a:solidFill>
@@ -5729,7 +5729,7 @@
           <a:p>
             <a:pPr algn="l"/>
             <a:r>
-              <a:rPr b="1" i="1" sz="3200">
+              <a:rPr b="1" i="1" sz="3600">
                 <a:solidFill>
                   <a:srgbClr val="F3EDE1"/>
                 </a:solidFill>
@@ -5764,7 +5764,7 @@
           <a:p>
             <a:pPr algn="l"/>
             <a:r>
-              <a:rPr b="1" i="1" sz="3200">
+              <a:rPr b="1" i="1" sz="3600">
                 <a:solidFill>
                   <a:srgbClr val="B8523A"/>
                 </a:solidFill>
@@ -5799,7 +5799,7 @@
           <a:p>
             <a:pPr algn="l"/>
             <a:r>
-              <a:rPr b="1" i="1" sz="3200">
+              <a:rPr b="1" i="1" sz="3600">
                 <a:solidFill>
                   <a:srgbClr val="B8523A"/>
                 </a:solidFill>
@@ -5834,7 +5834,7 @@
           <a:p>
             <a:pPr algn="l"/>
             <a:r>
-              <a:rPr b="0" i="0" sz="1500">
+              <a:rPr b="0" i="0" sz="2000">
                 <a:solidFill>
                   <a:srgbClr val="8A8175"/>
                 </a:solidFill>
@@ -5904,7 +5904,7 @@
           <a:p>
             <a:pPr algn="l"/>
             <a:r>
-              <a:rPr b="0" i="0" sz="1500">
+              <a:rPr b="0" i="0" sz="2000">
                 <a:solidFill>
                   <a:srgbClr val="8A8175"/>
                 </a:solidFill>
@@ -6008,7 +6008,7 @@
           <a:p>
             <a:pPr algn="l"/>
             <a:r>
-              <a:rPr b="1" i="0" sz="1000">
+              <a:rPr b="1" i="0" sz="1400">
                 <a:solidFill>
                   <a:srgbClr val="F3EDE1"/>
                 </a:solidFill>
@@ -6043,7 +6043,7 @@
           <a:p>
             <a:pPr algn="l"/>
             <a:r>
-              <a:rPr b="1" i="0" sz="4400">
+              <a:rPr b="1" i="0" sz="5000">
                 <a:solidFill>
                   <a:srgbClr val="3D3833"/>
                 </a:solidFill>
@@ -6078,7 +6078,7 @@
           <a:p>
             <a:pPr algn="l"/>
             <a:r>
-              <a:rPr b="1" i="0" sz="4400">
+              <a:rPr b="1" i="0" sz="5000">
                 <a:solidFill>
                   <a:srgbClr val="B8523A"/>
                 </a:solidFill>
@@ -6113,7 +6113,7 @@
           <a:p>
             <a:pPr algn="l"/>
             <a:r>
-              <a:rPr b="0" i="0" sz="1300">
+              <a:rPr b="0" i="0" sz="1900">
                 <a:solidFill>
                   <a:srgbClr val="8A8175"/>
                 </a:solidFill>
@@ -6226,7 +6226,7 @@
           <a:p>
             <a:pPr algn="l"/>
             <a:r>
-              <a:rPr b="1" i="0" sz="1000">
+              <a:rPr b="1" i="0" sz="1400">
                 <a:solidFill>
                   <a:srgbClr val="F3EDE1"/>
                 </a:solidFill>
@@ -6479,7 +6479,7 @@
           <a:p>
             <a:pPr algn="l"/>
             <a:r>
-              <a:rPr b="1" i="0" sz="1000">
+              <a:rPr b="1" i="0" sz="1400">
                 <a:solidFill>
                   <a:srgbClr val="F3EDE1"/>
                 </a:solidFill>
@@ -6758,7 +6758,7 @@
           <a:p>
             <a:pPr algn="l"/>
             <a:r>
-              <a:rPr b="1" i="0" sz="1000">
+              <a:rPr b="1" i="0" sz="1400">
                 <a:solidFill>
                   <a:srgbClr val="F3EDE1"/>
                 </a:solidFill>
@@ -6793,7 +6793,7 @@
           <a:p>
             <a:pPr algn="l"/>
             <a:r>
-              <a:rPr b="1" i="0" sz="4400">
+              <a:rPr b="1" i="0" sz="5000">
                 <a:solidFill>
                   <a:srgbClr val="3D3833"/>
                 </a:solidFill>
@@ -6828,7 +6828,7 @@
           <a:p>
             <a:pPr algn="l"/>
             <a:r>
-              <a:rPr b="0" i="0" sz="1400">
+              <a:rPr b="0" i="0" sz="2000">
                 <a:solidFill>
                   <a:srgbClr val="8A8175"/>
                 </a:solidFill>
@@ -6984,7 +6984,7 @@
           <a:p>
             <a:pPr algn="l"/>
             <a:r>
-              <a:rPr b="1" i="0" sz="5600">
+              <a:rPr b="1" i="0" sz="6200">
                 <a:solidFill>
                   <a:srgbClr val="E0D8C4"/>
                 </a:solidFill>
@@ -7019,7 +7019,7 @@
           <a:p>
             <a:pPr algn="l"/>
             <a:r>
-              <a:rPr b="1" i="0" sz="1300">
+              <a:rPr b="1" i="0" sz="1900">
                 <a:solidFill>
                   <a:srgbClr val="3D3833"/>
                 </a:solidFill>
@@ -7055,7 +7055,7 @@
           <a:p>
             <a:pPr algn="l"/>
             <a:r>
-              <a:rPr b="0" i="0" sz="1100">
+              <a:rPr b="0" i="0" sz="1600">
                 <a:solidFill>
                   <a:srgbClr val="8A8175"/>
                 </a:solidFill>
@@ -7090,7 +7090,7 @@
           <a:p>
             <a:pPr algn="l"/>
             <a:r>
-              <a:rPr b="0" i="0" sz="900">
+              <a:rPr b="0" i="0" sz="1300">
                 <a:solidFill>
                   <a:srgbClr val="B8523A"/>
                 </a:solidFill>
@@ -7211,7 +7211,7 @@
           <a:p>
             <a:pPr algn="l"/>
             <a:r>
-              <a:rPr b="1" i="0" sz="5600">
+              <a:rPr b="1" i="0" sz="6200">
                 <a:solidFill>
                   <a:srgbClr val="E0D8C4"/>
                 </a:solidFill>
@@ -7246,7 +7246,7 @@
           <a:p>
             <a:pPr algn="l"/>
             <a:r>
-              <a:rPr b="1" i="0" sz="1300">
+              <a:rPr b="1" i="0" sz="1900">
                 <a:solidFill>
                   <a:srgbClr val="3D3833"/>
                 </a:solidFill>
@@ -7282,7 +7282,7 @@
           <a:p>
             <a:pPr algn="l"/>
             <a:r>
-              <a:rPr b="0" i="0" sz="1100">
+              <a:rPr b="0" i="0" sz="1600">
                 <a:solidFill>
                   <a:srgbClr val="8A8175"/>
                 </a:solidFill>
@@ -7317,7 +7317,7 @@
           <a:p>
             <a:pPr algn="l"/>
             <a:r>
-              <a:rPr b="0" i="0" sz="900">
+              <a:rPr b="0" i="0" sz="1300">
                 <a:solidFill>
                   <a:srgbClr val="B8523A"/>
                 </a:solidFill>
@@ -7438,7 +7438,7 @@
           <a:p>
             <a:pPr algn="l"/>
             <a:r>
-              <a:rPr b="1" i="0" sz="5600">
+              <a:rPr b="1" i="0" sz="6200">
                 <a:solidFill>
                   <a:srgbClr val="E0D8C4"/>
                 </a:solidFill>
@@ -7473,7 +7473,7 @@
           <a:p>
             <a:pPr algn="l"/>
             <a:r>
-              <a:rPr b="1" i="0" sz="1300">
+              <a:rPr b="1" i="0" sz="1900">
                 <a:solidFill>
                   <a:srgbClr val="3D3833"/>
                 </a:solidFill>
@@ -7509,7 +7509,7 @@
           <a:p>
             <a:pPr algn="l"/>
             <a:r>
-              <a:rPr b="0" i="0" sz="1100">
+              <a:rPr b="0" i="0" sz="1600">
                 <a:solidFill>
                   <a:srgbClr val="8A8175"/>
                 </a:solidFill>
@@ -7544,7 +7544,7 @@
           <a:p>
             <a:pPr algn="l"/>
             <a:r>
-              <a:rPr b="0" i="0" sz="900">
+              <a:rPr b="0" i="0" sz="1300">
                 <a:solidFill>
                   <a:srgbClr val="B8523A"/>
                 </a:solidFill>
@@ -7665,7 +7665,7 @@
           <a:p>
             <a:pPr algn="l"/>
             <a:r>
-              <a:rPr b="1" i="0" sz="5600">
+              <a:rPr b="1" i="0" sz="6200">
                 <a:solidFill>
                   <a:srgbClr val="E0D8C4"/>
                 </a:solidFill>
@@ -7700,7 +7700,7 @@
           <a:p>
             <a:pPr algn="l"/>
             <a:r>
-              <a:rPr b="1" i="0" sz="1300">
+              <a:rPr b="1" i="0" sz="1900">
                 <a:solidFill>
                   <a:srgbClr val="3D3833"/>
                 </a:solidFill>
@@ -7736,7 +7736,7 @@
           <a:p>
             <a:pPr algn="l"/>
             <a:r>
-              <a:rPr b="0" i="0" sz="1100">
+              <a:rPr b="0" i="0" sz="1600">
                 <a:solidFill>
                   <a:srgbClr val="8A8175"/>
                 </a:solidFill>
@@ -7771,7 +7771,7 @@
           <a:p>
             <a:pPr algn="l"/>
             <a:r>
-              <a:rPr b="0" i="0" sz="900">
+              <a:rPr b="0" i="0" sz="1300">
                 <a:solidFill>
                   <a:srgbClr val="B8523A"/>
                 </a:solidFill>
@@ -7892,7 +7892,7 @@
           <a:p>
             <a:pPr algn="l"/>
             <a:r>
-              <a:rPr b="1" i="0" sz="5600">
+              <a:rPr b="1" i="0" sz="6200">
                 <a:solidFill>
                   <a:srgbClr val="E0D8C4"/>
                 </a:solidFill>
@@ -7927,7 +7927,7 @@
           <a:p>
             <a:pPr algn="l"/>
             <a:r>
-              <a:rPr b="1" i="0" sz="1300">
+              <a:rPr b="1" i="0" sz="1900">
                 <a:solidFill>
                   <a:srgbClr val="3D3833"/>
                 </a:solidFill>
@@ -7963,7 +7963,7 @@
           <a:p>
             <a:pPr algn="l"/>
             <a:r>
-              <a:rPr b="0" i="0" sz="1100">
+              <a:rPr b="0" i="0" sz="1600">
                 <a:solidFill>
                   <a:srgbClr val="8A8175"/>
                 </a:solidFill>
@@ -7998,7 +7998,7 @@
           <a:p>
             <a:pPr algn="l"/>
             <a:r>
-              <a:rPr b="0" i="0" sz="900">
+              <a:rPr b="0" i="0" sz="1300">
                 <a:solidFill>
                   <a:srgbClr val="B8523A"/>
                 </a:solidFill>
@@ -8102,7 +8102,7 @@
           <a:p>
             <a:pPr algn="l"/>
             <a:r>
-              <a:rPr b="1" i="0" sz="1000">
+              <a:rPr b="1" i="0" sz="1400">
                 <a:solidFill>
                   <a:srgbClr val="F3EDE1"/>
                 </a:solidFill>
@@ -8137,7 +8137,7 @@
           <a:p>
             <a:pPr algn="l"/>
             <a:r>
-              <a:rPr b="1" i="0" sz="3600">
+              <a:rPr b="1" i="0" sz="4200">
                 <a:solidFill>
                   <a:srgbClr val="3D3833"/>
                 </a:solidFill>
@@ -8258,7 +8258,7 @@
           <a:p>
             <a:pPr algn="l"/>
             <a:r>
-              <a:rPr b="0" i="1" sz="1200">
+              <a:rPr b="0" i="1" sz="1700">
                 <a:solidFill>
                   <a:srgbClr val="3D3833"/>
                 </a:solidFill>
@@ -8293,7 +8293,7 @@
           <a:p>
             <a:pPr algn="l"/>
             <a:r>
-              <a:rPr b="1" i="0" sz="1200">
+              <a:rPr b="1" i="0" sz="1700">
                 <a:solidFill>
                   <a:srgbClr val="B8523A"/>
                 </a:solidFill>
@@ -8414,7 +8414,7 @@
           <a:p>
             <a:pPr algn="l"/>
             <a:r>
-              <a:rPr b="1" i="0" sz="1000">
+              <a:rPr b="1" i="0" sz="1400">
                 <a:solidFill>
                   <a:srgbClr val="3D3833"/>
                 </a:solidFill>
@@ -8449,7 +8449,7 @@
           <a:p>
             <a:pPr algn="l"/>
             <a:r>
-              <a:rPr b="0" i="0" sz="900">
+              <a:rPr b="0" i="0" sz="1300">
                 <a:solidFill>
                   <a:srgbClr val="8A8175"/>
                 </a:solidFill>
@@ -8484,7 +8484,7 @@
           <a:p>
             <a:pPr algn="l"/>
             <a:r>
-              <a:rPr b="0" i="0" sz="800">
+              <a:rPr b="0" i="0" sz="1200">
                 <a:solidFill>
                   <a:srgbClr val="B8523A"/>
                 </a:solidFill>
@@ -8605,7 +8605,7 @@
           <a:p>
             <a:pPr algn="l"/>
             <a:r>
-              <a:rPr b="1" i="0" sz="1000">
+              <a:rPr b="1" i="0" sz="1400">
                 <a:solidFill>
                   <a:srgbClr val="3D3833"/>
                 </a:solidFill>
@@ -8640,7 +8640,7 @@
           <a:p>
             <a:pPr algn="l"/>
             <a:r>
-              <a:rPr b="0" i="0" sz="900">
+              <a:rPr b="0" i="0" sz="1300">
                 <a:solidFill>
                   <a:srgbClr val="8A8175"/>
                 </a:solidFill>
@@ -8675,7 +8675,7 @@
           <a:p>
             <a:pPr algn="l"/>
             <a:r>
-              <a:rPr b="0" i="0" sz="800">
+              <a:rPr b="0" i="0" sz="1200">
                 <a:solidFill>
                   <a:srgbClr val="B8523A"/>
                 </a:solidFill>
@@ -8796,7 +8796,7 @@
           <a:p>
             <a:pPr algn="l"/>
             <a:r>
-              <a:rPr b="1" i="0" sz="1000">
+              <a:rPr b="1" i="0" sz="1400">
                 <a:solidFill>
                   <a:srgbClr val="3D3833"/>
                 </a:solidFill>
@@ -8831,7 +8831,7 @@
           <a:p>
             <a:pPr algn="l"/>
             <a:r>
-              <a:rPr b="0" i="0" sz="900">
+              <a:rPr b="0" i="0" sz="1300">
                 <a:solidFill>
                   <a:srgbClr val="8A8175"/>
                 </a:solidFill>
@@ -8866,7 +8866,7 @@
           <a:p>
             <a:pPr algn="l"/>
             <a:r>
-              <a:rPr b="0" i="0" sz="800">
+              <a:rPr b="0" i="0" sz="1200">
                 <a:solidFill>
                   <a:srgbClr val="B8523A"/>
                 </a:solidFill>
@@ -8987,7 +8987,7 @@
           <a:p>
             <a:pPr algn="l"/>
             <a:r>
-              <a:rPr b="1" i="0" sz="1000">
+              <a:rPr b="1" i="0" sz="1400">
                 <a:solidFill>
                   <a:srgbClr val="3D3833"/>
                 </a:solidFill>
@@ -9022,7 +9022,7 @@
           <a:p>
             <a:pPr algn="l"/>
             <a:r>
-              <a:rPr b="0" i="0" sz="900">
+              <a:rPr b="0" i="0" sz="1300">
                 <a:solidFill>
                   <a:srgbClr val="8A8175"/>
                 </a:solidFill>
@@ -9057,7 +9057,7 @@
           <a:p>
             <a:pPr algn="l"/>
             <a:r>
-              <a:rPr b="0" i="0" sz="800">
+              <a:rPr b="0" i="0" sz="1200">
                 <a:solidFill>
                   <a:srgbClr val="B8523A"/>
                 </a:solidFill>
@@ -9178,7 +9178,7 @@
           <a:p>
             <a:pPr algn="l"/>
             <a:r>
-              <a:rPr b="1" i="0" sz="1000">
+              <a:rPr b="1" i="0" sz="1400">
                 <a:solidFill>
                   <a:srgbClr val="3D3833"/>
                 </a:solidFill>
@@ -9213,7 +9213,7 @@
           <a:p>
             <a:pPr algn="l"/>
             <a:r>
-              <a:rPr b="0" i="0" sz="900">
+              <a:rPr b="0" i="0" sz="1300">
                 <a:solidFill>
                   <a:srgbClr val="8A8175"/>
                 </a:solidFill>
@@ -9248,7 +9248,7 @@
           <a:p>
             <a:pPr algn="l"/>
             <a:r>
-              <a:rPr b="0" i="0" sz="800">
+              <a:rPr b="0" i="0" sz="1200">
                 <a:solidFill>
                   <a:srgbClr val="B8523A"/>
                 </a:solidFill>
@@ -9369,7 +9369,7 @@
           <a:p>
             <a:pPr algn="l"/>
             <a:r>
-              <a:rPr b="1" i="0" sz="1000">
+              <a:rPr b="1" i="0" sz="1400">
                 <a:solidFill>
                   <a:srgbClr val="3D3833"/>
                 </a:solidFill>
@@ -9404,7 +9404,7 @@
           <a:p>
             <a:pPr algn="l"/>
             <a:r>
-              <a:rPr b="0" i="0" sz="900">
+              <a:rPr b="0" i="0" sz="1300">
                 <a:solidFill>
                   <a:srgbClr val="8A8175"/>
                 </a:solidFill>
@@ -9439,7 +9439,7 @@
           <a:p>
             <a:pPr algn="l"/>
             <a:r>
-              <a:rPr b="0" i="0" sz="800">
+              <a:rPr b="0" i="0" sz="1200">
                 <a:solidFill>
                   <a:srgbClr val="B8523A"/>
                 </a:solidFill>
@@ -9560,7 +9560,7 @@
           <a:p>
             <a:pPr algn="l"/>
             <a:r>
-              <a:rPr b="1" i="0" sz="1000">
+              <a:rPr b="1" i="0" sz="1400">
                 <a:solidFill>
                   <a:srgbClr val="3D3833"/>
                 </a:solidFill>
@@ -9595,7 +9595,7 @@
           <a:p>
             <a:pPr algn="l"/>
             <a:r>
-              <a:rPr b="0" i="0" sz="900">
+              <a:rPr b="0" i="0" sz="1300">
                 <a:solidFill>
                   <a:srgbClr val="8A8175"/>
                 </a:solidFill>
@@ -9630,7 +9630,7 @@
           <a:p>
             <a:pPr algn="l"/>
             <a:r>
-              <a:rPr b="0" i="0" sz="800">
+              <a:rPr b="0" i="0" sz="1200">
                 <a:solidFill>
                   <a:srgbClr val="B8523A"/>
                 </a:solidFill>
@@ -9751,7 +9751,7 @@
           <a:p>
             <a:pPr algn="l"/>
             <a:r>
-              <a:rPr b="1" i="0" sz="1000">
+              <a:rPr b="1" i="0" sz="1400">
                 <a:solidFill>
                   <a:srgbClr val="3D3833"/>
                 </a:solidFill>
@@ -9786,7 +9786,7 @@
           <a:p>
             <a:pPr algn="l"/>
             <a:r>
-              <a:rPr b="0" i="0" sz="900">
+              <a:rPr b="0" i="0" sz="1300">
                 <a:solidFill>
                   <a:srgbClr val="8A8175"/>
                 </a:solidFill>
@@ -9821,7 +9821,7 @@
           <a:p>
             <a:pPr algn="l"/>
             <a:r>
-              <a:rPr b="0" i="0" sz="800">
+              <a:rPr b="0" i="0" sz="1200">
                 <a:solidFill>
                   <a:srgbClr val="B8523A"/>
                 </a:solidFill>
@@ -9942,7 +9942,7 @@
           <a:p>
             <a:pPr algn="l"/>
             <a:r>
-              <a:rPr b="1" i="0" sz="1000">
+              <a:rPr b="1" i="0" sz="1400">
                 <a:solidFill>
                   <a:srgbClr val="3D3833"/>
                 </a:solidFill>
@@ -9977,7 +9977,7 @@
           <a:p>
             <a:pPr algn="l"/>
             <a:r>
-              <a:rPr b="0" i="0" sz="900">
+              <a:rPr b="0" i="0" sz="1300">
                 <a:solidFill>
                   <a:srgbClr val="8A8175"/>
                 </a:solidFill>
@@ -10012,7 +10012,7 @@
           <a:p>
             <a:pPr algn="l"/>
             <a:r>
-              <a:rPr b="0" i="0" sz="800">
+              <a:rPr b="0" i="0" sz="1200">
                 <a:solidFill>
                   <a:srgbClr val="B8523A"/>
                 </a:solidFill>
@@ -10133,7 +10133,7 @@
           <a:p>
             <a:pPr algn="l"/>
             <a:r>
-              <a:rPr b="1" i="0" sz="1000">
+              <a:rPr b="1" i="0" sz="1400">
                 <a:solidFill>
                   <a:srgbClr val="3D3833"/>
                 </a:solidFill>
@@ -10168,7 +10168,7 @@
           <a:p>
             <a:pPr algn="l"/>
             <a:r>
-              <a:rPr b="0" i="0" sz="900">
+              <a:rPr b="0" i="0" sz="1300">
                 <a:solidFill>
                   <a:srgbClr val="8A8175"/>
                 </a:solidFill>
@@ -10203,7 +10203,7 @@
           <a:p>
             <a:pPr algn="l"/>
             <a:r>
-              <a:rPr b="0" i="0" sz="800">
+              <a:rPr b="0" i="0" sz="1200">
                 <a:solidFill>
                   <a:srgbClr val="B8523A"/>
                 </a:solidFill>
@@ -10324,7 +10324,7 @@
           <a:p>
             <a:pPr algn="l"/>
             <a:r>
-              <a:rPr b="1" i="0" sz="1000">
+              <a:rPr b="1" i="0" sz="1400">
                 <a:solidFill>
                   <a:srgbClr val="3D3833"/>
                 </a:solidFill>
@@ -10359,7 +10359,7 @@
           <a:p>
             <a:pPr algn="l"/>
             <a:r>
-              <a:rPr b="0" i="0" sz="900">
+              <a:rPr b="0" i="0" sz="1300">
                 <a:solidFill>
                   <a:srgbClr val="8A8175"/>
                 </a:solidFill>
@@ -10394,7 +10394,7 @@
           <a:p>
             <a:pPr algn="l"/>
             <a:r>
-              <a:rPr b="0" i="0" sz="800">
+              <a:rPr b="0" i="0" sz="1200">
                 <a:solidFill>
                   <a:srgbClr val="B8523A"/>
                 </a:solidFill>
@@ -10515,7 +10515,7 @@
           <a:p>
             <a:pPr algn="l"/>
             <a:r>
-              <a:rPr b="1" i="0" sz="1000">
+              <a:rPr b="1" i="0" sz="1400">
                 <a:solidFill>
                   <a:srgbClr val="3D3833"/>
                 </a:solidFill>
@@ -10550,7 +10550,7 @@
           <a:p>
             <a:pPr algn="l"/>
             <a:r>
-              <a:rPr b="0" i="0" sz="900">
+              <a:rPr b="0" i="0" sz="1300">
                 <a:solidFill>
                   <a:srgbClr val="8A8175"/>
                 </a:solidFill>
@@ -10585,7 +10585,7 @@
           <a:p>
             <a:pPr algn="l"/>
             <a:r>
-              <a:rPr b="0" i="0" sz="800">
+              <a:rPr b="0" i="0" sz="1200">
                 <a:solidFill>
                   <a:srgbClr val="B8523A"/>
                 </a:solidFill>
@@ -10706,7 +10706,7 @@
           <a:p>
             <a:pPr algn="l"/>
             <a:r>
-              <a:rPr b="1" i="0" sz="1000">
+              <a:rPr b="1" i="0" sz="1400">
                 <a:solidFill>
                   <a:srgbClr val="3D3833"/>
                 </a:solidFill>
@@ -10741,7 +10741,7 @@
           <a:p>
             <a:pPr algn="l"/>
             <a:r>
-              <a:rPr b="0" i="0" sz="900">
+              <a:rPr b="0" i="0" sz="1300">
                 <a:solidFill>
                   <a:srgbClr val="8A8175"/>
                 </a:solidFill>
@@ -10776,7 +10776,7 @@
           <a:p>
             <a:pPr algn="l"/>
             <a:r>
-              <a:rPr b="0" i="0" sz="800">
+              <a:rPr b="0" i="0" sz="1200">
                 <a:solidFill>
                   <a:srgbClr val="B8523A"/>
                 </a:solidFill>
@@ -10897,7 +10897,7 @@
           <a:p>
             <a:pPr algn="l"/>
             <a:r>
-              <a:rPr b="1" i="0" sz="1000">
+              <a:rPr b="1" i="0" sz="1400">
                 <a:solidFill>
                   <a:srgbClr val="3D3833"/>
                 </a:solidFill>
@@ -10932,7 +10932,7 @@
           <a:p>
             <a:pPr algn="l"/>
             <a:r>
-              <a:rPr b="0" i="0" sz="900">
+              <a:rPr b="0" i="0" sz="1300">
                 <a:solidFill>
                   <a:srgbClr val="8A8175"/>
                 </a:solidFill>
@@ -10967,7 +10967,7 @@
           <a:p>
             <a:pPr algn="l"/>
             <a:r>
-              <a:rPr b="0" i="0" sz="800">
+              <a:rPr b="0" i="0" sz="1200">
                 <a:solidFill>
                   <a:srgbClr val="B8523A"/>
                 </a:solidFill>
@@ -11088,7 +11088,7 @@
           <a:p>
             <a:pPr algn="l"/>
             <a:r>
-              <a:rPr b="1" i="0" sz="1000">
+              <a:rPr b="1" i="0" sz="1400">
                 <a:solidFill>
                   <a:srgbClr val="3D3833"/>
                 </a:solidFill>
@@ -11123,7 +11123,7 @@
           <a:p>
             <a:pPr algn="l"/>
             <a:r>
-              <a:rPr b="0" i="0" sz="900">
+              <a:rPr b="0" i="0" sz="1300">
                 <a:solidFill>
                   <a:srgbClr val="8A8175"/>
                 </a:solidFill>
@@ -11158,7 +11158,7 @@
           <a:p>
             <a:pPr algn="l"/>
             <a:r>
-              <a:rPr b="0" i="0" sz="800">
+              <a:rPr b="0" i="0" sz="1200">
                 <a:solidFill>
                   <a:srgbClr val="B8523A"/>
                 </a:solidFill>
@@ -11279,7 +11279,7 @@
           <a:p>
             <a:pPr algn="l"/>
             <a:r>
-              <a:rPr b="1" i="0" sz="1000">
+              <a:rPr b="1" i="0" sz="1400">
                 <a:solidFill>
                   <a:srgbClr val="3D3833"/>
                 </a:solidFill>
@@ -11314,7 +11314,7 @@
           <a:p>
             <a:pPr algn="l"/>
             <a:r>
-              <a:rPr b="0" i="0" sz="900">
+              <a:rPr b="0" i="0" sz="1300">
                 <a:solidFill>
                   <a:srgbClr val="8A8175"/>
                 </a:solidFill>
@@ -11349,7 +11349,7 @@
           <a:p>
             <a:pPr algn="l"/>
             <a:r>
-              <a:rPr b="0" i="0" sz="800">
+              <a:rPr b="0" i="0" sz="1200">
                 <a:solidFill>
                   <a:srgbClr val="B8523A"/>
                 </a:solidFill>
@@ -11427,7 +11427,7 @@
           <a:p>
             <a:pPr algn="ctr"/>
             <a:r>
-              <a:rPr b="0" i="1" sz="1200">
+              <a:rPr b="0" i="1" sz="1700">
                 <a:solidFill>
                   <a:srgbClr val="F3EDE1"/>
                 </a:solidFill>
@@ -11531,7 +11531,7 @@
           <a:p>
             <a:pPr algn="l"/>
             <a:r>
-              <a:rPr b="1" i="0" sz="1000">
+              <a:rPr b="1" i="0" sz="1400">
                 <a:solidFill>
                   <a:srgbClr val="F3EDE1"/>
                 </a:solidFill>
@@ -11566,7 +11566,7 @@
           <a:p>
             <a:pPr algn="l"/>
             <a:r>
-              <a:rPr b="1" i="0" sz="4400">
+              <a:rPr b="1" i="0" sz="5000">
                 <a:solidFill>
                   <a:srgbClr val="3D3833"/>
                 </a:solidFill>
@@ -11601,7 +11601,7 @@
           <a:p>
             <a:pPr algn="l"/>
             <a:r>
-              <a:rPr b="0" i="0" sz="1400">
+              <a:rPr b="0" i="0" sz="2000">
                 <a:solidFill>
                   <a:srgbClr val="8A8175"/>
                 </a:solidFill>
@@ -11757,7 +11757,7 @@
           <a:p>
             <a:pPr algn="l"/>
             <a:r>
-              <a:rPr b="1" i="0" sz="6000">
+              <a:rPr b="1" i="0" sz="6600">
                 <a:solidFill>
                   <a:srgbClr val="E0D8C4"/>
                 </a:solidFill>
@@ -11792,7 +11792,7 @@
           <a:p>
             <a:pPr algn="l"/>
             <a:r>
-              <a:rPr b="1" i="0" sz="1400">
+              <a:rPr b="1" i="0" sz="2000">
                 <a:solidFill>
                   <a:srgbClr val="3D3833"/>
                 </a:solidFill>
@@ -11828,7 +11828,7 @@
           <a:p>
             <a:pPr algn="l"/>
             <a:r>
-              <a:rPr b="0" i="1" sz="1200">
+              <a:rPr b="0" i="1" sz="1700">
                 <a:solidFill>
                   <a:srgbClr val="B8523A"/>
                 </a:solidFill>
@@ -11863,7 +11863,7 @@
           <a:p>
             <a:pPr algn="l"/>
             <a:r>
-              <a:rPr b="0" i="0" sz="1100">
+              <a:rPr b="0" i="0" sz="1600">
                 <a:solidFill>
                   <a:srgbClr val="8A8175"/>
                 </a:solidFill>
@@ -11898,7 +11898,7 @@
           <a:p>
             <a:pPr algn="l"/>
             <a:r>
-              <a:rPr b="0" i="1" sz="1100">
+              <a:rPr b="0" i="1" sz="1600">
                 <a:solidFill>
                   <a:srgbClr val="8A8175"/>
                 </a:solidFill>
@@ -11933,7 +11933,7 @@
           <a:p>
             <a:pPr algn="l"/>
             <a:r>
-              <a:rPr b="0" i="0" sz="1000">
+              <a:rPr b="0" i="0" sz="1400">
                 <a:solidFill>
                   <a:srgbClr val="B8523A"/>
                 </a:solidFill>
@@ -12054,7 +12054,7 @@
           <a:p>
             <a:pPr algn="l"/>
             <a:r>
-              <a:rPr b="1" i="0" sz="6000">
+              <a:rPr b="1" i="0" sz="6600">
                 <a:solidFill>
                   <a:srgbClr val="E0D8C4"/>
                 </a:solidFill>
@@ -12089,7 +12089,7 @@
           <a:p>
             <a:pPr algn="l"/>
             <a:r>
-              <a:rPr b="1" i="0" sz="1400">
+              <a:rPr b="1" i="0" sz="2000">
                 <a:solidFill>
                   <a:srgbClr val="3D3833"/>
                 </a:solidFill>
@@ -12125,7 +12125,7 @@
           <a:p>
             <a:pPr algn="l"/>
             <a:r>
-              <a:rPr b="0" i="1" sz="1200">
+              <a:rPr b="0" i="1" sz="1700">
                 <a:solidFill>
                   <a:srgbClr val="B8523A"/>
                 </a:solidFill>
@@ -12160,7 +12160,7 @@
           <a:p>
             <a:pPr algn="l"/>
             <a:r>
-              <a:rPr b="0" i="0" sz="1100">
+              <a:rPr b="0" i="0" sz="1600">
                 <a:solidFill>
                   <a:srgbClr val="8A8175"/>
                 </a:solidFill>
@@ -12195,7 +12195,7 @@
           <a:p>
             <a:pPr algn="l"/>
             <a:r>
-              <a:rPr b="0" i="1" sz="1100">
+              <a:rPr b="0" i="1" sz="1600">
                 <a:solidFill>
                   <a:srgbClr val="8A8175"/>
                 </a:solidFill>
@@ -12230,7 +12230,7 @@
           <a:p>
             <a:pPr algn="l"/>
             <a:r>
-              <a:rPr b="0" i="0" sz="1000">
+              <a:rPr b="0" i="0" sz="1400">
                 <a:solidFill>
                   <a:srgbClr val="B8523A"/>
                 </a:solidFill>
@@ -12351,7 +12351,7 @@
           <a:p>
             <a:pPr algn="l"/>
             <a:r>
-              <a:rPr b="1" i="0" sz="6000">
+              <a:rPr b="1" i="0" sz="6600">
                 <a:solidFill>
                   <a:srgbClr val="B8523A"/>
                 </a:solidFill>
@@ -12386,7 +12386,7 @@
           <a:p>
             <a:pPr algn="l"/>
             <a:r>
-              <a:rPr b="1" i="0" sz="1400">
+              <a:rPr b="1" i="0" sz="2000">
                 <a:solidFill>
                   <a:srgbClr val="F3EDE1"/>
                 </a:solidFill>
@@ -12422,7 +12422,7 @@
           <a:p>
             <a:pPr algn="l"/>
             <a:r>
-              <a:rPr b="0" i="1" sz="1200">
+              <a:rPr b="0" i="1" sz="1700">
                 <a:solidFill>
                   <a:srgbClr val="B8523A"/>
                 </a:solidFill>
@@ -12457,7 +12457,7 @@
           <a:p>
             <a:pPr algn="l"/>
             <a:r>
-              <a:rPr b="0" i="0" sz="1100">
+              <a:rPr b="0" i="0" sz="1600">
                 <a:solidFill>
                   <a:srgbClr val="8A8175"/>
                 </a:solidFill>
@@ -12492,7 +12492,7 @@
           <a:p>
             <a:pPr algn="l"/>
             <a:r>
-              <a:rPr b="0" i="1" sz="1100">
+              <a:rPr b="0" i="1" sz="1600">
                 <a:solidFill>
                   <a:srgbClr val="F3EDE1"/>
                 </a:solidFill>
@@ -12527,7 +12527,7 @@
           <a:p>
             <a:pPr algn="l"/>
             <a:r>
-              <a:rPr b="0" i="0" sz="1000">
+              <a:rPr b="0" i="0" sz="1400">
                 <a:solidFill>
                   <a:srgbClr val="B8523A"/>
                 </a:solidFill>
@@ -12631,7 +12631,7 @@
           <a:p>
             <a:pPr algn="l"/>
             <a:r>
-              <a:rPr b="1" i="0" sz="1000">
+              <a:rPr b="1" i="0" sz="1400">
                 <a:solidFill>
                   <a:srgbClr val="F3EDE1"/>
                 </a:solidFill>
@@ -12666,7 +12666,7 @@
           <a:p>
             <a:pPr algn="l"/>
             <a:r>
-              <a:rPr b="1" i="0" sz="4400">
+              <a:rPr b="1" i="0" sz="5000">
                 <a:solidFill>
                   <a:srgbClr val="3D3833"/>
                 </a:solidFill>
@@ -12701,7 +12701,7 @@
           <a:p>
             <a:pPr algn="l"/>
             <a:r>
-              <a:rPr b="0" i="0" sz="1400">
+              <a:rPr b="0" i="0" sz="2000">
                 <a:solidFill>
                   <a:srgbClr val="8A8175"/>
                 </a:solidFill>
@@ -12857,7 +12857,7 @@
           <a:p>
             <a:pPr algn="l"/>
             <a:r>
-              <a:rPr b="1" i="0" sz="1400">
+              <a:rPr b="1" i="0" sz="2000">
                 <a:solidFill>
                   <a:srgbClr val="B8523A"/>
                 </a:solidFill>
@@ -12892,7 +12892,7 @@
           <a:p>
             <a:pPr algn="l"/>
             <a:r>
-              <a:rPr b="0" i="1" sz="1100">
+              <a:rPr b="0" i="1" sz="1600">
                 <a:solidFill>
                   <a:srgbClr val="3D3833"/>
                 </a:solidFill>
@@ -12927,7 +12927,7 @@
           <a:p>
             <a:pPr algn="l"/>
             <a:r>
-              <a:rPr b="0" i="0" sz="1100">
+              <a:rPr b="0" i="0" sz="1600">
                 <a:solidFill>
                   <a:srgbClr val="8A8175"/>
                 </a:solidFill>
@@ -13048,7 +13048,7 @@
           <a:p>
             <a:pPr algn="l"/>
             <a:r>
-              <a:rPr b="1" i="0" sz="1400">
+              <a:rPr b="1" i="0" sz="2000">
                 <a:solidFill>
                   <a:srgbClr val="B8523A"/>
                 </a:solidFill>
@@ -13083,7 +13083,7 @@
           <a:p>
             <a:pPr algn="l"/>
             <a:r>
-              <a:rPr b="0" i="1" sz="1100">
+              <a:rPr b="0" i="1" sz="1600">
                 <a:solidFill>
                   <a:srgbClr val="3D3833"/>
                 </a:solidFill>
@@ -13118,7 +13118,7 @@
           <a:p>
             <a:pPr algn="l"/>
             <a:r>
-              <a:rPr b="0" i="0" sz="1100">
+              <a:rPr b="0" i="0" sz="1600">
                 <a:solidFill>
                   <a:srgbClr val="8A8175"/>
                 </a:solidFill>
@@ -13239,7 +13239,7 @@
           <a:p>
             <a:pPr algn="l"/>
             <a:r>
-              <a:rPr b="1" i="0" sz="1400">
+              <a:rPr b="1" i="0" sz="2000">
                 <a:solidFill>
                   <a:srgbClr val="B8523A"/>
                 </a:solidFill>
@@ -13274,7 +13274,7 @@
           <a:p>
             <a:pPr algn="l"/>
             <a:r>
-              <a:rPr b="0" i="1" sz="1100">
+              <a:rPr b="0" i="1" sz="1600">
                 <a:solidFill>
                   <a:srgbClr val="3D3833"/>
                 </a:solidFill>
@@ -13309,7 +13309,7 @@
           <a:p>
             <a:pPr algn="l"/>
             <a:r>
-              <a:rPr b="0" i="0" sz="1100">
+              <a:rPr b="0" i="0" sz="1600">
                 <a:solidFill>
                   <a:srgbClr val="8A8175"/>
                 </a:solidFill>
@@ -13430,7 +13430,7 @@
           <a:p>
             <a:pPr algn="l"/>
             <a:r>
-              <a:rPr b="1" i="0" sz="1400">
+              <a:rPr b="1" i="0" sz="2000">
                 <a:solidFill>
                   <a:srgbClr val="B8523A"/>
                 </a:solidFill>
@@ -13465,7 +13465,7 @@
           <a:p>
             <a:pPr algn="l"/>
             <a:r>
-              <a:rPr b="0" i="1" sz="1100">
+              <a:rPr b="0" i="1" sz="1600">
                 <a:solidFill>
                   <a:srgbClr val="3D3833"/>
                 </a:solidFill>
@@ -13500,7 +13500,7 @@
           <a:p>
             <a:pPr algn="l"/>
             <a:r>
-              <a:rPr b="0" i="0" sz="1100">
+              <a:rPr b="0" i="0" sz="1600">
                 <a:solidFill>
                   <a:srgbClr val="8A8175"/>
                 </a:solidFill>
@@ -13621,7 +13621,7 @@
           <a:p>
             <a:pPr algn="l"/>
             <a:r>
-              <a:rPr b="1" i="0" sz="1400">
+              <a:rPr b="1" i="0" sz="2000">
                 <a:solidFill>
                   <a:srgbClr val="B8523A"/>
                 </a:solidFill>
@@ -13656,7 +13656,7 @@
           <a:p>
             <a:pPr algn="l"/>
             <a:r>
-              <a:rPr b="0" i="1" sz="1100">
+              <a:rPr b="0" i="1" sz="1600">
                 <a:solidFill>
                   <a:srgbClr val="3D3833"/>
                 </a:solidFill>
@@ -13691,7 +13691,7 @@
           <a:p>
             <a:pPr algn="l"/>
             <a:r>
-              <a:rPr b="0" i="0" sz="1100">
+              <a:rPr b="0" i="0" sz="1600">
                 <a:solidFill>
                   <a:srgbClr val="8A8175"/>
                 </a:solidFill>
@@ -13812,7 +13812,7 @@
           <a:p>
             <a:pPr algn="l"/>
             <a:r>
-              <a:rPr b="1" i="0" sz="1400">
+              <a:rPr b="1" i="0" sz="2000">
                 <a:solidFill>
                   <a:srgbClr val="B8523A"/>
                 </a:solidFill>
@@ -13847,7 +13847,7 @@
           <a:p>
             <a:pPr algn="l"/>
             <a:r>
-              <a:rPr b="0" i="1" sz="1100">
+              <a:rPr b="0" i="1" sz="1600">
                 <a:solidFill>
                   <a:srgbClr val="3D3833"/>
                 </a:solidFill>
@@ -13882,7 +13882,7 @@
           <a:p>
             <a:pPr algn="l"/>
             <a:r>
-              <a:rPr b="0" i="0" sz="1100">
+              <a:rPr b="0" i="0" sz="1600">
                 <a:solidFill>
                   <a:srgbClr val="8A8175"/>
                 </a:solidFill>
@@ -13960,7 +13960,7 @@
           <a:p>
             <a:pPr algn="ctr"/>
             <a:r>
-              <a:rPr b="0" i="1" sz="1600">
+              <a:rPr b="0" i="1" sz="2200">
                 <a:solidFill>
                   <a:srgbClr val="F3EDE1"/>
                 </a:solidFill>
@@ -14064,7 +14064,7 @@
           <a:p>
             <a:pPr algn="l"/>
             <a:r>
-              <a:rPr b="1" i="0" sz="1000">
+              <a:rPr b="1" i="0" sz="1400">
                 <a:solidFill>
                   <a:srgbClr val="F3EDE1"/>
                 </a:solidFill>
@@ -14099,7 +14099,7 @@
           <a:p>
             <a:pPr algn="l"/>
             <a:r>
-              <a:rPr b="1" i="0" sz="4400">
+              <a:rPr b="1" i="0" sz="5000">
                 <a:solidFill>
                   <a:srgbClr val="3D3833"/>
                 </a:solidFill>
@@ -14134,7 +14134,7 @@
           <a:p>
             <a:pPr algn="l"/>
             <a:r>
-              <a:rPr b="0" i="0" sz="1400">
+              <a:rPr b="0" i="0" sz="2000">
                 <a:solidFill>
                   <a:srgbClr val="8A8175"/>
                 </a:solidFill>
@@ -14290,7 +14290,7 @@
           <a:p>
             <a:pPr algn="l"/>
             <a:r>
-              <a:rPr b="1" i="0" sz="1400">
+              <a:rPr b="1" i="0" sz="2000">
                 <a:solidFill>
                   <a:srgbClr val="3D3833"/>
                 </a:solidFill>
@@ -14326,7 +14326,7 @@
           <a:p>
             <a:pPr algn="l"/>
             <a:r>
-              <a:rPr b="0" i="1" sz="1100">
+              <a:rPr b="0" i="1" sz="1600">
                 <a:solidFill>
                   <a:srgbClr val="B8523A"/>
                 </a:solidFill>
@@ -14361,7 +14361,7 @@
           <a:p>
             <a:pPr algn="l"/>
             <a:r>
-              <a:rPr b="0" i="0" sz="1000">
+              <a:rPr b="0" i="0" sz="1400">
                 <a:solidFill>
                   <a:srgbClr val="8A8175"/>
                 </a:solidFill>
@@ -14396,7 +14396,7 @@
           <a:p>
             <a:pPr algn="l"/>
             <a:r>
-              <a:rPr b="0" i="0" sz="1000">
+              <a:rPr b="0" i="0" sz="1400">
                 <a:solidFill>
                   <a:srgbClr val="8A8175"/>
                 </a:solidFill>
@@ -14431,7 +14431,7 @@
           <a:p>
             <a:pPr algn="l"/>
             <a:r>
-              <a:rPr b="0" i="0" sz="1000">
+              <a:rPr b="0" i="0" sz="1400">
                 <a:solidFill>
                   <a:srgbClr val="8A8175"/>
                 </a:solidFill>
@@ -14466,7 +14466,7 @@
           <a:p>
             <a:pPr algn="l"/>
             <a:r>
-              <a:rPr b="0" i="0" sz="1000">
+              <a:rPr b="0" i="0" sz="1400">
                 <a:solidFill>
                   <a:srgbClr val="8A8175"/>
                 </a:solidFill>
@@ -14587,7 +14587,7 @@
           <a:p>
             <a:pPr algn="l"/>
             <a:r>
-              <a:rPr b="1" i="0" sz="1400">
+              <a:rPr b="1" i="0" sz="2000">
                 <a:solidFill>
                   <a:srgbClr val="3D3833"/>
                 </a:solidFill>
@@ -14623,7 +14623,7 @@
           <a:p>
             <a:pPr algn="l"/>
             <a:r>
-              <a:rPr b="0" i="1" sz="1100">
+              <a:rPr b="0" i="1" sz="1600">
                 <a:solidFill>
                   <a:srgbClr val="B8523A"/>
                 </a:solidFill>
@@ -14658,7 +14658,7 @@
           <a:p>
             <a:pPr algn="l"/>
             <a:r>
-              <a:rPr b="0" i="0" sz="1000">
+              <a:rPr b="0" i="0" sz="1400">
                 <a:solidFill>
                   <a:srgbClr val="8A8175"/>
                 </a:solidFill>
@@ -14693,7 +14693,7 @@
           <a:p>
             <a:pPr algn="l"/>
             <a:r>
-              <a:rPr b="0" i="0" sz="1000">
+              <a:rPr b="0" i="0" sz="1400">
                 <a:solidFill>
                   <a:srgbClr val="8A8175"/>
                 </a:solidFill>
@@ -14728,7 +14728,7 @@
           <a:p>
             <a:pPr algn="l"/>
             <a:r>
-              <a:rPr b="0" i="0" sz="1000">
+              <a:rPr b="0" i="0" sz="1400">
                 <a:solidFill>
                   <a:srgbClr val="8A8175"/>
                 </a:solidFill>
@@ -14763,7 +14763,7 @@
           <a:p>
             <a:pPr algn="l"/>
             <a:r>
-              <a:rPr b="0" i="0" sz="1000">
+              <a:rPr b="0" i="0" sz="1400">
                 <a:solidFill>
                   <a:srgbClr val="8A8175"/>
                 </a:solidFill>
@@ -14884,7 +14884,7 @@
           <a:p>
             <a:pPr algn="l"/>
             <a:r>
-              <a:rPr b="1" i="0" sz="1400">
+              <a:rPr b="1" i="0" sz="2000">
                 <a:solidFill>
                   <a:srgbClr val="3D3833"/>
                 </a:solidFill>
@@ -14920,7 +14920,7 @@
           <a:p>
             <a:pPr algn="l"/>
             <a:r>
-              <a:rPr b="0" i="1" sz="1100">
+              <a:rPr b="0" i="1" sz="1600">
                 <a:solidFill>
                   <a:srgbClr val="B8523A"/>
                 </a:solidFill>
@@ -14955,7 +14955,7 @@
           <a:p>
             <a:pPr algn="l"/>
             <a:r>
-              <a:rPr b="0" i="0" sz="1000">
+              <a:rPr b="0" i="0" sz="1400">
                 <a:solidFill>
                   <a:srgbClr val="8A8175"/>
                 </a:solidFill>
@@ -14990,7 +14990,7 @@
           <a:p>
             <a:pPr algn="l"/>
             <a:r>
-              <a:rPr b="0" i="0" sz="1000">
+              <a:rPr b="0" i="0" sz="1400">
                 <a:solidFill>
                   <a:srgbClr val="8A8175"/>
                 </a:solidFill>
@@ -15025,7 +15025,7 @@
           <a:p>
             <a:pPr algn="l"/>
             <a:r>
-              <a:rPr b="0" i="0" sz="1000">
+              <a:rPr b="0" i="0" sz="1400">
                 <a:solidFill>
                   <a:srgbClr val="8A8175"/>
                 </a:solidFill>
@@ -15060,7 +15060,7 @@
           <a:p>
             <a:pPr algn="l"/>
             <a:r>
-              <a:rPr b="0" i="0" sz="1000">
+              <a:rPr b="0" i="0" sz="1400">
                 <a:solidFill>
                   <a:srgbClr val="8A8175"/>
                 </a:solidFill>
@@ -15181,7 +15181,7 @@
           <a:p>
             <a:pPr algn="l"/>
             <a:r>
-              <a:rPr b="1" i="0" sz="1400">
+              <a:rPr b="1" i="0" sz="2000">
                 <a:solidFill>
                   <a:srgbClr val="3D3833"/>
                 </a:solidFill>
@@ -15217,7 +15217,7 @@
           <a:p>
             <a:pPr algn="l"/>
             <a:r>
-              <a:rPr b="0" i="1" sz="1100">
+              <a:rPr b="0" i="1" sz="1600">
                 <a:solidFill>
                   <a:srgbClr val="B8523A"/>
                 </a:solidFill>
@@ -15252,7 +15252,7 @@
           <a:p>
             <a:pPr algn="l"/>
             <a:r>
-              <a:rPr b="0" i="0" sz="1000">
+              <a:rPr b="0" i="0" sz="1400">
                 <a:solidFill>
                   <a:srgbClr val="8A8175"/>
                 </a:solidFill>
@@ -15287,7 +15287,7 @@
           <a:p>
             <a:pPr algn="l"/>
             <a:r>
-              <a:rPr b="0" i="0" sz="1000">
+              <a:rPr b="0" i="0" sz="1400">
                 <a:solidFill>
                   <a:srgbClr val="8A8175"/>
                 </a:solidFill>
@@ -15322,7 +15322,7 @@
           <a:p>
             <a:pPr algn="l"/>
             <a:r>
-              <a:rPr b="0" i="0" sz="1000">
+              <a:rPr b="0" i="0" sz="1400">
                 <a:solidFill>
                   <a:srgbClr val="8A8175"/>
                 </a:solidFill>
@@ -15357,7 +15357,7 @@
           <a:p>
             <a:pPr algn="l"/>
             <a:r>
-              <a:rPr b="0" i="0" sz="1000">
+              <a:rPr b="0" i="0" sz="1400">
                 <a:solidFill>
                   <a:srgbClr val="8A8175"/>
                 </a:solidFill>
@@ -15461,7 +15461,7 @@
           <a:p>
             <a:pPr algn="l"/>
             <a:r>
-              <a:rPr b="1" i="0" sz="1000">
+              <a:rPr b="1" i="0" sz="1400">
                 <a:solidFill>
                   <a:srgbClr val="F3EDE1"/>
                 </a:solidFill>
@@ -15496,7 +15496,7 @@
           <a:p>
             <a:pPr algn="l"/>
             <a:r>
-              <a:rPr b="1" i="0" sz="4400">
+              <a:rPr b="1" i="0" sz="5000">
                 <a:solidFill>
                   <a:srgbClr val="3D3833"/>
                 </a:solidFill>
@@ -15531,7 +15531,7 @@
           <a:p>
             <a:pPr algn="l"/>
             <a:r>
-              <a:rPr b="0" i="0" sz="1400">
+              <a:rPr b="0" i="0" sz="2000">
                 <a:solidFill>
                   <a:srgbClr val="8A8175"/>
                 </a:solidFill>
@@ -15687,7 +15687,7 @@
           <a:p>
             <a:pPr algn="l"/>
             <a:r>
-              <a:rPr b="1" i="0" sz="5200">
+              <a:rPr b="1" i="0" sz="5800">
                 <a:solidFill>
                   <a:srgbClr val="E0D8C4"/>
                 </a:solidFill>
@@ -15722,7 +15722,7 @@
           <a:p>
             <a:pPr algn="l"/>
             <a:r>
-              <a:rPr b="1" i="0" sz="1300">
+              <a:rPr b="1" i="0" sz="1900">
                 <a:solidFill>
                   <a:srgbClr val="3D3833"/>
                 </a:solidFill>
@@ -15757,7 +15757,7 @@
           <a:p>
             <a:pPr algn="l"/>
             <a:r>
-              <a:rPr b="0" i="1" sz="1100">
+              <a:rPr b="0" i="1" sz="1600">
                 <a:solidFill>
                   <a:srgbClr val="3D3833"/>
                 </a:solidFill>
@@ -15792,7 +15792,7 @@
           <a:p>
             <a:pPr algn="l"/>
             <a:r>
-              <a:rPr b="0" i="0" sz="1100">
+              <a:rPr b="0" i="0" sz="1600">
                 <a:solidFill>
                   <a:srgbClr val="8A8175"/>
                 </a:solidFill>
@@ -15913,7 +15913,7 @@
           <a:p>
             <a:pPr algn="l"/>
             <a:r>
-              <a:rPr b="1" i="0" sz="5200">
+              <a:rPr b="1" i="0" sz="5800">
                 <a:solidFill>
                   <a:srgbClr val="E0D8C4"/>
                 </a:solidFill>
@@ -15948,7 +15948,7 @@
           <a:p>
             <a:pPr algn="l"/>
             <a:r>
-              <a:rPr b="1" i="0" sz="1300">
+              <a:rPr b="1" i="0" sz="1900">
                 <a:solidFill>
                   <a:srgbClr val="3D3833"/>
                 </a:solidFill>
@@ -15983,7 +15983,7 @@
           <a:p>
             <a:pPr algn="l"/>
             <a:r>
-              <a:rPr b="0" i="1" sz="1100">
+              <a:rPr b="0" i="1" sz="1600">
                 <a:solidFill>
                   <a:srgbClr val="3D3833"/>
                 </a:solidFill>
@@ -16018,7 +16018,7 @@
           <a:p>
             <a:pPr algn="l"/>
             <a:r>
-              <a:rPr b="0" i="0" sz="1100">
+              <a:rPr b="0" i="0" sz="1600">
                 <a:solidFill>
                   <a:srgbClr val="8A8175"/>
                 </a:solidFill>
@@ -16139,7 +16139,7 @@
           <a:p>
             <a:pPr algn="l"/>
             <a:r>
-              <a:rPr b="1" i="0" sz="5200">
+              <a:rPr b="1" i="0" sz="5800">
                 <a:solidFill>
                   <a:srgbClr val="E0D8C4"/>
                 </a:solidFill>
@@ -16174,7 +16174,7 @@
           <a:p>
             <a:pPr algn="l"/>
             <a:r>
-              <a:rPr b="1" i="0" sz="1300">
+              <a:rPr b="1" i="0" sz="1900">
                 <a:solidFill>
                   <a:srgbClr val="3D3833"/>
                 </a:solidFill>
@@ -16209,7 +16209,7 @@
           <a:p>
             <a:pPr algn="l"/>
             <a:r>
-              <a:rPr b="0" i="1" sz="1100">
+              <a:rPr b="0" i="1" sz="1600">
                 <a:solidFill>
                   <a:srgbClr val="3D3833"/>
                 </a:solidFill>
@@ -16244,7 +16244,7 @@
           <a:p>
             <a:pPr algn="l"/>
             <a:r>
-              <a:rPr b="0" i="0" sz="1100">
+              <a:rPr b="0" i="0" sz="1600">
                 <a:solidFill>
                   <a:srgbClr val="8A8175"/>
                 </a:solidFill>
@@ -16365,7 +16365,7 @@
           <a:p>
             <a:pPr algn="l"/>
             <a:r>
-              <a:rPr b="1" i="0" sz="5200">
+              <a:rPr b="1" i="0" sz="5800">
                 <a:solidFill>
                   <a:srgbClr val="E0D8C4"/>
                 </a:solidFill>
@@ -16400,7 +16400,7 @@
           <a:p>
             <a:pPr algn="l"/>
             <a:r>
-              <a:rPr b="1" i="0" sz="1300">
+              <a:rPr b="1" i="0" sz="1900">
                 <a:solidFill>
                   <a:srgbClr val="3D3833"/>
                 </a:solidFill>
@@ -16435,7 +16435,7 @@
           <a:p>
             <a:pPr algn="l"/>
             <a:r>
-              <a:rPr b="0" i="1" sz="1100">
+              <a:rPr b="0" i="1" sz="1600">
                 <a:solidFill>
                   <a:srgbClr val="3D3833"/>
                 </a:solidFill>
@@ -16470,7 +16470,7 @@
           <a:p>
             <a:pPr algn="l"/>
             <a:r>
-              <a:rPr b="0" i="0" sz="1100">
+              <a:rPr b="0" i="0" sz="1600">
                 <a:solidFill>
                   <a:srgbClr val="8A8175"/>
                 </a:solidFill>
@@ -16574,7 +16574,7 @@
           <a:p>
             <a:pPr algn="l"/>
             <a:r>
-              <a:rPr b="1" i="1" sz="5800">
+              <a:rPr b="1" i="1" sz="6400">
                 <a:solidFill>
                   <a:srgbClr val="F3EDE1"/>
                 </a:solidFill>
@@ -16609,7 +16609,7 @@
           <a:p>
             <a:pPr algn="l"/>
             <a:r>
-              <a:rPr b="1" i="1" sz="5800">
+              <a:rPr b="1" i="1" sz="6400">
                 <a:solidFill>
                   <a:srgbClr val="B8523A"/>
                 </a:solidFill>
@@ -16679,7 +16679,7 @@
           <a:p>
             <a:pPr algn="l"/>
             <a:r>
-              <a:rPr b="0" i="1" sz="1600">
+              <a:rPr b="0" i="1" sz="2200">
                 <a:solidFill>
                   <a:srgbClr val="8A8175"/>
                 </a:solidFill>
@@ -16714,7 +16714,7 @@
           <a:p>
             <a:pPr algn="l"/>
             <a:r>
-              <a:rPr b="0" i="1" sz="1600">
+              <a:rPr b="0" i="1" sz="2200">
                 <a:solidFill>
                   <a:srgbClr val="8A8175"/>
                 </a:solidFill>
@@ -17071,7 +17071,7 @@
           <a:p>
             <a:pPr algn="l"/>
             <a:r>
-              <a:rPr b="1" i="0" sz="4400">
+              <a:rPr b="1" i="0" sz="5000">
                 <a:solidFill>
                   <a:srgbClr val="B8523A"/>
                 </a:solidFill>
@@ -17106,7 +17106,7 @@
           <a:p>
             <a:pPr algn="l"/>
             <a:r>
-              <a:rPr b="0" i="0" sz="1300">
+              <a:rPr b="0" i="0" sz="1900">
                 <a:solidFill>
                   <a:srgbClr val="8A8175"/>
                 </a:solidFill>
@@ -17296,7 +17296,7 @@
           <a:p>
             <a:pPr algn="l"/>
             <a:r>
-              <a:rPr b="1" i="0" sz="1000">
+              <a:rPr b="1" i="0" sz="1400">
                 <a:solidFill>
                   <a:srgbClr val="F3EDE1"/>
                 </a:solidFill>
@@ -17331,7 +17331,7 @@
           <a:p>
             <a:pPr algn="l"/>
             <a:r>
-              <a:rPr b="1" i="0" sz="3200">
+              <a:rPr b="1" i="0" sz="3600">
                 <a:solidFill>
                   <a:srgbClr val="3D3833"/>
                 </a:solidFill>
@@ -17401,7 +17401,7 @@
           <a:p>
             <a:pPr algn="l"/>
             <a:r>
-              <a:rPr b="1" i="0" sz="1400">
+              <a:rPr b="1" i="0" sz="2000">
                 <a:solidFill>
                   <a:srgbClr val="B8523A"/>
                 </a:solidFill>
@@ -17580,7 +17580,7 @@
           <a:p>
             <a:pPr algn="l"/>
             <a:r>
-              <a:rPr b="0" i="1" sz="1100">
+              <a:rPr b="0" i="1" sz="1600">
                 <a:solidFill>
                   <a:srgbClr val="8A8175"/>
                 </a:solidFill>
@@ -17658,7 +17658,7 @@
           <a:p>
             <a:pPr algn="ctr"/>
             <a:r>
-              <a:rPr b="0" i="0" sz="1500">
+              <a:rPr b="0" i="0" sz="2000">
                 <a:solidFill>
                   <a:srgbClr val="8A8175"/>
                 </a:solidFill>
@@ -17762,7 +17762,7 @@
           <a:p>
             <a:pPr algn="l"/>
             <a:r>
-              <a:rPr b="1" i="0" sz="1000">
+              <a:rPr b="1" i="0" sz="1400">
                 <a:solidFill>
                   <a:srgbClr val="F3EDE1"/>
                 </a:solidFill>
@@ -17797,7 +17797,7 @@
           <a:p>
             <a:pPr algn="l"/>
             <a:r>
-              <a:rPr b="1" i="0" sz="4800">
+              <a:rPr b="1" i="0" sz="5400">
                 <a:solidFill>
                   <a:srgbClr val="3D3833"/>
                 </a:solidFill>
@@ -18054,7 +18054,7 @@
           <a:p>
             <a:pPr algn="l"/>
             <a:r>
-              <a:rPr b="1" i="0" sz="5200">
+              <a:rPr b="1" i="0" sz="5800">
                 <a:solidFill>
                   <a:srgbClr val="E0D8C4"/>
                 </a:solidFill>
@@ -18089,7 +18089,7 @@
           <a:p>
             <a:pPr algn="l"/>
             <a:r>
-              <a:rPr b="1" i="0" sz="1300">
+              <a:rPr b="1" i="0" sz="1900">
                 <a:solidFill>
                   <a:srgbClr val="3D3833"/>
                 </a:solidFill>
@@ -18124,7 +18124,7 @@
           <a:p>
             <a:pPr algn="l"/>
             <a:r>
-              <a:rPr b="0" i="0" sz="1100">
+              <a:rPr b="0" i="0" sz="1600">
                 <a:solidFill>
                   <a:srgbClr val="8A8175"/>
                 </a:solidFill>
@@ -18245,7 +18245,7 @@
           <a:p>
             <a:pPr algn="l"/>
             <a:r>
-              <a:rPr b="1" i="0" sz="5200">
+              <a:rPr b="1" i="0" sz="5800">
                 <a:solidFill>
                   <a:srgbClr val="E0D8C4"/>
                 </a:solidFill>
@@ -18280,7 +18280,7 @@
           <a:p>
             <a:pPr algn="l"/>
             <a:r>
-              <a:rPr b="1" i="0" sz="1300">
+              <a:rPr b="1" i="0" sz="1900">
                 <a:solidFill>
                   <a:srgbClr val="3D3833"/>
                 </a:solidFill>
@@ -18315,7 +18315,7 @@
           <a:p>
             <a:pPr algn="l"/>
             <a:r>
-              <a:rPr b="0" i="0" sz="1100">
+              <a:rPr b="0" i="0" sz="1600">
                 <a:solidFill>
                   <a:srgbClr val="8A8175"/>
                 </a:solidFill>
@@ -18436,7 +18436,7 @@
           <a:p>
             <a:pPr algn="l"/>
             <a:r>
-              <a:rPr b="1" i="0" sz="5200">
+              <a:rPr b="1" i="0" sz="5800">
                 <a:solidFill>
                   <a:srgbClr val="E0D8C4"/>
                 </a:solidFill>
@@ -18471,7 +18471,7 @@
           <a:p>
             <a:pPr algn="l"/>
             <a:r>
-              <a:rPr b="1" i="0" sz="1300">
+              <a:rPr b="1" i="0" sz="1900">
                 <a:solidFill>
                   <a:srgbClr val="3D3833"/>
                 </a:solidFill>
@@ -18506,7 +18506,7 @@
           <a:p>
             <a:pPr algn="l"/>
             <a:r>
-              <a:rPr b="0" i="0" sz="1100">
+              <a:rPr b="0" i="0" sz="1600">
                 <a:solidFill>
                   <a:srgbClr val="8A8175"/>
                 </a:solidFill>
@@ -18610,7 +18610,7 @@
           <a:p>
             <a:pPr algn="l"/>
             <a:r>
-              <a:rPr b="1" i="0" sz="1000">
+              <a:rPr b="1" i="0" sz="1400">
                 <a:solidFill>
                   <a:srgbClr val="F3EDE1"/>
                 </a:solidFill>
@@ -18645,7 +18645,7 @@
           <a:p>
             <a:pPr algn="l"/>
             <a:r>
-              <a:rPr b="1" i="0" sz="4000">
+              <a:rPr b="1" i="0" sz="4600">
                 <a:solidFill>
                   <a:srgbClr val="3D3833"/>
                 </a:solidFill>
@@ -18680,7 +18680,7 @@
           <a:p>
             <a:pPr algn="l"/>
             <a:r>
-              <a:rPr b="0" i="0" sz="1400">
+              <a:rPr b="0" i="0" sz="2000">
                 <a:solidFill>
                   <a:srgbClr val="8A8175"/>
                 </a:solidFill>
@@ -18793,7 +18793,7 @@
           <a:p>
             <a:pPr algn="l"/>
             <a:r>
-              <a:rPr b="1" i="0" sz="1200">
+              <a:rPr b="1" i="0" sz="1700">
                 <a:solidFill>
                   <a:srgbClr val="F3EDE1"/>
                 </a:solidFill>
@@ -19016,7 +19016,7 @@
           <a:p>
             <a:pPr algn="l"/>
             <a:r>
-              <a:rPr b="1" i="0" sz="1200">
+              <a:rPr b="1" i="0" sz="1700">
                 <a:solidFill>
                   <a:srgbClr val="F3EDE1"/>
                 </a:solidFill>
@@ -19231,7 +19231,7 @@
           <a:p>
             <a:pPr algn="l"/>
             <a:r>
-              <a:rPr b="1" i="0" sz="1000">
+              <a:rPr b="1" i="0" sz="1400">
                 <a:solidFill>
                   <a:srgbClr val="8A8175"/>
                 </a:solidFill>
@@ -19352,7 +19352,7 @@
           <a:p>
             <a:pPr algn="l"/>
             <a:r>
-              <a:rPr b="1" i="0" sz="1100">
+              <a:rPr b="1" i="0" sz="1600">
                 <a:solidFill>
                   <a:srgbClr val="3D3833"/>
                 </a:solidFill>
@@ -19387,7 +19387,7 @@
           <a:p>
             <a:pPr algn="l"/>
             <a:r>
-              <a:rPr b="0" i="0" sz="1100">
+              <a:rPr b="0" i="0" sz="1600">
                 <a:solidFill>
                   <a:srgbClr val="8A8175"/>
                 </a:solidFill>
@@ -19508,7 +19508,7 @@
           <a:p>
             <a:pPr algn="l"/>
             <a:r>
-              <a:rPr b="1" i="0" sz="1100">
+              <a:rPr b="1" i="0" sz="1600">
                 <a:solidFill>
                   <a:srgbClr val="3D3833"/>
                 </a:solidFill>
@@ -19543,7 +19543,7 @@
           <a:p>
             <a:pPr algn="l"/>
             <a:r>
-              <a:rPr b="0" i="0" sz="1100">
+              <a:rPr b="0" i="0" sz="1600">
                 <a:solidFill>
                   <a:srgbClr val="8A8175"/>
                 </a:solidFill>
@@ -19664,7 +19664,7 @@
           <a:p>
             <a:pPr algn="l"/>
             <a:r>
-              <a:rPr b="1" i="0" sz="1100">
+              <a:rPr b="1" i="0" sz="1600">
                 <a:solidFill>
                   <a:srgbClr val="3D3833"/>
                 </a:solidFill>
@@ -19699,7 +19699,7 @@
           <a:p>
             <a:pPr algn="l"/>
             <a:r>
-              <a:rPr b="0" i="0" sz="1100">
+              <a:rPr b="0" i="0" sz="1600">
                 <a:solidFill>
                   <a:srgbClr val="8A8175"/>
                 </a:solidFill>
@@ -19803,7 +19803,7 @@
           <a:p>
             <a:pPr algn="l"/>
             <a:r>
-              <a:rPr b="1" i="0" sz="1000">
+              <a:rPr b="1" i="0" sz="1400">
                 <a:solidFill>
                   <a:srgbClr val="F3EDE1"/>
                 </a:solidFill>
@@ -19838,7 +19838,7 @@
           <a:p>
             <a:pPr algn="l"/>
             <a:r>
-              <a:rPr b="1" i="0" sz="4400">
+              <a:rPr b="1" i="0" sz="5000">
                 <a:solidFill>
                   <a:srgbClr val="F3EDE1"/>
                 </a:solidFill>
@@ -19873,7 +19873,7 @@
           <a:p>
             <a:pPr algn="l"/>
             <a:r>
-              <a:rPr b="1" i="0" sz="4400">
+              <a:rPr b="1" i="0" sz="5000">
                 <a:solidFill>
                   <a:srgbClr val="B8523A"/>
                 </a:solidFill>
@@ -19908,7 +19908,7 @@
           <a:p>
             <a:pPr algn="l"/>
             <a:r>
-              <a:rPr b="0" i="0" sz="1300">
+              <a:rPr b="0" i="0" sz="1900">
                 <a:solidFill>
                   <a:srgbClr val="8A8175"/>
                 </a:solidFill>
@@ -20064,7 +20064,7 @@
           <a:p>
             <a:pPr algn="l"/>
             <a:r>
-              <a:rPr b="1" i="0" sz="6000">
+              <a:rPr b="1" i="0" sz="6600">
                 <a:solidFill>
                   <a:srgbClr val="332D28"/>
                 </a:solidFill>
@@ -20099,7 +20099,7 @@
           <a:p>
             <a:pPr algn="l"/>
             <a:r>
-              <a:rPr b="1" i="0" sz="1400">
+              <a:rPr b="1" i="0" sz="2000">
                 <a:solidFill>
                   <a:srgbClr val="F3EDE1"/>
                 </a:solidFill>
@@ -20134,7 +20134,7 @@
           <a:p>
             <a:pPr algn="l"/>
             <a:r>
-              <a:rPr b="0" i="0" sz="1100">
+              <a:rPr b="0" i="0" sz="1600">
                 <a:solidFill>
                   <a:srgbClr val="8A8175"/>
                 </a:solidFill>
@@ -20255,7 +20255,7 @@
           <a:p>
             <a:pPr algn="l"/>
             <a:r>
-              <a:rPr b="1" i="0" sz="6000">
+              <a:rPr b="1" i="0" sz="6600">
                 <a:solidFill>
                   <a:srgbClr val="332D28"/>
                 </a:solidFill>
@@ -20290,7 +20290,7 @@
           <a:p>
             <a:pPr algn="l"/>
             <a:r>
-              <a:rPr b="1" i="0" sz="1400">
+              <a:rPr b="1" i="0" sz="2000">
                 <a:solidFill>
                   <a:srgbClr val="F3EDE1"/>
                 </a:solidFill>
@@ -20325,7 +20325,7 @@
           <a:p>
             <a:pPr algn="l"/>
             <a:r>
-              <a:rPr b="0" i="0" sz="1100">
+              <a:rPr b="0" i="0" sz="1600">
                 <a:solidFill>
                   <a:srgbClr val="8A8175"/>
                 </a:solidFill>
@@ -20446,7 +20446,7 @@
           <a:p>
             <a:pPr algn="l"/>
             <a:r>
-              <a:rPr b="1" i="0" sz="6000">
+              <a:rPr b="1" i="0" sz="6600">
                 <a:solidFill>
                   <a:srgbClr val="332D28"/>
                 </a:solidFill>
@@ -20481,7 +20481,7 @@
           <a:p>
             <a:pPr algn="l"/>
             <a:r>
-              <a:rPr b="1" i="0" sz="1400">
+              <a:rPr b="1" i="0" sz="2000">
                 <a:solidFill>
                   <a:srgbClr val="F3EDE1"/>
                 </a:solidFill>
@@ -20516,7 +20516,7 @@
           <a:p>
             <a:pPr algn="l"/>
             <a:r>
-              <a:rPr b="0" i="0" sz="1100">
+              <a:rPr b="0" i="0" sz="1600">
                 <a:solidFill>
                   <a:srgbClr val="8A8175"/>
                 </a:solidFill>
@@ -20594,7 +20594,7 @@
           <a:p>
             <a:pPr algn="ctr"/>
             <a:r>
-              <a:rPr b="0" i="1" sz="1300">
+              <a:rPr b="0" i="1" sz="1900">
                 <a:solidFill>
                   <a:srgbClr val="F3EDE1"/>
                 </a:solidFill>
@@ -20698,7 +20698,7 @@
           <a:p>
             <a:pPr algn="l"/>
             <a:r>
-              <a:rPr b="1" i="0" sz="1000">
+              <a:rPr b="1" i="0" sz="1400">
                 <a:solidFill>
                   <a:srgbClr val="F3EDE1"/>
                 </a:solidFill>
@@ -20733,7 +20733,7 @@
           <a:p>
             <a:pPr algn="l"/>
             <a:r>
-              <a:rPr b="1" i="0" sz="4400">
+              <a:rPr b="1" i="0" sz="5000">
                 <a:solidFill>
                   <a:srgbClr val="3D3833"/>
                 </a:solidFill>
@@ -20768,7 +20768,7 @@
           <a:p>
             <a:pPr algn="l"/>
             <a:r>
-              <a:rPr b="0" i="0" sz="1400">
+              <a:rPr b="0" i="0" sz="2000">
                 <a:solidFill>
                   <a:srgbClr val="8A8175"/>
                 </a:solidFill>
@@ -20881,7 +20881,7 @@
           <a:p>
             <a:pPr algn="l"/>
             <a:r>
-              <a:rPr b="1" i="0" sz="1100">
+              <a:rPr b="1" i="0" sz="1600">
                 <a:solidFill>
                   <a:srgbClr val="F3EDE1"/>
                 </a:solidFill>
@@ -21002,7 +21002,7 @@
           <a:p>
             <a:pPr algn="l"/>
             <a:r>
-              <a:rPr b="0" i="0" sz="1300">
+              <a:rPr b="0" i="0" sz="1900">
                 <a:solidFill>
                   <a:srgbClr val="3D3833"/>
                 </a:solidFill>
@@ -21037,7 +21037,7 @@
           <a:p>
             <a:pPr algn="l"/>
             <a:r>
-              <a:rPr b="0" i="0" sz="1300">
+              <a:rPr b="0" i="0" sz="1900">
                 <a:solidFill>
                   <a:srgbClr val="3D3833"/>
                 </a:solidFill>
@@ -21072,7 +21072,7 @@
           <a:p>
             <a:pPr algn="l"/>
             <a:r>
-              <a:rPr b="0" i="0" sz="1300">
+              <a:rPr b="0" i="0" sz="1900">
                 <a:solidFill>
                   <a:srgbClr val="3D3833"/>
                 </a:solidFill>
@@ -21107,7 +21107,7 @@
           <a:p>
             <a:pPr algn="l"/>
             <a:r>
-              <a:rPr b="0" i="0" sz="1300">
+              <a:rPr b="0" i="0" sz="1900">
                 <a:solidFill>
                   <a:srgbClr val="3D3833"/>
                 </a:solidFill>
@@ -21142,7 +21142,7 @@
           <a:p>
             <a:pPr algn="l"/>
             <a:r>
-              <a:rPr b="0" i="0" sz="1300">
+              <a:rPr b="0" i="0" sz="1900">
                 <a:solidFill>
                   <a:srgbClr val="3D3833"/>
                 </a:solidFill>
@@ -21220,7 +21220,7 @@
           <a:p>
             <a:pPr algn="l"/>
             <a:r>
-              <a:rPr b="1" i="0" sz="1100">
+              <a:rPr b="1" i="0" sz="1600">
                 <a:solidFill>
                   <a:srgbClr val="F3EDE1"/>
                 </a:solidFill>
@@ -21341,7 +21341,7 @@
           <a:p>
             <a:pPr algn="l"/>
             <a:r>
-              <a:rPr b="0" i="0" sz="1300">
+              <a:rPr b="0" i="0" sz="1900">
                 <a:solidFill>
                   <a:srgbClr val="3D3833"/>
                 </a:solidFill>
@@ -21376,7 +21376,7 @@
           <a:p>
             <a:pPr algn="l"/>
             <a:r>
-              <a:rPr b="0" i="0" sz="1300">
+              <a:rPr b="0" i="0" sz="1900">
                 <a:solidFill>
                   <a:srgbClr val="3D3833"/>
                 </a:solidFill>
@@ -21411,7 +21411,7 @@
           <a:p>
             <a:pPr algn="l"/>
             <a:r>
-              <a:rPr b="0" i="0" sz="1300">
+              <a:rPr b="0" i="0" sz="1900">
                 <a:solidFill>
                   <a:srgbClr val="3D3833"/>
                 </a:solidFill>
@@ -21446,7 +21446,7 @@
           <a:p>
             <a:pPr algn="l"/>
             <a:r>
-              <a:rPr b="0" i="0" sz="1300">
+              <a:rPr b="0" i="0" sz="1900">
                 <a:solidFill>
                   <a:srgbClr val="3D3833"/>
                 </a:solidFill>
@@ -21481,7 +21481,7 @@
           <a:p>
             <a:pPr algn="l"/>
             <a:r>
-              <a:rPr b="0" i="0" sz="1300">
+              <a:rPr b="0" i="0" sz="1900">
                 <a:solidFill>
                   <a:srgbClr val="3D3833"/>
                 </a:solidFill>
@@ -21559,7 +21559,7 @@
           <a:p>
             <a:pPr algn="ctr"/>
             <a:r>
-              <a:rPr b="1" i="0" sz="1600">
+              <a:rPr b="1" i="0" sz="2200">
                 <a:solidFill>
                   <a:srgbClr val="F3EDE1"/>
                 </a:solidFill>
@@ -21663,7 +21663,7 @@
           <a:p>
             <a:pPr algn="l"/>
             <a:r>
-              <a:rPr b="1" i="0" sz="1000">
+              <a:rPr b="1" i="0" sz="1400">
                 <a:solidFill>
                   <a:srgbClr val="F3EDE1"/>
                 </a:solidFill>
@@ -21698,7 +21698,7 @@
           <a:p>
             <a:pPr algn="l"/>
             <a:r>
-              <a:rPr b="1" i="0" sz="4400">
+              <a:rPr b="1" i="0" sz="5000">
                 <a:solidFill>
                   <a:srgbClr val="3D3833"/>
                 </a:solidFill>
@@ -21733,7 +21733,7 @@
           <a:p>
             <a:pPr algn="l"/>
             <a:r>
-              <a:rPr b="0" i="0" sz="1400">
+              <a:rPr b="0" i="0" sz="2000">
                 <a:solidFill>
                   <a:srgbClr val="8A8175"/>
                 </a:solidFill>
@@ -21846,7 +21846,7 @@
           <a:p>
             <a:pPr algn="l"/>
             <a:r>
-              <a:rPr b="1" i="0" sz="1200">
+              <a:rPr b="1" i="0" sz="1700">
                 <a:solidFill>
                   <a:srgbClr val="F3EDE1"/>
                 </a:solidFill>
@@ -21967,7 +21967,7 @@
           <a:p>
             <a:pPr algn="l"/>
             <a:r>
-              <a:rPr b="1" i="0" sz="1800">
+              <a:rPr b="1" i="0" sz="2400">
                 <a:solidFill>
                   <a:srgbClr val="3D3833"/>
                 </a:solidFill>
@@ -22002,7 +22002,7 @@
           <a:p>
             <a:pPr algn="l"/>
             <a:r>
-              <a:rPr b="0" i="0" sz="1300">
+              <a:rPr b="0" i="0" sz="1900">
                 <a:solidFill>
                   <a:srgbClr val="8A8175"/>
                 </a:solidFill>
@@ -22037,7 +22037,7 @@
           <a:p>
             <a:pPr algn="l"/>
             <a:r>
-              <a:rPr b="0" i="0" sz="1300">
+              <a:rPr b="0" i="0" sz="1900">
                 <a:solidFill>
                   <a:srgbClr val="8A8175"/>
                 </a:solidFill>
@@ -22072,7 +22072,7 @@
           <a:p>
             <a:pPr algn="l"/>
             <a:r>
-              <a:rPr b="0" i="0" sz="1300">
+              <a:rPr b="0" i="0" sz="1900">
                 <a:solidFill>
                   <a:srgbClr val="8A8175"/>
                 </a:solidFill>
@@ -22107,7 +22107,7 @@
           <a:p>
             <a:pPr algn="l"/>
             <a:r>
-              <a:rPr b="0" i="0" sz="1300">
+              <a:rPr b="0" i="0" sz="1900">
                 <a:solidFill>
                   <a:srgbClr val="8A8175"/>
                 </a:solidFill>
@@ -22185,7 +22185,7 @@
           <a:p>
             <a:pPr algn="l"/>
             <a:r>
-              <a:rPr b="1" i="0" sz="1200">
+              <a:rPr b="1" i="0" sz="1700">
                 <a:solidFill>
                   <a:srgbClr val="F3EDE1"/>
                 </a:solidFill>
@@ -22306,7 +22306,7 @@
           <a:p>
             <a:pPr algn="l"/>
             <a:r>
-              <a:rPr b="1" i="0" sz="1800">
+              <a:rPr b="1" i="0" sz="2400">
                 <a:solidFill>
                   <a:srgbClr val="F3EDE1"/>
                 </a:solidFill>
@@ -22341,7 +22341,7 @@
           <a:p>
             <a:pPr algn="l"/>
             <a:r>
-              <a:rPr b="0" i="0" sz="1300">
+              <a:rPr b="0" i="0" sz="1900">
                 <a:solidFill>
                   <a:srgbClr val="F3EDE1"/>
                 </a:solidFill>
@@ -22376,7 +22376,7 @@
           <a:p>
             <a:pPr algn="l"/>
             <a:r>
-              <a:rPr b="0" i="0" sz="1300">
+              <a:rPr b="0" i="0" sz="1900">
                 <a:solidFill>
                   <a:srgbClr val="F3EDE1"/>
                 </a:solidFill>
@@ -22411,7 +22411,7 @@
           <a:p>
             <a:pPr algn="l"/>
             <a:r>
-              <a:rPr b="0" i="0" sz="1300">
+              <a:rPr b="0" i="0" sz="1900">
                 <a:solidFill>
                   <a:srgbClr val="F3EDE1"/>
                 </a:solidFill>
@@ -22446,7 +22446,7 @@
           <a:p>
             <a:pPr algn="l"/>
             <a:r>
-              <a:rPr b="0" i="0" sz="1300">
+              <a:rPr b="0" i="0" sz="1900">
                 <a:solidFill>
                   <a:srgbClr val="F3EDE1"/>
                 </a:solidFill>
@@ -22481,7 +22481,7 @@
           <a:p>
             <a:pPr algn="ctr"/>
             <a:r>
-              <a:rPr b="1" i="0" sz="4400">
+              <a:rPr b="1" i="0" sz="5000">
                 <a:solidFill>
                   <a:srgbClr val="B8523A"/>
                 </a:solidFill>
@@ -22559,7 +22559,7 @@
           <a:p>
             <a:pPr algn="ctr"/>
             <a:r>
-              <a:rPr b="0" i="1" sz="1200">
+              <a:rPr b="0" i="1" sz="1700">
                 <a:solidFill>
                   <a:srgbClr val="F3EDE1"/>
                 </a:solidFill>
@@ -22663,7 +22663,7 @@
           <a:p>
             <a:pPr algn="l"/>
             <a:r>
-              <a:rPr b="1" i="0" sz="1000">
+              <a:rPr b="1" i="0" sz="1400">
                 <a:solidFill>
                   <a:srgbClr val="F3EDE1"/>
                 </a:solidFill>
@@ -22698,7 +22698,7 @@
           <a:p>
             <a:pPr algn="l"/>
             <a:r>
-              <a:rPr b="1" i="0" sz="3800">
+              <a:rPr b="1" i="0" sz="4400">
                 <a:solidFill>
                   <a:srgbClr val="3D3833"/>
                 </a:solidFill>
@@ -22811,7 +22811,7 @@
           <a:p>
             <a:pPr algn="l"/>
             <a:r>
-              <a:rPr b="1" i="0" sz="1200">
+              <a:rPr b="1" i="0" sz="1700">
                 <a:solidFill>
                   <a:srgbClr val="F3EDE1"/>
                 </a:solidFill>
@@ -22932,7 +22932,7 @@
           <a:p>
             <a:pPr algn="l"/>
             <a:r>
-              <a:rPr b="0" i="0" sz="1200">
+              <a:rPr b="0" i="0" sz="1700">
                 <a:solidFill>
                   <a:srgbClr val="3D3833"/>
                 </a:solidFill>
@@ -22950,7 +22950,7 @@
           <a:p>
             <a:pPr algn="l"/>
             <a:r>
-              <a:rPr b="0" i="0" sz="1200">
+              <a:rPr b="0" i="0" sz="1700">
                 <a:solidFill>
                   <a:srgbClr val="3D3833"/>
                 </a:solidFill>
@@ -22962,7 +22962,7 @@
           <a:p>
             <a:pPr algn="l"/>
             <a:r>
-              <a:rPr b="0" i="0" sz="1200">
+              <a:rPr b="0" i="0" sz="1700">
                 <a:solidFill>
                   <a:srgbClr val="3D3833"/>
                 </a:solidFill>
@@ -23040,7 +23040,7 @@
           <a:p>
             <a:pPr algn="l"/>
             <a:r>
-              <a:rPr b="1" i="0" sz="1200">
+              <a:rPr b="1" i="0" sz="1700">
                 <a:solidFill>
                   <a:srgbClr val="F3EDE1"/>
                 </a:solidFill>
@@ -23161,7 +23161,7 @@
           <a:p>
             <a:pPr algn="l"/>
             <a:r>
-              <a:rPr b="0" i="0" sz="1200">
+              <a:rPr b="0" i="0" sz="1700">
                 <a:solidFill>
                   <a:srgbClr val="3D3833"/>
                 </a:solidFill>
@@ -23173,7 +23173,7 @@
           <a:p>
             <a:pPr algn="l"/>
             <a:r>
-              <a:rPr b="0" i="0" sz="1200">
+              <a:rPr b="0" i="0" sz="1700">
                 <a:solidFill>
                   <a:srgbClr val="3D3833"/>
                 </a:solidFill>
@@ -23191,7 +23191,7 @@
           <a:p>
             <a:pPr algn="l"/>
             <a:r>
-              <a:rPr b="0" i="0" sz="1200">
+              <a:rPr b="0" i="0" sz="1700">
                 <a:solidFill>
                   <a:srgbClr val="3D3833"/>
                 </a:solidFill>
@@ -23304,7 +23304,7 @@
           <a:p>
             <a:pPr algn="l"/>
             <a:r>
-              <a:rPr b="1" i="0" sz="1000">
+              <a:rPr b="1" i="0" sz="1400">
                 <a:solidFill>
                   <a:srgbClr val="B8523A"/>
                 </a:solidFill>
@@ -23339,7 +23339,7 @@
           <a:p>
             <a:pPr algn="l"/>
             <a:r>
-              <a:rPr b="0" i="0" sz="1300">
+              <a:rPr b="0" i="0" sz="1900">
                 <a:solidFill>
                   <a:srgbClr val="8A8175"/>
                 </a:solidFill>
@@ -23460,7 +23460,7 @@
           <a:p>
             <a:pPr algn="l"/>
             <a:r>
-              <a:rPr b="1" i="0" sz="900">
+              <a:rPr b="1" i="0" sz="1300">
                 <a:solidFill>
                   <a:srgbClr val="B8523A"/>
                 </a:solidFill>
@@ -23495,7 +23495,7 @@
           <a:p>
             <a:pPr algn="l"/>
             <a:r>
-              <a:rPr b="1" i="0" sz="1300">
+              <a:rPr b="1" i="0" sz="1900">
                 <a:solidFill>
                   <a:srgbClr val="3D3833"/>
                 </a:solidFill>
@@ -23530,7 +23530,7 @@
           <a:p>
             <a:pPr algn="l"/>
             <a:r>
-              <a:rPr b="0" i="0" sz="1100">
+              <a:rPr b="0" i="0" sz="1600">
                 <a:solidFill>
                   <a:srgbClr val="8A8175"/>
                 </a:solidFill>
@@ -23565,7 +23565,7 @@
           <a:p>
             <a:pPr algn="l"/>
             <a:r>
-              <a:rPr b="0" i="1" sz="1100">
+              <a:rPr b="0" i="1" sz="1600">
                 <a:solidFill>
                   <a:srgbClr val="3D3833"/>
                 </a:solidFill>
@@ -23686,7 +23686,7 @@
           <a:p>
             <a:pPr algn="l"/>
             <a:r>
-              <a:rPr b="1" i="0" sz="900">
+              <a:rPr b="1" i="0" sz="1300">
                 <a:solidFill>
                   <a:srgbClr val="B8523A"/>
                 </a:solidFill>
@@ -23721,7 +23721,7 @@
           <a:p>
             <a:pPr algn="l"/>
             <a:r>
-              <a:rPr b="1" i="0" sz="1300">
+              <a:rPr b="1" i="0" sz="1900">
                 <a:solidFill>
                   <a:srgbClr val="3D3833"/>
                 </a:solidFill>
@@ -23756,7 +23756,7 @@
           <a:p>
             <a:pPr algn="l"/>
             <a:r>
-              <a:rPr b="0" i="0" sz="1100">
+              <a:rPr b="0" i="0" sz="1600">
                 <a:solidFill>
                   <a:srgbClr val="8A8175"/>
                 </a:solidFill>
@@ -23791,7 +23791,7 @@
           <a:p>
             <a:pPr algn="l"/>
             <a:r>
-              <a:rPr b="0" i="1" sz="1100">
+              <a:rPr b="0" i="1" sz="1600">
                 <a:solidFill>
                   <a:srgbClr val="3D3833"/>
                 </a:solidFill>
@@ -23912,7 +23912,7 @@
           <a:p>
             <a:pPr algn="l"/>
             <a:r>
-              <a:rPr b="1" i="0" sz="900">
+              <a:rPr b="1" i="0" sz="1300">
                 <a:solidFill>
                   <a:srgbClr val="B8523A"/>
                 </a:solidFill>
@@ -23947,7 +23947,7 @@
           <a:p>
             <a:pPr algn="l"/>
             <a:r>
-              <a:rPr b="1" i="0" sz="1300">
+              <a:rPr b="1" i="0" sz="1900">
                 <a:solidFill>
                   <a:srgbClr val="3D3833"/>
                 </a:solidFill>
@@ -23982,7 +23982,7 @@
           <a:p>
             <a:pPr algn="l"/>
             <a:r>
-              <a:rPr b="0" i="0" sz="1100">
+              <a:rPr b="0" i="0" sz="1600">
                 <a:solidFill>
                   <a:srgbClr val="8A8175"/>
                 </a:solidFill>
@@ -24017,7 +24017,7 @@
           <a:p>
             <a:pPr algn="l"/>
             <a:r>
-              <a:rPr b="0" i="1" sz="1100">
+              <a:rPr b="0" i="1" sz="1600">
                 <a:solidFill>
                   <a:srgbClr val="3D3833"/>
                 </a:solidFill>

</xml_diff>

<commit_message>
Layout B+A: compress header, anchor panels to bottom
B — Header compresso: CT da H*14% a H*10%, sottotitolo a H*21%,
hline a H*28%, panel start a H*31%.

A — Panel ancorati: ogni slide estende i panel fino a H*88%
eliminando le dead zone inferiori. Slide 17 (Amplificatori):
ph H*14.8% → H*19%, riempie l'intera area contenuto.

Co-Authored-By: Claude Sonnet 4.6 <noreply@anthropic.com>
Claude-Session: https://claude.ai/code/session_012BJMKNkvQJ6bNjyTN4A4ZY
</commit_message>
<xml_diff>
--- a/Social_Listening_Speech_FINAL_v4.pptx
+++ b/Social_Listening_Speech_FINAL_v4.pptx
@@ -3489,7 +3489,7 @@
         </p:nvSpPr>
         <p:spPr>
           <a:xfrm>
-            <a:off x="1280160" y="1440180"/>
+            <a:off x="1280160" y="1028700"/>
             <a:ext cx="15727680" cy="1234440"/>
           </a:xfrm>
           <a:prstGeom prst="rect">
@@ -3524,8 +3524,8 @@
         </p:nvSpPr>
         <p:spPr>
           <a:xfrm>
-            <a:off x="1280160" y="2880360"/>
-            <a:ext cx="15727680" cy="617220"/>
+            <a:off x="1280160" y="2160270"/>
+            <a:ext cx="15727680" cy="565785"/>
           </a:xfrm>
           <a:prstGeom prst="rect">
             <a:avLst/>
@@ -3559,7 +3559,7 @@
         </p:nvCxnSpPr>
         <p:spPr>
           <a:xfrm>
-            <a:off x="1280160" y="3703320"/>
+            <a:off x="1280160" y="2880360"/>
             <a:ext cx="15727680" cy="0"/>
           </a:xfrm>
           <a:prstGeom prst="line">
@@ -3594,8 +3594,8 @@
         </p:nvSpPr>
         <p:spPr>
           <a:xfrm>
-            <a:off x="1280160" y="4011930"/>
-            <a:ext cx="5120640" cy="5966460"/>
+            <a:off x="1280160" y="3188970"/>
+            <a:ext cx="5120640" cy="6583680"/>
           </a:xfrm>
           <a:prstGeom prst="rect">
             <a:avLst/>
@@ -3637,8 +3637,8 @@
         </p:nvSpPr>
         <p:spPr>
           <a:xfrm>
-            <a:off x="1280160" y="4011930"/>
-            <a:ext cx="50292" cy="5966460"/>
+            <a:off x="1280160" y="3188970"/>
+            <a:ext cx="50292" cy="6583680"/>
           </a:xfrm>
           <a:prstGeom prst="rect">
             <a:avLst/>
@@ -3680,7 +3680,7 @@
         </p:nvSpPr>
         <p:spPr>
           <a:xfrm>
-            <a:off x="1444752" y="4063365"/>
+            <a:off x="1444752" y="3240405"/>
             <a:ext cx="1005840" cy="1131570"/>
           </a:xfrm>
           <a:prstGeom prst="rect">
@@ -3715,7 +3715,7 @@
         </p:nvSpPr>
         <p:spPr>
           <a:xfrm>
-            <a:off x="1444752" y="5246370"/>
+            <a:off x="1444752" y="4474845"/>
             <a:ext cx="4572000" cy="822960"/>
           </a:xfrm>
           <a:prstGeom prst="rect">
@@ -3751,7 +3751,7 @@
         </p:nvSpPr>
         <p:spPr>
           <a:xfrm>
-            <a:off x="1444752" y="6100191"/>
+            <a:off x="1444752" y="5349240"/>
             <a:ext cx="4572000" cy="617220"/>
           </a:xfrm>
           <a:prstGeom prst="rect">
@@ -3786,7 +3786,7 @@
         </p:nvSpPr>
         <p:spPr>
           <a:xfrm>
-            <a:off x="1444752" y="6737985"/>
+            <a:off x="1444752" y="5966460"/>
             <a:ext cx="4572000" cy="1440180"/>
           </a:xfrm>
           <a:prstGeom prst="rect">
@@ -3821,7 +3821,7 @@
         </p:nvSpPr>
         <p:spPr>
           <a:xfrm>
-            <a:off x="1444752" y="8229600"/>
+            <a:off x="1444752" y="7509510"/>
             <a:ext cx="4572000" cy="1440180"/>
           </a:xfrm>
           <a:prstGeom prst="rect">
@@ -3856,8 +3856,8 @@
         </p:nvSpPr>
         <p:spPr>
           <a:xfrm>
-            <a:off x="6949440" y="4011930"/>
-            <a:ext cx="5120640" cy="5966460"/>
+            <a:off x="6949440" y="3188970"/>
+            <a:ext cx="5120640" cy="6583680"/>
           </a:xfrm>
           <a:prstGeom prst="rect">
             <a:avLst/>
@@ -3899,8 +3899,8 @@
         </p:nvSpPr>
         <p:spPr>
           <a:xfrm>
-            <a:off x="6949440" y="4011930"/>
-            <a:ext cx="50292" cy="5966460"/>
+            <a:off x="6949440" y="3188970"/>
+            <a:ext cx="50292" cy="6583680"/>
           </a:xfrm>
           <a:prstGeom prst="rect">
             <a:avLst/>
@@ -3942,7 +3942,7 @@
         </p:nvSpPr>
         <p:spPr>
           <a:xfrm>
-            <a:off x="7114032" y="4063365"/>
+            <a:off x="7114032" y="3240405"/>
             <a:ext cx="1005840" cy="1131570"/>
           </a:xfrm>
           <a:prstGeom prst="rect">
@@ -3977,7 +3977,7 @@
         </p:nvSpPr>
         <p:spPr>
           <a:xfrm>
-            <a:off x="7114032" y="5246370"/>
+            <a:off x="7114032" y="4474845"/>
             <a:ext cx="4572000" cy="822960"/>
           </a:xfrm>
           <a:prstGeom prst="rect">
@@ -4013,7 +4013,7 @@
         </p:nvSpPr>
         <p:spPr>
           <a:xfrm>
-            <a:off x="7114032" y="6100191"/>
+            <a:off x="7114032" y="5349240"/>
             <a:ext cx="4572000" cy="617220"/>
           </a:xfrm>
           <a:prstGeom prst="rect">
@@ -4048,7 +4048,7 @@
         </p:nvSpPr>
         <p:spPr>
           <a:xfrm>
-            <a:off x="7114032" y="6737985"/>
+            <a:off x="7114032" y="5966460"/>
             <a:ext cx="4572000" cy="1440180"/>
           </a:xfrm>
           <a:prstGeom prst="rect">
@@ -4083,7 +4083,7 @@
         </p:nvSpPr>
         <p:spPr>
           <a:xfrm>
-            <a:off x="7114032" y="8229600"/>
+            <a:off x="7114032" y="7509510"/>
             <a:ext cx="4572000" cy="1440180"/>
           </a:xfrm>
           <a:prstGeom prst="rect">
@@ -4118,8 +4118,8 @@
         </p:nvSpPr>
         <p:spPr>
           <a:xfrm>
-            <a:off x="12618720" y="4011930"/>
-            <a:ext cx="5120640" cy="5966460"/>
+            <a:off x="12618720" y="3188970"/>
+            <a:ext cx="5120640" cy="6583680"/>
           </a:xfrm>
           <a:prstGeom prst="rect">
             <a:avLst/>
@@ -4161,8 +4161,8 @@
         </p:nvSpPr>
         <p:spPr>
           <a:xfrm>
-            <a:off x="12618720" y="4011930"/>
-            <a:ext cx="50292" cy="5966460"/>
+            <a:off x="12618720" y="3188970"/>
+            <a:ext cx="50292" cy="6583680"/>
           </a:xfrm>
           <a:prstGeom prst="rect">
             <a:avLst/>
@@ -4204,7 +4204,7 @@
         </p:nvSpPr>
         <p:spPr>
           <a:xfrm>
-            <a:off x="12783312" y="4063365"/>
+            <a:off x="12783312" y="3240405"/>
             <a:ext cx="1005840" cy="1131570"/>
           </a:xfrm>
           <a:prstGeom prst="rect">
@@ -4239,7 +4239,7 @@
         </p:nvSpPr>
         <p:spPr>
           <a:xfrm>
-            <a:off x="12783312" y="5246370"/>
+            <a:off x="12783312" y="4474845"/>
             <a:ext cx="4572000" cy="822960"/>
           </a:xfrm>
           <a:prstGeom prst="rect">
@@ -4275,7 +4275,7 @@
         </p:nvSpPr>
         <p:spPr>
           <a:xfrm>
-            <a:off x="12783312" y="6100191"/>
+            <a:off x="12783312" y="5349240"/>
             <a:ext cx="4572000" cy="617220"/>
           </a:xfrm>
           <a:prstGeom prst="rect">
@@ -4310,7 +4310,7 @@
         </p:nvSpPr>
         <p:spPr>
           <a:xfrm>
-            <a:off x="12783312" y="6737985"/>
+            <a:off x="12783312" y="5966460"/>
             <a:ext cx="4572000" cy="1440180"/>
           </a:xfrm>
           <a:prstGeom prst="rect">
@@ -4345,7 +4345,7 @@
         </p:nvSpPr>
         <p:spPr>
           <a:xfrm>
-            <a:off x="12783312" y="8229600"/>
+            <a:off x="12783312" y="7509510"/>
             <a:ext cx="4572000" cy="1440180"/>
           </a:xfrm>
           <a:prstGeom prst="rect">
@@ -4484,7 +4484,7 @@
         </p:nvSpPr>
         <p:spPr>
           <a:xfrm>
-            <a:off x="1280160" y="1440180"/>
+            <a:off x="1280160" y="1028700"/>
             <a:ext cx="15727680" cy="1234440"/>
           </a:xfrm>
           <a:prstGeom prst="rect">
@@ -4519,8 +4519,8 @@
         </p:nvSpPr>
         <p:spPr>
           <a:xfrm>
-            <a:off x="1280160" y="2880360"/>
-            <a:ext cx="15727680" cy="617220"/>
+            <a:off x="1280160" y="2160270"/>
+            <a:ext cx="15727680" cy="565785"/>
           </a:xfrm>
           <a:prstGeom prst="rect">
             <a:avLst/>
@@ -4554,7 +4554,7 @@
         </p:nvCxnSpPr>
         <p:spPr>
           <a:xfrm>
-            <a:off x="1280160" y="3703320"/>
+            <a:off x="1280160" y="2880360"/>
             <a:ext cx="15727680" cy="0"/>
           </a:xfrm>
           <a:prstGeom prst="line">
@@ -4589,8 +4589,8 @@
         </p:nvSpPr>
         <p:spPr>
           <a:xfrm>
-            <a:off x="1280160" y="4011930"/>
-            <a:ext cx="5120640" cy="5040630"/>
+            <a:off x="1280160" y="3188970"/>
+            <a:ext cx="5120640" cy="5863589"/>
           </a:xfrm>
           <a:prstGeom prst="rect">
             <a:avLst/>
@@ -4632,8 +4632,8 @@
         </p:nvSpPr>
         <p:spPr>
           <a:xfrm>
-            <a:off x="1280160" y="4011930"/>
-            <a:ext cx="50292" cy="5040630"/>
+            <a:off x="1280160" y="3188970"/>
+            <a:ext cx="50292" cy="5863589"/>
           </a:xfrm>
           <a:prstGeom prst="rect">
             <a:avLst/>
@@ -4675,7 +4675,7 @@
         </p:nvSpPr>
         <p:spPr>
           <a:xfrm>
-            <a:off x="1444752" y="4114800"/>
+            <a:off x="1444752" y="3291840"/>
             <a:ext cx="4572000" cy="514350"/>
           </a:xfrm>
           <a:prstGeom prst="rect">
@@ -4710,7 +4710,7 @@
         </p:nvSpPr>
         <p:spPr>
           <a:xfrm>
-            <a:off x="1444752" y="4649724"/>
+            <a:off x="1444752" y="3857625"/>
             <a:ext cx="4572000" cy="925830"/>
           </a:xfrm>
           <a:prstGeom prst="rect">
@@ -4746,7 +4746,7 @@
         </p:nvSpPr>
         <p:spPr>
           <a:xfrm>
-            <a:off x="1444752" y="5585841"/>
+            <a:off x="1444752" y="4783455"/>
             <a:ext cx="4572000" cy="720090"/>
           </a:xfrm>
           <a:prstGeom prst="rect">
@@ -4781,7 +4781,7 @@
         </p:nvSpPr>
         <p:spPr>
           <a:xfrm>
-            <a:off x="1444752" y="6336792"/>
+            <a:off x="1444752" y="5534406"/>
             <a:ext cx="4572000" cy="1337310"/>
           </a:xfrm>
           <a:prstGeom prst="rect">
@@ -4816,7 +4816,7 @@
         </p:nvSpPr>
         <p:spPr>
           <a:xfrm>
-            <a:off x="1444752" y="7715250"/>
+            <a:off x="1444752" y="6995160"/>
             <a:ext cx="4572000" cy="1234440"/>
           </a:xfrm>
           <a:prstGeom prst="rect">
@@ -4851,8 +4851,8 @@
         </p:nvSpPr>
         <p:spPr>
           <a:xfrm>
-            <a:off x="6949440" y="4011930"/>
-            <a:ext cx="5120640" cy="5040630"/>
+            <a:off x="6949440" y="3188970"/>
+            <a:ext cx="5120640" cy="5863589"/>
           </a:xfrm>
           <a:prstGeom prst="rect">
             <a:avLst/>
@@ -4894,8 +4894,8 @@
         </p:nvSpPr>
         <p:spPr>
           <a:xfrm>
-            <a:off x="6949440" y="4011930"/>
-            <a:ext cx="50292" cy="5040630"/>
+            <a:off x="6949440" y="3188970"/>
+            <a:ext cx="50292" cy="5863589"/>
           </a:xfrm>
           <a:prstGeom prst="rect">
             <a:avLst/>
@@ -4937,7 +4937,7 @@
         </p:nvSpPr>
         <p:spPr>
           <a:xfrm>
-            <a:off x="7114032" y="4114800"/>
+            <a:off x="7114032" y="3291840"/>
             <a:ext cx="4572000" cy="514350"/>
           </a:xfrm>
           <a:prstGeom prst="rect">
@@ -4972,7 +4972,7 @@
         </p:nvSpPr>
         <p:spPr>
           <a:xfrm>
-            <a:off x="7114032" y="4649724"/>
+            <a:off x="7114032" y="3857625"/>
             <a:ext cx="4572000" cy="925830"/>
           </a:xfrm>
           <a:prstGeom prst="rect">
@@ -5008,7 +5008,7 @@
         </p:nvSpPr>
         <p:spPr>
           <a:xfrm>
-            <a:off x="7114032" y="5585841"/>
+            <a:off x="7114032" y="4783455"/>
             <a:ext cx="4572000" cy="720090"/>
           </a:xfrm>
           <a:prstGeom prst="rect">
@@ -5043,7 +5043,7 @@
         </p:nvSpPr>
         <p:spPr>
           <a:xfrm>
-            <a:off x="7114032" y="6336792"/>
+            <a:off x="7114032" y="5534406"/>
             <a:ext cx="4572000" cy="1337310"/>
           </a:xfrm>
           <a:prstGeom prst="rect">
@@ -5078,7 +5078,7 @@
         </p:nvSpPr>
         <p:spPr>
           <a:xfrm>
-            <a:off x="7114032" y="7715250"/>
+            <a:off x="7114032" y="6995160"/>
             <a:ext cx="4572000" cy="1234440"/>
           </a:xfrm>
           <a:prstGeom prst="rect">
@@ -5113,8 +5113,8 @@
         </p:nvSpPr>
         <p:spPr>
           <a:xfrm>
-            <a:off x="12618720" y="4011930"/>
-            <a:ext cx="5120640" cy="5040630"/>
+            <a:off x="12618720" y="3188970"/>
+            <a:ext cx="5120640" cy="5863589"/>
           </a:xfrm>
           <a:prstGeom prst="rect">
             <a:avLst/>
@@ -5156,8 +5156,8 @@
         </p:nvSpPr>
         <p:spPr>
           <a:xfrm>
-            <a:off x="12618720" y="4011930"/>
-            <a:ext cx="50292" cy="5040630"/>
+            <a:off x="12618720" y="3188970"/>
+            <a:ext cx="50292" cy="5863589"/>
           </a:xfrm>
           <a:prstGeom prst="rect">
             <a:avLst/>
@@ -5199,7 +5199,7 @@
         </p:nvSpPr>
         <p:spPr>
           <a:xfrm>
-            <a:off x="12783312" y="4114800"/>
+            <a:off x="12783312" y="3291840"/>
             <a:ext cx="4572000" cy="514350"/>
           </a:xfrm>
           <a:prstGeom prst="rect">
@@ -5234,7 +5234,7 @@
         </p:nvSpPr>
         <p:spPr>
           <a:xfrm>
-            <a:off x="12783312" y="4649724"/>
+            <a:off x="12783312" y="3857625"/>
             <a:ext cx="4572000" cy="925830"/>
           </a:xfrm>
           <a:prstGeom prst="rect">
@@ -5270,7 +5270,7 @@
         </p:nvSpPr>
         <p:spPr>
           <a:xfrm>
-            <a:off x="12783312" y="5585841"/>
+            <a:off x="12783312" y="4783455"/>
             <a:ext cx="4572000" cy="720090"/>
           </a:xfrm>
           <a:prstGeom prst="rect">
@@ -5305,7 +5305,7 @@
         </p:nvSpPr>
         <p:spPr>
           <a:xfrm>
-            <a:off x="12783312" y="6336792"/>
+            <a:off x="12783312" y="5534406"/>
             <a:ext cx="4572000" cy="1337310"/>
           </a:xfrm>
           <a:prstGeom prst="rect">
@@ -5340,7 +5340,7 @@
         </p:nvSpPr>
         <p:spPr>
           <a:xfrm>
-            <a:off x="12783312" y="7715250"/>
+            <a:off x="12783312" y="6995160"/>
             <a:ext cx="4572000" cy="1234440"/>
           </a:xfrm>
           <a:prstGeom prst="rect">
@@ -6027,7 +6027,7 @@
         </p:nvSpPr>
         <p:spPr>
           <a:xfrm>
-            <a:off x="1280160" y="1440180"/>
+            <a:off x="1280160" y="1028700"/>
             <a:ext cx="15727680" cy="1131570"/>
           </a:xfrm>
           <a:prstGeom prst="rect">
@@ -6167,7 +6167,7 @@
         </p:nvSpPr>
         <p:spPr>
           <a:xfrm>
-            <a:off x="1280160" y="4937760"/>
+            <a:off x="1280160" y="4217670"/>
             <a:ext cx="7315200" cy="565785"/>
           </a:xfrm>
           <a:prstGeom prst="rect">
@@ -6245,8 +6245,8 @@
         </p:nvSpPr>
         <p:spPr>
           <a:xfrm>
-            <a:off x="1280160" y="5534406"/>
-            <a:ext cx="7315200" cy="4114800"/>
+            <a:off x="1280160" y="4814316"/>
+            <a:ext cx="7315200" cy="4217670"/>
           </a:xfrm>
           <a:prstGeom prst="rect">
             <a:avLst/>
@@ -6288,8 +6288,8 @@
         </p:nvSpPr>
         <p:spPr>
           <a:xfrm>
-            <a:off x="1280160" y="5534406"/>
-            <a:ext cx="50292" cy="4114800"/>
+            <a:off x="1280160" y="4814316"/>
+            <a:ext cx="50292" cy="4217670"/>
           </a:xfrm>
           <a:prstGeom prst="rect">
             <a:avLst/>
@@ -6331,8 +6331,8 @@
         </p:nvSpPr>
         <p:spPr>
           <a:xfrm>
-            <a:off x="1463040" y="5637276"/>
-            <a:ext cx="6583680" cy="3909060"/>
+            <a:off x="1463040" y="4917186"/>
+            <a:ext cx="6583680" cy="4011930"/>
           </a:xfrm>
           <a:prstGeom prst="rect">
             <a:avLst/>
@@ -6420,7 +6420,7 @@
         </p:nvSpPr>
         <p:spPr>
           <a:xfrm>
-            <a:off x="9509760" y="4937760"/>
+            <a:off x="9509760" y="4217670"/>
             <a:ext cx="7315200" cy="565785"/>
           </a:xfrm>
           <a:prstGeom prst="rect">
@@ -6498,8 +6498,8 @@
         </p:nvSpPr>
         <p:spPr>
           <a:xfrm>
-            <a:off x="9509760" y="5534406"/>
-            <a:ext cx="7315200" cy="4114800"/>
+            <a:off x="9509760" y="4814316"/>
+            <a:ext cx="7315200" cy="4217670"/>
           </a:xfrm>
           <a:prstGeom prst="rect">
             <a:avLst/>
@@ -6541,8 +6541,8 @@
         </p:nvSpPr>
         <p:spPr>
           <a:xfrm>
-            <a:off x="9509760" y="5534406"/>
-            <a:ext cx="50292" cy="4114800"/>
+            <a:off x="9509760" y="4814316"/>
+            <a:ext cx="50292" cy="4217670"/>
           </a:xfrm>
           <a:prstGeom prst="rect">
             <a:avLst/>
@@ -6584,8 +6584,8 @@
         </p:nvSpPr>
         <p:spPr>
           <a:xfrm>
-            <a:off x="9692640" y="5637276"/>
-            <a:ext cx="6583680" cy="3909060"/>
+            <a:off x="9692640" y="4917186"/>
+            <a:ext cx="6583680" cy="4011930"/>
           </a:xfrm>
           <a:prstGeom prst="rect">
             <a:avLst/>
@@ -6777,7 +6777,7 @@
         </p:nvSpPr>
         <p:spPr>
           <a:xfrm>
-            <a:off x="1280160" y="1440180"/>
+            <a:off x="1280160" y="1028700"/>
             <a:ext cx="15727680" cy="1234440"/>
           </a:xfrm>
           <a:prstGeom prst="rect">
@@ -6812,8 +6812,8 @@
         </p:nvSpPr>
         <p:spPr>
           <a:xfrm>
-            <a:off x="1280160" y="2880360"/>
-            <a:ext cx="15727680" cy="617220"/>
+            <a:off x="1280160" y="2160270"/>
+            <a:ext cx="15727680" cy="565785"/>
           </a:xfrm>
           <a:prstGeom prst="rect">
             <a:avLst/>
@@ -6847,7 +6847,7 @@
         </p:nvCxnSpPr>
         <p:spPr>
           <a:xfrm>
-            <a:off x="1280160" y="3703320"/>
+            <a:off x="1280160" y="2880360"/>
             <a:ext cx="15727680" cy="0"/>
           </a:xfrm>
           <a:prstGeom prst="line">
@@ -6882,8 +6882,8 @@
         </p:nvSpPr>
         <p:spPr>
           <a:xfrm>
-            <a:off x="1280160" y="4011930"/>
-            <a:ext cx="2980944" cy="5657850"/>
+            <a:off x="1280160" y="3188970"/>
+            <a:ext cx="2980944" cy="5863589"/>
           </a:xfrm>
           <a:prstGeom prst="rect">
             <a:avLst/>
@@ -6925,8 +6925,8 @@
         </p:nvSpPr>
         <p:spPr>
           <a:xfrm>
-            <a:off x="1280160" y="4011930"/>
-            <a:ext cx="50292" cy="5657850"/>
+            <a:off x="1280160" y="3188970"/>
+            <a:ext cx="50292" cy="5863589"/>
           </a:xfrm>
           <a:prstGeom prst="rect">
             <a:avLst/>
@@ -6968,7 +6968,7 @@
         </p:nvSpPr>
         <p:spPr>
           <a:xfrm>
-            <a:off x="1444752" y="4063365"/>
+            <a:off x="1444752" y="3240405"/>
             <a:ext cx="2980944" cy="1028700"/>
           </a:xfrm>
           <a:prstGeom prst="rect">
@@ -7003,7 +7003,7 @@
         </p:nvSpPr>
         <p:spPr>
           <a:xfrm>
-            <a:off x="1444752" y="5112639"/>
+            <a:off x="1444752" y="4320540"/>
             <a:ext cx="2798064" cy="925830"/>
           </a:xfrm>
           <a:prstGeom prst="rect">
@@ -7039,7 +7039,7 @@
         </p:nvSpPr>
         <p:spPr>
           <a:xfrm>
-            <a:off x="1444752" y="6069330"/>
+            <a:off x="1444752" y="5246370"/>
             <a:ext cx="2798064" cy="2366010"/>
           </a:xfrm>
           <a:prstGeom prst="rect">
@@ -7109,8 +7109,8 @@
         </p:nvSpPr>
         <p:spPr>
           <a:xfrm>
-            <a:off x="4334256" y="4011930"/>
-            <a:ext cx="2980944" cy="5657850"/>
+            <a:off x="4334256" y="3188970"/>
+            <a:ext cx="2980944" cy="5863589"/>
           </a:xfrm>
           <a:prstGeom prst="rect">
             <a:avLst/>
@@ -7152,8 +7152,8 @@
         </p:nvSpPr>
         <p:spPr>
           <a:xfrm>
-            <a:off x="4334256" y="4011930"/>
-            <a:ext cx="50292" cy="5657850"/>
+            <a:off x="4334256" y="3188970"/>
+            <a:ext cx="50292" cy="5863589"/>
           </a:xfrm>
           <a:prstGeom prst="rect">
             <a:avLst/>
@@ -7195,7 +7195,7 @@
         </p:nvSpPr>
         <p:spPr>
           <a:xfrm>
-            <a:off x="4498848" y="4063365"/>
+            <a:off x="4498848" y="3240405"/>
             <a:ext cx="2980944" cy="1028700"/>
           </a:xfrm>
           <a:prstGeom prst="rect">
@@ -7230,7 +7230,7 @@
         </p:nvSpPr>
         <p:spPr>
           <a:xfrm>
-            <a:off x="4498848" y="5112639"/>
+            <a:off x="4498848" y="4320540"/>
             <a:ext cx="2798064" cy="925830"/>
           </a:xfrm>
           <a:prstGeom prst="rect">
@@ -7266,7 +7266,7 @@
         </p:nvSpPr>
         <p:spPr>
           <a:xfrm>
-            <a:off x="4498848" y="6069330"/>
+            <a:off x="4498848" y="5246370"/>
             <a:ext cx="2798064" cy="2366010"/>
           </a:xfrm>
           <a:prstGeom prst="rect">
@@ -7336,8 +7336,8 @@
         </p:nvSpPr>
         <p:spPr>
           <a:xfrm>
-            <a:off x="7388352" y="4011930"/>
-            <a:ext cx="2980944" cy="5657850"/>
+            <a:off x="7388352" y="3188970"/>
+            <a:ext cx="2980944" cy="5863589"/>
           </a:xfrm>
           <a:prstGeom prst="rect">
             <a:avLst/>
@@ -7379,8 +7379,8 @@
         </p:nvSpPr>
         <p:spPr>
           <a:xfrm>
-            <a:off x="7388352" y="4011930"/>
-            <a:ext cx="50292" cy="5657850"/>
+            <a:off x="7388352" y="3188970"/>
+            <a:ext cx="50292" cy="5863589"/>
           </a:xfrm>
           <a:prstGeom prst="rect">
             <a:avLst/>
@@ -7422,7 +7422,7 @@
         </p:nvSpPr>
         <p:spPr>
           <a:xfrm>
-            <a:off x="7552944" y="4063365"/>
+            <a:off x="7552944" y="3240405"/>
             <a:ext cx="2980944" cy="1028700"/>
           </a:xfrm>
           <a:prstGeom prst="rect">
@@ -7457,7 +7457,7 @@
         </p:nvSpPr>
         <p:spPr>
           <a:xfrm>
-            <a:off x="7552944" y="5112639"/>
+            <a:off x="7552944" y="4320540"/>
             <a:ext cx="2798064" cy="925830"/>
           </a:xfrm>
           <a:prstGeom prst="rect">
@@ -7493,7 +7493,7 @@
         </p:nvSpPr>
         <p:spPr>
           <a:xfrm>
-            <a:off x="7552944" y="6069330"/>
+            <a:off x="7552944" y="5246370"/>
             <a:ext cx="2798064" cy="2366010"/>
           </a:xfrm>
           <a:prstGeom prst="rect">
@@ -7563,8 +7563,8 @@
         </p:nvSpPr>
         <p:spPr>
           <a:xfrm>
-            <a:off x="10442448" y="4011930"/>
-            <a:ext cx="2980944" cy="5657850"/>
+            <a:off x="10442448" y="3188970"/>
+            <a:ext cx="2980944" cy="5863589"/>
           </a:xfrm>
           <a:prstGeom prst="rect">
             <a:avLst/>
@@ -7606,8 +7606,8 @@
         </p:nvSpPr>
         <p:spPr>
           <a:xfrm>
-            <a:off x="10442448" y="4011930"/>
-            <a:ext cx="50292" cy="5657850"/>
+            <a:off x="10442448" y="3188970"/>
+            <a:ext cx="50292" cy="5863589"/>
           </a:xfrm>
           <a:prstGeom prst="rect">
             <a:avLst/>
@@ -7649,7 +7649,7 @@
         </p:nvSpPr>
         <p:spPr>
           <a:xfrm>
-            <a:off x="10607040" y="4063365"/>
+            <a:off x="10607040" y="3240405"/>
             <a:ext cx="2980944" cy="1028700"/>
           </a:xfrm>
           <a:prstGeom prst="rect">
@@ -7684,7 +7684,7 @@
         </p:nvSpPr>
         <p:spPr>
           <a:xfrm>
-            <a:off x="10607040" y="5112639"/>
+            <a:off x="10607040" y="4320540"/>
             <a:ext cx="2798064" cy="925830"/>
           </a:xfrm>
           <a:prstGeom prst="rect">
@@ -7720,7 +7720,7 @@
         </p:nvSpPr>
         <p:spPr>
           <a:xfrm>
-            <a:off x="10607040" y="6069330"/>
+            <a:off x="10607040" y="5246370"/>
             <a:ext cx="2798064" cy="2366010"/>
           </a:xfrm>
           <a:prstGeom prst="rect">
@@ -7790,8 +7790,8 @@
         </p:nvSpPr>
         <p:spPr>
           <a:xfrm>
-            <a:off x="13496544" y="4011930"/>
-            <a:ext cx="2980944" cy="5657850"/>
+            <a:off x="13496544" y="3188970"/>
+            <a:ext cx="2980944" cy="5863589"/>
           </a:xfrm>
           <a:prstGeom prst="rect">
             <a:avLst/>
@@ -7833,8 +7833,8 @@
         </p:nvSpPr>
         <p:spPr>
           <a:xfrm>
-            <a:off x="13496544" y="4011930"/>
-            <a:ext cx="50292" cy="5657850"/>
+            <a:off x="13496544" y="3188970"/>
+            <a:ext cx="50292" cy="5863589"/>
           </a:xfrm>
           <a:prstGeom prst="rect">
             <a:avLst/>
@@ -7876,7 +7876,7 @@
         </p:nvSpPr>
         <p:spPr>
           <a:xfrm>
-            <a:off x="13661136" y="4063365"/>
+            <a:off x="13661136" y="3240405"/>
             <a:ext cx="2980944" cy="1028700"/>
           </a:xfrm>
           <a:prstGeom prst="rect">
@@ -7911,7 +7911,7 @@
         </p:nvSpPr>
         <p:spPr>
           <a:xfrm>
-            <a:off x="13661136" y="5112639"/>
+            <a:off x="13661136" y="4320540"/>
             <a:ext cx="2798064" cy="925830"/>
           </a:xfrm>
           <a:prstGeom prst="rect">
@@ -7947,7 +7947,7 @@
         </p:nvSpPr>
         <p:spPr>
           <a:xfrm>
-            <a:off x="13661136" y="6069330"/>
+            <a:off x="13661136" y="5246370"/>
             <a:ext cx="2798064" cy="2366010"/>
           </a:xfrm>
           <a:prstGeom prst="rect">
@@ -8121,7 +8121,7 @@
         </p:nvSpPr>
         <p:spPr>
           <a:xfrm>
-            <a:off x="1280160" y="1440180"/>
+            <a:off x="1280160" y="1028700"/>
             <a:ext cx="15727680" cy="1131570"/>
           </a:xfrm>
           <a:prstGeom prst="rect">
@@ -8156,8 +8156,8 @@
         </p:nvSpPr>
         <p:spPr>
           <a:xfrm>
-            <a:off x="0" y="2468880"/>
-            <a:ext cx="18288000" cy="977265"/>
+            <a:off x="0" y="2160270"/>
+            <a:ext cx="18288000" cy="925830"/>
           </a:xfrm>
           <a:prstGeom prst="rect">
             <a:avLst/>
@@ -8199,8 +8199,8 @@
         </p:nvSpPr>
         <p:spPr>
           <a:xfrm>
-            <a:off x="0" y="2468880"/>
-            <a:ext cx="82296" cy="977265"/>
+            <a:off x="0" y="2160270"/>
+            <a:ext cx="82296" cy="925830"/>
           </a:xfrm>
           <a:prstGeom prst="rect">
             <a:avLst/>
@@ -8277,7 +8277,7 @@
         </p:nvSpPr>
         <p:spPr>
           <a:xfrm>
-            <a:off x="1280160" y="2911220"/>
+            <a:off x="1280160" y="2592324"/>
             <a:ext cx="15727680" cy="411480"/>
           </a:xfrm>
           <a:prstGeom prst="rect">
@@ -8312,7 +8312,7 @@
         </p:nvSpPr>
         <p:spPr>
           <a:xfrm>
-            <a:off x="1280160" y="3559301"/>
+            <a:off x="1280160" y="3188970"/>
             <a:ext cx="3803904" cy="1059561"/>
           </a:xfrm>
           <a:prstGeom prst="rect">
@@ -8355,7 +8355,7 @@
         </p:nvSpPr>
         <p:spPr>
           <a:xfrm>
-            <a:off x="1280160" y="3559301"/>
+            <a:off x="1280160" y="3188970"/>
             <a:ext cx="45720" cy="1059561"/>
           </a:xfrm>
           <a:prstGeom prst="rect">
@@ -8398,7 +8398,7 @@
         </p:nvSpPr>
         <p:spPr>
           <a:xfrm>
-            <a:off x="1399032" y="3651884"/>
+            <a:off x="1399032" y="3281553"/>
             <a:ext cx="3657600" cy="308610"/>
           </a:xfrm>
           <a:prstGeom prst="rect">
@@ -8433,7 +8433,7 @@
         </p:nvSpPr>
         <p:spPr>
           <a:xfrm>
-            <a:off x="1399032" y="3960494"/>
+            <a:off x="1399032" y="3590163"/>
             <a:ext cx="3657600" cy="411480"/>
           </a:xfrm>
           <a:prstGeom prst="rect">
@@ -8468,7 +8468,7 @@
         </p:nvSpPr>
         <p:spPr>
           <a:xfrm>
-            <a:off x="1399032" y="4361687"/>
+            <a:off x="1399032" y="3991356"/>
             <a:ext cx="3657600" cy="205740"/>
           </a:xfrm>
           <a:prstGeom prst="rect">
@@ -8503,7 +8503,7 @@
         </p:nvSpPr>
         <p:spPr>
           <a:xfrm>
-            <a:off x="5248656" y="3559301"/>
+            <a:off x="5248656" y="3188970"/>
             <a:ext cx="3803904" cy="1059561"/>
           </a:xfrm>
           <a:prstGeom prst="rect">
@@ -8546,7 +8546,7 @@
         </p:nvSpPr>
         <p:spPr>
           <a:xfrm>
-            <a:off x="5248656" y="3559301"/>
+            <a:off x="5248656" y="3188970"/>
             <a:ext cx="45720" cy="1059561"/>
           </a:xfrm>
           <a:prstGeom prst="rect">
@@ -8589,7 +8589,7 @@
         </p:nvSpPr>
         <p:spPr>
           <a:xfrm>
-            <a:off x="5367528" y="3651884"/>
+            <a:off x="5367528" y="3281553"/>
             <a:ext cx="3657600" cy="308610"/>
           </a:xfrm>
           <a:prstGeom prst="rect">
@@ -8624,7 +8624,7 @@
         </p:nvSpPr>
         <p:spPr>
           <a:xfrm>
-            <a:off x="5367528" y="3960494"/>
+            <a:off x="5367528" y="3590163"/>
             <a:ext cx="3657600" cy="411480"/>
           </a:xfrm>
           <a:prstGeom prst="rect">
@@ -8659,7 +8659,7 @@
         </p:nvSpPr>
         <p:spPr>
           <a:xfrm>
-            <a:off x="5367528" y="4361687"/>
+            <a:off x="5367528" y="3991356"/>
             <a:ext cx="3657600" cy="205740"/>
           </a:xfrm>
           <a:prstGeom prst="rect">
@@ -8694,7 +8694,7 @@
         </p:nvSpPr>
         <p:spPr>
           <a:xfrm>
-            <a:off x="9217152" y="3559301"/>
+            <a:off x="9217152" y="3188970"/>
             <a:ext cx="3803904" cy="1059561"/>
           </a:xfrm>
           <a:prstGeom prst="rect">
@@ -8737,7 +8737,7 @@
         </p:nvSpPr>
         <p:spPr>
           <a:xfrm>
-            <a:off x="9217152" y="3559301"/>
+            <a:off x="9217152" y="3188970"/>
             <a:ext cx="45720" cy="1059561"/>
           </a:xfrm>
           <a:prstGeom prst="rect">
@@ -8780,7 +8780,7 @@
         </p:nvSpPr>
         <p:spPr>
           <a:xfrm>
-            <a:off x="9336024" y="3651884"/>
+            <a:off x="9336024" y="3281553"/>
             <a:ext cx="3657600" cy="308610"/>
           </a:xfrm>
           <a:prstGeom prst="rect">
@@ -8815,7 +8815,7 @@
         </p:nvSpPr>
         <p:spPr>
           <a:xfrm>
-            <a:off x="9336024" y="3960494"/>
+            <a:off x="9336024" y="3590163"/>
             <a:ext cx="3657600" cy="411480"/>
           </a:xfrm>
           <a:prstGeom prst="rect">
@@ -8850,7 +8850,7 @@
         </p:nvSpPr>
         <p:spPr>
           <a:xfrm>
-            <a:off x="9336024" y="4361687"/>
+            <a:off x="9336024" y="3991356"/>
             <a:ext cx="3657600" cy="205740"/>
           </a:xfrm>
           <a:prstGeom prst="rect">
@@ -8885,7 +8885,7 @@
         </p:nvSpPr>
         <p:spPr>
           <a:xfrm>
-            <a:off x="13185648" y="3559301"/>
+            <a:off x="13185648" y="3188970"/>
             <a:ext cx="3803904" cy="1059561"/>
           </a:xfrm>
           <a:prstGeom prst="rect">
@@ -8928,7 +8928,7 @@
         </p:nvSpPr>
         <p:spPr>
           <a:xfrm>
-            <a:off x="13185648" y="3559301"/>
+            <a:off x="13185648" y="3188970"/>
             <a:ext cx="45720" cy="1059561"/>
           </a:xfrm>
           <a:prstGeom prst="rect">
@@ -8971,7 +8971,7 @@
         </p:nvSpPr>
         <p:spPr>
           <a:xfrm>
-            <a:off x="13304520" y="3651884"/>
+            <a:off x="13304520" y="3281553"/>
             <a:ext cx="3657600" cy="308610"/>
           </a:xfrm>
           <a:prstGeom prst="rect">
@@ -9006,7 +9006,7 @@
         </p:nvSpPr>
         <p:spPr>
           <a:xfrm>
-            <a:off x="13304520" y="3960494"/>
+            <a:off x="13304520" y="3590163"/>
             <a:ext cx="3657600" cy="411480"/>
           </a:xfrm>
           <a:prstGeom prst="rect">
@@ -9041,7 +9041,7 @@
         </p:nvSpPr>
         <p:spPr>
           <a:xfrm>
-            <a:off x="13304520" y="4361687"/>
+            <a:off x="13304520" y="3991356"/>
             <a:ext cx="3657600" cy="205740"/>
           </a:xfrm>
           <a:prstGeom prst="rect">
@@ -9076,7 +9076,7 @@
         </p:nvSpPr>
         <p:spPr>
           <a:xfrm>
-            <a:off x="1280160" y="4690871"/>
+            <a:off x="1280160" y="4320540"/>
             <a:ext cx="3803904" cy="1059561"/>
           </a:xfrm>
           <a:prstGeom prst="rect">
@@ -9119,7 +9119,7 @@
         </p:nvSpPr>
         <p:spPr>
           <a:xfrm>
-            <a:off x="1280160" y="4690871"/>
+            <a:off x="1280160" y="4320540"/>
             <a:ext cx="45720" cy="1059561"/>
           </a:xfrm>
           <a:prstGeom prst="rect">
@@ -9162,7 +9162,7 @@
         </p:nvSpPr>
         <p:spPr>
           <a:xfrm>
-            <a:off x="1399032" y="4783454"/>
+            <a:off x="1399032" y="4413123"/>
             <a:ext cx="3657600" cy="308610"/>
           </a:xfrm>
           <a:prstGeom prst="rect">
@@ -9197,7 +9197,7 @@
         </p:nvSpPr>
         <p:spPr>
           <a:xfrm>
-            <a:off x="1399032" y="5092064"/>
+            <a:off x="1399032" y="4721733"/>
             <a:ext cx="3657600" cy="411480"/>
           </a:xfrm>
           <a:prstGeom prst="rect">
@@ -9232,7 +9232,7 @@
         </p:nvSpPr>
         <p:spPr>
           <a:xfrm>
-            <a:off x="1399032" y="5493257"/>
+            <a:off x="1399032" y="5122926"/>
             <a:ext cx="3657600" cy="205740"/>
           </a:xfrm>
           <a:prstGeom prst="rect">
@@ -9267,7 +9267,7 @@
         </p:nvSpPr>
         <p:spPr>
           <a:xfrm>
-            <a:off x="5248656" y="4690871"/>
+            <a:off x="5248656" y="4320540"/>
             <a:ext cx="3803904" cy="1059561"/>
           </a:xfrm>
           <a:prstGeom prst="rect">
@@ -9310,7 +9310,7 @@
         </p:nvSpPr>
         <p:spPr>
           <a:xfrm>
-            <a:off x="5248656" y="4690871"/>
+            <a:off x="5248656" y="4320540"/>
             <a:ext cx="45720" cy="1059561"/>
           </a:xfrm>
           <a:prstGeom prst="rect">
@@ -9353,7 +9353,7 @@
         </p:nvSpPr>
         <p:spPr>
           <a:xfrm>
-            <a:off x="5367528" y="4783454"/>
+            <a:off x="5367528" y="4413123"/>
             <a:ext cx="3657600" cy="308610"/>
           </a:xfrm>
           <a:prstGeom prst="rect">
@@ -9388,7 +9388,7 @@
         </p:nvSpPr>
         <p:spPr>
           <a:xfrm>
-            <a:off x="5367528" y="5092064"/>
+            <a:off x="5367528" y="4721733"/>
             <a:ext cx="3657600" cy="411480"/>
           </a:xfrm>
           <a:prstGeom prst="rect">
@@ -9423,7 +9423,7 @@
         </p:nvSpPr>
         <p:spPr>
           <a:xfrm>
-            <a:off x="5367528" y="5493257"/>
+            <a:off x="5367528" y="5122926"/>
             <a:ext cx="3657600" cy="205740"/>
           </a:xfrm>
           <a:prstGeom prst="rect">
@@ -9458,7 +9458,7 @@
         </p:nvSpPr>
         <p:spPr>
           <a:xfrm>
-            <a:off x="9217152" y="4690871"/>
+            <a:off x="9217152" y="4320540"/>
             <a:ext cx="3803904" cy="1059561"/>
           </a:xfrm>
           <a:prstGeom prst="rect">
@@ -9501,7 +9501,7 @@
         </p:nvSpPr>
         <p:spPr>
           <a:xfrm>
-            <a:off x="9217152" y="4690871"/>
+            <a:off x="9217152" y="4320540"/>
             <a:ext cx="45720" cy="1059561"/>
           </a:xfrm>
           <a:prstGeom prst="rect">
@@ -9544,7 +9544,7 @@
         </p:nvSpPr>
         <p:spPr>
           <a:xfrm>
-            <a:off x="9336024" y="4783454"/>
+            <a:off x="9336024" y="4413123"/>
             <a:ext cx="3657600" cy="308610"/>
           </a:xfrm>
           <a:prstGeom prst="rect">
@@ -9579,7 +9579,7 @@
         </p:nvSpPr>
         <p:spPr>
           <a:xfrm>
-            <a:off x="9336024" y="5092064"/>
+            <a:off x="9336024" y="4721733"/>
             <a:ext cx="3657600" cy="411480"/>
           </a:xfrm>
           <a:prstGeom prst="rect">
@@ -9614,7 +9614,7 @@
         </p:nvSpPr>
         <p:spPr>
           <a:xfrm>
-            <a:off x="9336024" y="5493257"/>
+            <a:off x="9336024" y="5122926"/>
             <a:ext cx="3657600" cy="205740"/>
           </a:xfrm>
           <a:prstGeom prst="rect">
@@ -9649,7 +9649,7 @@
         </p:nvSpPr>
         <p:spPr>
           <a:xfrm>
-            <a:off x="13185648" y="4690871"/>
+            <a:off x="13185648" y="4320540"/>
             <a:ext cx="3803904" cy="1059561"/>
           </a:xfrm>
           <a:prstGeom prst="rect">
@@ -9692,7 +9692,7 @@
         </p:nvSpPr>
         <p:spPr>
           <a:xfrm>
-            <a:off x="13185648" y="4690871"/>
+            <a:off x="13185648" y="4320540"/>
             <a:ext cx="45720" cy="1059561"/>
           </a:xfrm>
           <a:prstGeom prst="rect">
@@ -9735,7 +9735,7 @@
         </p:nvSpPr>
         <p:spPr>
           <a:xfrm>
-            <a:off x="13304520" y="4783454"/>
+            <a:off x="13304520" y="4413123"/>
             <a:ext cx="3657600" cy="308610"/>
           </a:xfrm>
           <a:prstGeom prst="rect">
@@ -9770,7 +9770,7 @@
         </p:nvSpPr>
         <p:spPr>
           <a:xfrm>
-            <a:off x="13304520" y="5092064"/>
+            <a:off x="13304520" y="4721733"/>
             <a:ext cx="3657600" cy="411480"/>
           </a:xfrm>
           <a:prstGeom prst="rect">
@@ -9805,7 +9805,7 @@
         </p:nvSpPr>
         <p:spPr>
           <a:xfrm>
-            <a:off x="13304520" y="5493257"/>
+            <a:off x="13304520" y="5122926"/>
             <a:ext cx="3657600" cy="205740"/>
           </a:xfrm>
           <a:prstGeom prst="rect">
@@ -9840,7 +9840,7 @@
         </p:nvSpPr>
         <p:spPr>
           <a:xfrm>
-            <a:off x="1280160" y="5822441"/>
+            <a:off x="1280160" y="5452110"/>
             <a:ext cx="3803904" cy="1059561"/>
           </a:xfrm>
           <a:prstGeom prst="rect">
@@ -9883,7 +9883,7 @@
         </p:nvSpPr>
         <p:spPr>
           <a:xfrm>
-            <a:off x="1280160" y="5822441"/>
+            <a:off x="1280160" y="5452110"/>
             <a:ext cx="45720" cy="1059561"/>
           </a:xfrm>
           <a:prstGeom prst="rect">
@@ -9926,7 +9926,7 @@
         </p:nvSpPr>
         <p:spPr>
           <a:xfrm>
-            <a:off x="1399032" y="5915024"/>
+            <a:off x="1399032" y="5544693"/>
             <a:ext cx="3657600" cy="308610"/>
           </a:xfrm>
           <a:prstGeom prst="rect">
@@ -9961,7 +9961,7 @@
         </p:nvSpPr>
         <p:spPr>
           <a:xfrm>
-            <a:off x="1399032" y="6223634"/>
+            <a:off x="1399032" y="5853303"/>
             <a:ext cx="3657600" cy="411480"/>
           </a:xfrm>
           <a:prstGeom prst="rect">
@@ -9996,7 +9996,7 @@
         </p:nvSpPr>
         <p:spPr>
           <a:xfrm>
-            <a:off x="1399032" y="6624827"/>
+            <a:off x="1399032" y="6254496"/>
             <a:ext cx="3657600" cy="205740"/>
           </a:xfrm>
           <a:prstGeom prst="rect">
@@ -10031,7 +10031,7 @@
         </p:nvSpPr>
         <p:spPr>
           <a:xfrm>
-            <a:off x="5248656" y="5822441"/>
+            <a:off x="5248656" y="5452110"/>
             <a:ext cx="3803904" cy="1059561"/>
           </a:xfrm>
           <a:prstGeom prst="rect">
@@ -10074,7 +10074,7 @@
         </p:nvSpPr>
         <p:spPr>
           <a:xfrm>
-            <a:off x="5248656" y="5822441"/>
+            <a:off x="5248656" y="5452110"/>
             <a:ext cx="45720" cy="1059561"/>
           </a:xfrm>
           <a:prstGeom prst="rect">
@@ -10117,7 +10117,7 @@
         </p:nvSpPr>
         <p:spPr>
           <a:xfrm>
-            <a:off x="5367528" y="5915024"/>
+            <a:off x="5367528" y="5544693"/>
             <a:ext cx="3657600" cy="308610"/>
           </a:xfrm>
           <a:prstGeom prst="rect">
@@ -10152,7 +10152,7 @@
         </p:nvSpPr>
         <p:spPr>
           <a:xfrm>
-            <a:off x="5367528" y="6223634"/>
+            <a:off x="5367528" y="5853303"/>
             <a:ext cx="3657600" cy="411480"/>
           </a:xfrm>
           <a:prstGeom prst="rect">
@@ -10187,7 +10187,7 @@
         </p:nvSpPr>
         <p:spPr>
           <a:xfrm>
-            <a:off x="5367528" y="6624827"/>
+            <a:off x="5367528" y="6254496"/>
             <a:ext cx="3657600" cy="205740"/>
           </a:xfrm>
           <a:prstGeom prst="rect">
@@ -10222,7 +10222,7 @@
         </p:nvSpPr>
         <p:spPr>
           <a:xfrm>
-            <a:off x="9217152" y="5822441"/>
+            <a:off x="9217152" y="5452110"/>
             <a:ext cx="3803904" cy="1059561"/>
           </a:xfrm>
           <a:prstGeom prst="rect">
@@ -10265,7 +10265,7 @@
         </p:nvSpPr>
         <p:spPr>
           <a:xfrm>
-            <a:off x="9217152" y="5822441"/>
+            <a:off x="9217152" y="5452110"/>
             <a:ext cx="45720" cy="1059561"/>
           </a:xfrm>
           <a:prstGeom prst="rect">
@@ -10308,7 +10308,7 @@
         </p:nvSpPr>
         <p:spPr>
           <a:xfrm>
-            <a:off x="9336024" y="5915024"/>
+            <a:off x="9336024" y="5544693"/>
             <a:ext cx="3657600" cy="308610"/>
           </a:xfrm>
           <a:prstGeom prst="rect">
@@ -10343,7 +10343,7 @@
         </p:nvSpPr>
         <p:spPr>
           <a:xfrm>
-            <a:off x="9336024" y="6223634"/>
+            <a:off x="9336024" y="5853303"/>
             <a:ext cx="3657600" cy="411480"/>
           </a:xfrm>
           <a:prstGeom prst="rect">
@@ -10378,7 +10378,7 @@
         </p:nvSpPr>
         <p:spPr>
           <a:xfrm>
-            <a:off x="9336024" y="6624827"/>
+            <a:off x="9336024" y="6254496"/>
             <a:ext cx="3657600" cy="205740"/>
           </a:xfrm>
           <a:prstGeom prst="rect">
@@ -10413,7 +10413,7 @@
         </p:nvSpPr>
         <p:spPr>
           <a:xfrm>
-            <a:off x="13185648" y="5822441"/>
+            <a:off x="13185648" y="5452110"/>
             <a:ext cx="3803904" cy="1059561"/>
           </a:xfrm>
           <a:prstGeom prst="rect">
@@ -10456,7 +10456,7 @@
         </p:nvSpPr>
         <p:spPr>
           <a:xfrm>
-            <a:off x="13185648" y="5822441"/>
+            <a:off x="13185648" y="5452110"/>
             <a:ext cx="45720" cy="1059561"/>
           </a:xfrm>
           <a:prstGeom prst="rect">
@@ -10499,7 +10499,7 @@
         </p:nvSpPr>
         <p:spPr>
           <a:xfrm>
-            <a:off x="13304520" y="5915024"/>
+            <a:off x="13304520" y="5544693"/>
             <a:ext cx="3657600" cy="308610"/>
           </a:xfrm>
           <a:prstGeom prst="rect">
@@ -10534,7 +10534,7 @@
         </p:nvSpPr>
         <p:spPr>
           <a:xfrm>
-            <a:off x="13304520" y="6223634"/>
+            <a:off x="13304520" y="5853303"/>
             <a:ext cx="3657600" cy="411480"/>
           </a:xfrm>
           <a:prstGeom prst="rect">
@@ -10569,7 +10569,7 @@
         </p:nvSpPr>
         <p:spPr>
           <a:xfrm>
-            <a:off x="13304520" y="6624827"/>
+            <a:off x="13304520" y="6254496"/>
             <a:ext cx="3657600" cy="205740"/>
           </a:xfrm>
           <a:prstGeom prst="rect">
@@ -10604,7 +10604,7 @@
         </p:nvSpPr>
         <p:spPr>
           <a:xfrm>
-            <a:off x="1280160" y="6954011"/>
+            <a:off x="1280160" y="6583680"/>
             <a:ext cx="3803904" cy="1059561"/>
           </a:xfrm>
           <a:prstGeom prst="rect">
@@ -10647,7 +10647,7 @@
         </p:nvSpPr>
         <p:spPr>
           <a:xfrm>
-            <a:off x="1280160" y="6954011"/>
+            <a:off x="1280160" y="6583680"/>
             <a:ext cx="45720" cy="1059561"/>
           </a:xfrm>
           <a:prstGeom prst="rect">
@@ -10690,7 +10690,7 @@
         </p:nvSpPr>
         <p:spPr>
           <a:xfrm>
-            <a:off x="1399032" y="7046594"/>
+            <a:off x="1399032" y="6676263"/>
             <a:ext cx="3657600" cy="308610"/>
           </a:xfrm>
           <a:prstGeom prst="rect">
@@ -10725,7 +10725,7 @@
         </p:nvSpPr>
         <p:spPr>
           <a:xfrm>
-            <a:off x="1399032" y="7355204"/>
+            <a:off x="1399032" y="6984873"/>
             <a:ext cx="3657600" cy="411480"/>
           </a:xfrm>
           <a:prstGeom prst="rect">
@@ -10760,7 +10760,7 @@
         </p:nvSpPr>
         <p:spPr>
           <a:xfrm>
-            <a:off x="1399032" y="7756397"/>
+            <a:off x="1399032" y="7386066"/>
             <a:ext cx="3657600" cy="205740"/>
           </a:xfrm>
           <a:prstGeom prst="rect">
@@ -10795,7 +10795,7 @@
         </p:nvSpPr>
         <p:spPr>
           <a:xfrm>
-            <a:off x="5248656" y="6954011"/>
+            <a:off x="5248656" y="6583680"/>
             <a:ext cx="3803904" cy="1059561"/>
           </a:xfrm>
           <a:prstGeom prst="rect">
@@ -10838,7 +10838,7 @@
         </p:nvSpPr>
         <p:spPr>
           <a:xfrm>
-            <a:off x="5248656" y="6954011"/>
+            <a:off x="5248656" y="6583680"/>
             <a:ext cx="45720" cy="1059561"/>
           </a:xfrm>
           <a:prstGeom prst="rect">
@@ -10881,7 +10881,7 @@
         </p:nvSpPr>
         <p:spPr>
           <a:xfrm>
-            <a:off x="5367528" y="7046594"/>
+            <a:off x="5367528" y="6676263"/>
             <a:ext cx="3657600" cy="308610"/>
           </a:xfrm>
           <a:prstGeom prst="rect">
@@ -10916,7 +10916,7 @@
         </p:nvSpPr>
         <p:spPr>
           <a:xfrm>
-            <a:off x="5367528" y="7355204"/>
+            <a:off x="5367528" y="6984873"/>
             <a:ext cx="3657600" cy="411480"/>
           </a:xfrm>
           <a:prstGeom prst="rect">
@@ -10951,7 +10951,7 @@
         </p:nvSpPr>
         <p:spPr>
           <a:xfrm>
-            <a:off x="5367528" y="7756397"/>
+            <a:off x="5367528" y="7386066"/>
             <a:ext cx="3657600" cy="205740"/>
           </a:xfrm>
           <a:prstGeom prst="rect">
@@ -10986,7 +10986,7 @@
         </p:nvSpPr>
         <p:spPr>
           <a:xfrm>
-            <a:off x="9217152" y="6954011"/>
+            <a:off x="9217152" y="6583680"/>
             <a:ext cx="3803904" cy="1059561"/>
           </a:xfrm>
           <a:prstGeom prst="rect">
@@ -11029,7 +11029,7 @@
         </p:nvSpPr>
         <p:spPr>
           <a:xfrm>
-            <a:off x="9217152" y="6954011"/>
+            <a:off x="9217152" y="6583680"/>
             <a:ext cx="45720" cy="1059561"/>
           </a:xfrm>
           <a:prstGeom prst="rect">
@@ -11072,7 +11072,7 @@
         </p:nvSpPr>
         <p:spPr>
           <a:xfrm>
-            <a:off x="9336024" y="7046594"/>
+            <a:off x="9336024" y="6676263"/>
             <a:ext cx="3657600" cy="308610"/>
           </a:xfrm>
           <a:prstGeom prst="rect">
@@ -11107,7 +11107,7 @@
         </p:nvSpPr>
         <p:spPr>
           <a:xfrm>
-            <a:off x="9336024" y="7355204"/>
+            <a:off x="9336024" y="6984873"/>
             <a:ext cx="3657600" cy="411480"/>
           </a:xfrm>
           <a:prstGeom prst="rect">
@@ -11142,7 +11142,7 @@
         </p:nvSpPr>
         <p:spPr>
           <a:xfrm>
-            <a:off x="9336024" y="7756397"/>
+            <a:off x="9336024" y="7386066"/>
             <a:ext cx="3657600" cy="205740"/>
           </a:xfrm>
           <a:prstGeom prst="rect">
@@ -11177,7 +11177,7 @@
         </p:nvSpPr>
         <p:spPr>
           <a:xfrm>
-            <a:off x="13185648" y="6954011"/>
+            <a:off x="13185648" y="6583680"/>
             <a:ext cx="3803904" cy="1059561"/>
           </a:xfrm>
           <a:prstGeom prst="rect">
@@ -11220,7 +11220,7 @@
         </p:nvSpPr>
         <p:spPr>
           <a:xfrm>
-            <a:off x="13185648" y="6954011"/>
+            <a:off x="13185648" y="6583680"/>
             <a:ext cx="45720" cy="1059561"/>
           </a:xfrm>
           <a:prstGeom prst="rect">
@@ -11263,7 +11263,7 @@
         </p:nvSpPr>
         <p:spPr>
           <a:xfrm>
-            <a:off x="13304520" y="7046594"/>
+            <a:off x="13304520" y="6676263"/>
             <a:ext cx="3657600" cy="308610"/>
           </a:xfrm>
           <a:prstGeom prst="rect">
@@ -11298,7 +11298,7 @@
         </p:nvSpPr>
         <p:spPr>
           <a:xfrm>
-            <a:off x="13304520" y="7355204"/>
+            <a:off x="13304520" y="6984873"/>
             <a:ext cx="3657600" cy="411480"/>
           </a:xfrm>
           <a:prstGeom prst="rect">
@@ -11333,7 +11333,7 @@
         </p:nvSpPr>
         <p:spPr>
           <a:xfrm>
-            <a:off x="13304520" y="7756397"/>
+            <a:off x="13304520" y="7386066"/>
             <a:ext cx="3657600" cy="205740"/>
           </a:xfrm>
           <a:prstGeom prst="rect">
@@ -11550,7 +11550,7 @@
         </p:nvSpPr>
         <p:spPr>
           <a:xfrm>
-            <a:off x="1280160" y="1440180"/>
+            <a:off x="1280160" y="1028700"/>
             <a:ext cx="15727680" cy="1234440"/>
           </a:xfrm>
           <a:prstGeom prst="rect">
@@ -11585,8 +11585,8 @@
         </p:nvSpPr>
         <p:spPr>
           <a:xfrm>
-            <a:off x="1280160" y="2880360"/>
-            <a:ext cx="15727680" cy="617220"/>
+            <a:off x="1280160" y="2160270"/>
+            <a:ext cx="15727680" cy="565785"/>
           </a:xfrm>
           <a:prstGeom prst="rect">
             <a:avLst/>
@@ -11620,7 +11620,7 @@
         </p:nvCxnSpPr>
         <p:spPr>
           <a:xfrm>
-            <a:off x="1280160" y="3703320"/>
+            <a:off x="1280160" y="2880360"/>
             <a:ext cx="15727680" cy="0"/>
           </a:xfrm>
           <a:prstGeom prst="line">
@@ -11655,8 +11655,8 @@
         </p:nvSpPr>
         <p:spPr>
           <a:xfrm>
-            <a:off x="1280160" y="4011930"/>
-            <a:ext cx="5120640" cy="5760720"/>
+            <a:off x="1280160" y="3188970"/>
+            <a:ext cx="5120640" cy="5863589"/>
           </a:xfrm>
           <a:prstGeom prst="rect">
             <a:avLst/>
@@ -11698,8 +11698,8 @@
         </p:nvSpPr>
         <p:spPr>
           <a:xfrm>
-            <a:off x="1280160" y="4011930"/>
-            <a:ext cx="50292" cy="5760720"/>
+            <a:off x="1280160" y="3188970"/>
+            <a:ext cx="50292" cy="5863589"/>
           </a:xfrm>
           <a:prstGeom prst="rect">
             <a:avLst/>
@@ -11741,7 +11741,7 @@
         </p:nvSpPr>
         <p:spPr>
           <a:xfrm>
-            <a:off x="1444752" y="4063365"/>
+            <a:off x="1444752" y="3240405"/>
             <a:ext cx="1005840" cy="1131570"/>
           </a:xfrm>
           <a:prstGeom prst="rect">
@@ -11776,7 +11776,7 @@
         </p:nvSpPr>
         <p:spPr>
           <a:xfrm>
-            <a:off x="1444752" y="5246370"/>
+            <a:off x="1444752" y="4474845"/>
             <a:ext cx="4572000" cy="822960"/>
           </a:xfrm>
           <a:prstGeom prst="rect">
@@ -11812,7 +11812,7 @@
         </p:nvSpPr>
         <p:spPr>
           <a:xfrm>
-            <a:off x="1444752" y="6089904"/>
+            <a:off x="1444752" y="5318379"/>
             <a:ext cx="4572000" cy="617220"/>
           </a:xfrm>
           <a:prstGeom prst="rect">
@@ -11847,7 +11847,7 @@
         </p:nvSpPr>
         <p:spPr>
           <a:xfrm>
-            <a:off x="1444752" y="6737985"/>
+            <a:off x="1444752" y="5997321"/>
             <a:ext cx="4572000" cy="720090"/>
           </a:xfrm>
           <a:prstGeom prst="rect">
@@ -11882,7 +11882,7 @@
         </p:nvSpPr>
         <p:spPr>
           <a:xfrm>
-            <a:off x="1444752" y="7478649"/>
+            <a:off x="1444752" y="6665976"/>
             <a:ext cx="4572000" cy="1234440"/>
           </a:xfrm>
           <a:prstGeom prst="rect">
@@ -11917,7 +11917,7 @@
         </p:nvSpPr>
         <p:spPr>
           <a:xfrm>
-            <a:off x="1444752" y="8795385"/>
+            <a:off x="1444752" y="8126730"/>
             <a:ext cx="4572000" cy="720090"/>
           </a:xfrm>
           <a:prstGeom prst="rect">
@@ -11952,8 +11952,8 @@
         </p:nvSpPr>
         <p:spPr>
           <a:xfrm>
-            <a:off x="6949440" y="4011930"/>
-            <a:ext cx="5120640" cy="5760720"/>
+            <a:off x="6949440" y="3188970"/>
+            <a:ext cx="5120640" cy="5863589"/>
           </a:xfrm>
           <a:prstGeom prst="rect">
             <a:avLst/>
@@ -11995,8 +11995,8 @@
         </p:nvSpPr>
         <p:spPr>
           <a:xfrm>
-            <a:off x="6949440" y="4011930"/>
-            <a:ext cx="50292" cy="5760720"/>
+            <a:off x="6949440" y="3188970"/>
+            <a:ext cx="50292" cy="5863589"/>
           </a:xfrm>
           <a:prstGeom prst="rect">
             <a:avLst/>
@@ -12038,7 +12038,7 @@
         </p:nvSpPr>
         <p:spPr>
           <a:xfrm>
-            <a:off x="7114032" y="4063365"/>
+            <a:off x="7114032" y="3240405"/>
             <a:ext cx="1005840" cy="1131570"/>
           </a:xfrm>
           <a:prstGeom prst="rect">
@@ -12073,7 +12073,7 @@
         </p:nvSpPr>
         <p:spPr>
           <a:xfrm>
-            <a:off x="7114032" y="5246370"/>
+            <a:off x="7114032" y="4474845"/>
             <a:ext cx="4572000" cy="822960"/>
           </a:xfrm>
           <a:prstGeom prst="rect">
@@ -12109,7 +12109,7 @@
         </p:nvSpPr>
         <p:spPr>
           <a:xfrm>
-            <a:off x="7114032" y="6089904"/>
+            <a:off x="7114032" y="5318379"/>
             <a:ext cx="4572000" cy="617220"/>
           </a:xfrm>
           <a:prstGeom prst="rect">
@@ -12144,7 +12144,7 @@
         </p:nvSpPr>
         <p:spPr>
           <a:xfrm>
-            <a:off x="7114032" y="6737985"/>
+            <a:off x="7114032" y="5997321"/>
             <a:ext cx="4572000" cy="720090"/>
           </a:xfrm>
           <a:prstGeom prst="rect">
@@ -12179,7 +12179,7 @@
         </p:nvSpPr>
         <p:spPr>
           <a:xfrm>
-            <a:off x="7114032" y="7478649"/>
+            <a:off x="7114032" y="6665976"/>
             <a:ext cx="4572000" cy="1234440"/>
           </a:xfrm>
           <a:prstGeom prst="rect">
@@ -12214,7 +12214,7 @@
         </p:nvSpPr>
         <p:spPr>
           <a:xfrm>
-            <a:off x="7114032" y="8795385"/>
+            <a:off x="7114032" y="8126730"/>
             <a:ext cx="4572000" cy="720090"/>
           </a:xfrm>
           <a:prstGeom prst="rect">
@@ -12249,8 +12249,8 @@
         </p:nvSpPr>
         <p:spPr>
           <a:xfrm>
-            <a:off x="12618720" y="4011930"/>
-            <a:ext cx="5120640" cy="5760720"/>
+            <a:off x="12618720" y="3188970"/>
+            <a:ext cx="5120640" cy="5863589"/>
           </a:xfrm>
           <a:prstGeom prst="rect">
             <a:avLst/>
@@ -12292,8 +12292,8 @@
         </p:nvSpPr>
         <p:spPr>
           <a:xfrm>
-            <a:off x="12618720" y="4011930"/>
-            <a:ext cx="50292" cy="5760720"/>
+            <a:off x="12618720" y="3188970"/>
+            <a:ext cx="50292" cy="5863589"/>
           </a:xfrm>
           <a:prstGeom prst="rect">
             <a:avLst/>
@@ -12335,7 +12335,7 @@
         </p:nvSpPr>
         <p:spPr>
           <a:xfrm>
-            <a:off x="12783312" y="4063365"/>
+            <a:off x="12783312" y="3240405"/>
             <a:ext cx="1005840" cy="1131570"/>
           </a:xfrm>
           <a:prstGeom prst="rect">
@@ -12370,7 +12370,7 @@
         </p:nvSpPr>
         <p:spPr>
           <a:xfrm>
-            <a:off x="12783312" y="5246370"/>
+            <a:off x="12783312" y="4474845"/>
             <a:ext cx="4572000" cy="822960"/>
           </a:xfrm>
           <a:prstGeom prst="rect">
@@ -12406,7 +12406,7 @@
         </p:nvSpPr>
         <p:spPr>
           <a:xfrm>
-            <a:off x="12783312" y="6089904"/>
+            <a:off x="12783312" y="5318379"/>
             <a:ext cx="4572000" cy="617220"/>
           </a:xfrm>
           <a:prstGeom prst="rect">
@@ -12441,7 +12441,7 @@
         </p:nvSpPr>
         <p:spPr>
           <a:xfrm>
-            <a:off x="12783312" y="6737985"/>
+            <a:off x="12783312" y="5997321"/>
             <a:ext cx="4572000" cy="720090"/>
           </a:xfrm>
           <a:prstGeom prst="rect">
@@ -12476,7 +12476,7 @@
         </p:nvSpPr>
         <p:spPr>
           <a:xfrm>
-            <a:off x="12783312" y="7478649"/>
+            <a:off x="12783312" y="6665976"/>
             <a:ext cx="4572000" cy="1234440"/>
           </a:xfrm>
           <a:prstGeom prst="rect">
@@ -12511,7 +12511,7 @@
         </p:nvSpPr>
         <p:spPr>
           <a:xfrm>
-            <a:off x="12783312" y="8795385"/>
+            <a:off x="12783312" y="8126730"/>
             <a:ext cx="4572000" cy="720090"/>
           </a:xfrm>
           <a:prstGeom prst="rect">
@@ -12650,7 +12650,7 @@
         </p:nvSpPr>
         <p:spPr>
           <a:xfrm>
-            <a:off x="1280160" y="1440180"/>
+            <a:off x="1280160" y="1028700"/>
             <a:ext cx="15727680" cy="1234440"/>
           </a:xfrm>
           <a:prstGeom prst="rect">
@@ -12685,8 +12685,8 @@
         </p:nvSpPr>
         <p:spPr>
           <a:xfrm>
-            <a:off x="1280160" y="2880360"/>
-            <a:ext cx="15727680" cy="617220"/>
+            <a:off x="1280160" y="2160270"/>
+            <a:ext cx="15727680" cy="565785"/>
           </a:xfrm>
           <a:prstGeom prst="rect">
             <a:avLst/>
@@ -12720,7 +12720,7 @@
         </p:nvCxnSpPr>
         <p:spPr>
           <a:xfrm>
-            <a:off x="1280160" y="3703320"/>
+            <a:off x="1280160" y="2880360"/>
             <a:ext cx="15727680" cy="0"/>
           </a:xfrm>
           <a:prstGeom prst="line">
@@ -12755,8 +12755,8 @@
         </p:nvSpPr>
         <p:spPr>
           <a:xfrm>
-            <a:off x="1280160" y="3909060"/>
-            <a:ext cx="5212080" cy="1522476"/>
+            <a:off x="1280160" y="3188970"/>
+            <a:ext cx="5212080" cy="1954530"/>
           </a:xfrm>
           <a:prstGeom prst="rect">
             <a:avLst/>
@@ -12798,8 +12798,8 @@
         </p:nvSpPr>
         <p:spPr>
           <a:xfrm>
-            <a:off x="1280160" y="3909060"/>
-            <a:ext cx="50292" cy="1522476"/>
+            <a:off x="1280160" y="3188970"/>
+            <a:ext cx="50292" cy="1954530"/>
           </a:xfrm>
           <a:prstGeom prst="rect">
             <a:avLst/>
@@ -12841,7 +12841,7 @@
         </p:nvSpPr>
         <p:spPr>
           <a:xfrm>
-            <a:off x="1444752" y="4032504"/>
+            <a:off x="1444752" y="3312414"/>
             <a:ext cx="2194560" cy="411480"/>
           </a:xfrm>
           <a:prstGeom prst="rect">
@@ -12876,7 +12876,7 @@
         </p:nvSpPr>
         <p:spPr>
           <a:xfrm>
-            <a:off x="1444752" y="4485132"/>
+            <a:off x="1444752" y="3806190"/>
             <a:ext cx="4983480" cy="390906"/>
           </a:xfrm>
           <a:prstGeom prst="rect">
@@ -12911,8 +12911,8 @@
         </p:nvSpPr>
         <p:spPr>
           <a:xfrm>
-            <a:off x="1444752" y="4896612"/>
-            <a:ext cx="4983480" cy="493776"/>
+            <a:off x="1444752" y="4279392"/>
+            <a:ext cx="4983480" cy="781812"/>
           </a:xfrm>
           <a:prstGeom prst="rect">
             <a:avLst/>
@@ -12946,8 +12946,8 @@
         </p:nvSpPr>
         <p:spPr>
           <a:xfrm>
-            <a:off x="6547104" y="3909060"/>
-            <a:ext cx="5212080" cy="1522476"/>
+            <a:off x="6547104" y="3188970"/>
+            <a:ext cx="5212080" cy="1954530"/>
           </a:xfrm>
           <a:prstGeom prst="rect">
             <a:avLst/>
@@ -12989,8 +12989,8 @@
         </p:nvSpPr>
         <p:spPr>
           <a:xfrm>
-            <a:off x="6547104" y="3909060"/>
-            <a:ext cx="50292" cy="1522476"/>
+            <a:off x="6547104" y="3188970"/>
+            <a:ext cx="50292" cy="1954530"/>
           </a:xfrm>
           <a:prstGeom prst="rect">
             <a:avLst/>
@@ -13032,7 +13032,7 @@
         </p:nvSpPr>
         <p:spPr>
           <a:xfrm>
-            <a:off x="6711696" y="4032504"/>
+            <a:off x="6711696" y="3312414"/>
             <a:ext cx="2194560" cy="411480"/>
           </a:xfrm>
           <a:prstGeom prst="rect">
@@ -13067,7 +13067,7 @@
         </p:nvSpPr>
         <p:spPr>
           <a:xfrm>
-            <a:off x="6711696" y="4485132"/>
+            <a:off x="6711696" y="3806190"/>
             <a:ext cx="4983480" cy="390906"/>
           </a:xfrm>
           <a:prstGeom prst="rect">
@@ -13102,8 +13102,8 @@
         </p:nvSpPr>
         <p:spPr>
           <a:xfrm>
-            <a:off x="6711696" y="4896612"/>
-            <a:ext cx="4983480" cy="493776"/>
+            <a:off x="6711696" y="4279392"/>
+            <a:ext cx="4983480" cy="781812"/>
           </a:xfrm>
           <a:prstGeom prst="rect">
             <a:avLst/>
@@ -13137,8 +13137,8 @@
         </p:nvSpPr>
         <p:spPr>
           <a:xfrm>
-            <a:off x="11814048" y="3909060"/>
-            <a:ext cx="5212080" cy="1522476"/>
+            <a:off x="11814048" y="3188970"/>
+            <a:ext cx="5212080" cy="1954530"/>
           </a:xfrm>
           <a:prstGeom prst="rect">
             <a:avLst/>
@@ -13180,8 +13180,8 @@
         </p:nvSpPr>
         <p:spPr>
           <a:xfrm>
-            <a:off x="11814048" y="3909060"/>
-            <a:ext cx="50292" cy="1522476"/>
+            <a:off x="11814048" y="3188970"/>
+            <a:ext cx="50292" cy="1954530"/>
           </a:xfrm>
           <a:prstGeom prst="rect">
             <a:avLst/>
@@ -13223,7 +13223,7 @@
         </p:nvSpPr>
         <p:spPr>
           <a:xfrm>
-            <a:off x="11978640" y="4032504"/>
+            <a:off x="11978640" y="3312414"/>
             <a:ext cx="2194560" cy="411480"/>
           </a:xfrm>
           <a:prstGeom prst="rect">
@@ -13258,7 +13258,7 @@
         </p:nvSpPr>
         <p:spPr>
           <a:xfrm>
-            <a:off x="11978640" y="4485132"/>
+            <a:off x="11978640" y="3806190"/>
             <a:ext cx="4983480" cy="390906"/>
           </a:xfrm>
           <a:prstGeom prst="rect">
@@ -13293,8 +13293,8 @@
         </p:nvSpPr>
         <p:spPr>
           <a:xfrm>
-            <a:off x="11978640" y="4896612"/>
-            <a:ext cx="4983480" cy="493776"/>
+            <a:off x="11978640" y="4279392"/>
+            <a:ext cx="4983480" cy="781812"/>
           </a:xfrm>
           <a:prstGeom prst="rect">
             <a:avLst/>
@@ -13328,8 +13328,8 @@
         </p:nvSpPr>
         <p:spPr>
           <a:xfrm>
-            <a:off x="1280160" y="5554980"/>
-            <a:ext cx="5212080" cy="1522476"/>
+            <a:off x="1280160" y="5297805"/>
+            <a:ext cx="5212080" cy="1954530"/>
           </a:xfrm>
           <a:prstGeom prst="rect">
             <a:avLst/>
@@ -13371,8 +13371,8 @@
         </p:nvSpPr>
         <p:spPr>
           <a:xfrm>
-            <a:off x="1280160" y="5554980"/>
-            <a:ext cx="50292" cy="1522476"/>
+            <a:off x="1280160" y="5297805"/>
+            <a:ext cx="50292" cy="1954530"/>
           </a:xfrm>
           <a:prstGeom prst="rect">
             <a:avLst/>
@@ -13414,7 +13414,7 @@
         </p:nvSpPr>
         <p:spPr>
           <a:xfrm>
-            <a:off x="1444752" y="5678424"/>
+            <a:off x="1444752" y="5421249"/>
             <a:ext cx="2194560" cy="411480"/>
           </a:xfrm>
           <a:prstGeom prst="rect">
@@ -13449,7 +13449,7 @@
         </p:nvSpPr>
         <p:spPr>
           <a:xfrm>
-            <a:off x="1444752" y="6131052"/>
+            <a:off x="1444752" y="5915025"/>
             <a:ext cx="4983480" cy="390906"/>
           </a:xfrm>
           <a:prstGeom prst="rect">
@@ -13484,8 +13484,8 @@
         </p:nvSpPr>
         <p:spPr>
           <a:xfrm>
-            <a:off x="1444752" y="6542532"/>
-            <a:ext cx="4983480" cy="493776"/>
+            <a:off x="1444752" y="6388227"/>
+            <a:ext cx="4983480" cy="781812"/>
           </a:xfrm>
           <a:prstGeom prst="rect">
             <a:avLst/>
@@ -13519,8 +13519,8 @@
         </p:nvSpPr>
         <p:spPr>
           <a:xfrm>
-            <a:off x="6547104" y="5554980"/>
-            <a:ext cx="5212080" cy="1522476"/>
+            <a:off x="6547104" y="5297805"/>
+            <a:ext cx="5212080" cy="1954530"/>
           </a:xfrm>
           <a:prstGeom prst="rect">
             <a:avLst/>
@@ -13562,8 +13562,8 @@
         </p:nvSpPr>
         <p:spPr>
           <a:xfrm>
-            <a:off x="6547104" y="5554980"/>
-            <a:ext cx="50292" cy="1522476"/>
+            <a:off x="6547104" y="5297805"/>
+            <a:ext cx="50292" cy="1954530"/>
           </a:xfrm>
           <a:prstGeom prst="rect">
             <a:avLst/>
@@ -13605,7 +13605,7 @@
         </p:nvSpPr>
         <p:spPr>
           <a:xfrm>
-            <a:off x="6711696" y="5678424"/>
+            <a:off x="6711696" y="5421249"/>
             <a:ext cx="2194560" cy="411480"/>
           </a:xfrm>
           <a:prstGeom prst="rect">
@@ -13640,7 +13640,7 @@
         </p:nvSpPr>
         <p:spPr>
           <a:xfrm>
-            <a:off x="6711696" y="6131052"/>
+            <a:off x="6711696" y="5915025"/>
             <a:ext cx="4983480" cy="390906"/>
           </a:xfrm>
           <a:prstGeom prst="rect">
@@ -13675,8 +13675,8 @@
         </p:nvSpPr>
         <p:spPr>
           <a:xfrm>
-            <a:off x="6711696" y="6542532"/>
-            <a:ext cx="4983480" cy="493776"/>
+            <a:off x="6711696" y="6388227"/>
+            <a:ext cx="4983480" cy="781812"/>
           </a:xfrm>
           <a:prstGeom prst="rect">
             <a:avLst/>
@@ -13710,8 +13710,8 @@
         </p:nvSpPr>
         <p:spPr>
           <a:xfrm>
-            <a:off x="11814048" y="5554980"/>
-            <a:ext cx="5212080" cy="1522476"/>
+            <a:off x="11814048" y="5297805"/>
+            <a:ext cx="5212080" cy="1954530"/>
           </a:xfrm>
           <a:prstGeom prst="rect">
             <a:avLst/>
@@ -13753,8 +13753,8 @@
         </p:nvSpPr>
         <p:spPr>
           <a:xfrm>
-            <a:off x="11814048" y="5554980"/>
-            <a:ext cx="50292" cy="1522476"/>
+            <a:off x="11814048" y="5297805"/>
+            <a:ext cx="50292" cy="1954530"/>
           </a:xfrm>
           <a:prstGeom prst="rect">
             <a:avLst/>
@@ -13796,7 +13796,7 @@
         </p:nvSpPr>
         <p:spPr>
           <a:xfrm>
-            <a:off x="11978640" y="5678424"/>
+            <a:off x="11978640" y="5421249"/>
             <a:ext cx="2194560" cy="411480"/>
           </a:xfrm>
           <a:prstGeom prst="rect">
@@ -13831,7 +13831,7 @@
         </p:nvSpPr>
         <p:spPr>
           <a:xfrm>
-            <a:off x="11978640" y="6131052"/>
+            <a:off x="11978640" y="5915025"/>
             <a:ext cx="4983480" cy="390906"/>
           </a:xfrm>
           <a:prstGeom prst="rect">
@@ -13866,8 +13866,8 @@
         </p:nvSpPr>
         <p:spPr>
           <a:xfrm>
-            <a:off x="11978640" y="6542532"/>
-            <a:ext cx="4983480" cy="493776"/>
+            <a:off x="11978640" y="6388227"/>
+            <a:ext cx="4983480" cy="781812"/>
           </a:xfrm>
           <a:prstGeom prst="rect">
             <a:avLst/>
@@ -14083,7 +14083,7 @@
         </p:nvSpPr>
         <p:spPr>
           <a:xfrm>
-            <a:off x="1280160" y="1440180"/>
+            <a:off x="1280160" y="1028700"/>
             <a:ext cx="15727680" cy="1234440"/>
           </a:xfrm>
           <a:prstGeom prst="rect">
@@ -14118,8 +14118,8 @@
         </p:nvSpPr>
         <p:spPr>
           <a:xfrm>
-            <a:off x="1280160" y="2880360"/>
-            <a:ext cx="15727680" cy="617220"/>
+            <a:off x="1280160" y="2160270"/>
+            <a:ext cx="15727680" cy="565785"/>
           </a:xfrm>
           <a:prstGeom prst="rect">
             <a:avLst/>
@@ -14153,7 +14153,7 @@
         </p:nvCxnSpPr>
         <p:spPr>
           <a:xfrm>
-            <a:off x="1280160" y="3703320"/>
+            <a:off x="1280160" y="2880360"/>
             <a:ext cx="15727680" cy="0"/>
           </a:xfrm>
           <a:prstGeom prst="line">
@@ -14188,8 +14188,8 @@
         </p:nvSpPr>
         <p:spPr>
           <a:xfrm>
-            <a:off x="1280160" y="3909060"/>
-            <a:ext cx="7863840" cy="2777490"/>
+            <a:off x="1280160" y="3188970"/>
+            <a:ext cx="7863840" cy="3086100"/>
           </a:xfrm>
           <a:prstGeom prst="rect">
             <a:avLst/>
@@ -14231,8 +14231,8 @@
         </p:nvSpPr>
         <p:spPr>
           <a:xfrm>
-            <a:off x="1280160" y="3909060"/>
-            <a:ext cx="50292" cy="2777490"/>
+            <a:off x="1280160" y="3188970"/>
+            <a:ext cx="50292" cy="3086100"/>
           </a:xfrm>
           <a:prstGeom prst="rect">
             <a:avLst/>
@@ -14274,8 +14274,8 @@
         </p:nvSpPr>
         <p:spPr>
           <a:xfrm>
-            <a:off x="1444752" y="4042791"/>
-            <a:ext cx="7635240" cy="699516"/>
+            <a:off x="1444752" y="3322701"/>
+            <a:ext cx="7635240" cy="740664"/>
           </a:xfrm>
           <a:prstGeom prst="rect">
             <a:avLst/>
@@ -14310,7 +14310,7 @@
         </p:nvSpPr>
         <p:spPr>
           <a:xfrm>
-            <a:off x="1444752" y="4762881"/>
+            <a:off x="1444752" y="4114800"/>
             <a:ext cx="7635240" cy="462915"/>
           </a:xfrm>
           <a:prstGeom prst="rect">
@@ -14345,7 +14345,7 @@
         </p:nvSpPr>
         <p:spPr>
           <a:xfrm>
-            <a:off x="1444752" y="5297805"/>
+            <a:off x="1444752" y="4577715"/>
             <a:ext cx="7635240" cy="329184"/>
           </a:xfrm>
           <a:prstGeom prst="rect">
@@ -14380,7 +14380,7 @@
         </p:nvSpPr>
         <p:spPr>
           <a:xfrm>
-            <a:off x="1444752" y="5637276"/>
+            <a:off x="1444752" y="4917186"/>
             <a:ext cx="7635240" cy="329184"/>
           </a:xfrm>
           <a:prstGeom prst="rect">
@@ -14415,7 +14415,7 @@
         </p:nvSpPr>
         <p:spPr>
           <a:xfrm>
-            <a:off x="1444752" y="5976747"/>
+            <a:off x="1444752" y="5256657"/>
             <a:ext cx="7635240" cy="329184"/>
           </a:xfrm>
           <a:prstGeom prst="rect">
@@ -14450,7 +14450,7 @@
         </p:nvSpPr>
         <p:spPr>
           <a:xfrm>
-            <a:off x="1444752" y="6316218"/>
+            <a:off x="1444752" y="5596128"/>
             <a:ext cx="7635240" cy="329184"/>
           </a:xfrm>
           <a:prstGeom prst="rect">
@@ -14485,8 +14485,8 @@
         </p:nvSpPr>
         <p:spPr>
           <a:xfrm>
-            <a:off x="9875520" y="3909060"/>
-            <a:ext cx="7863840" cy="2777490"/>
+            <a:off x="9875520" y="3188970"/>
+            <a:ext cx="7863840" cy="3086100"/>
           </a:xfrm>
           <a:prstGeom prst="rect">
             <a:avLst/>
@@ -14528,8 +14528,8 @@
         </p:nvSpPr>
         <p:spPr>
           <a:xfrm>
-            <a:off x="9875520" y="3909060"/>
-            <a:ext cx="50292" cy="2777490"/>
+            <a:off x="9875520" y="3188970"/>
+            <a:ext cx="50292" cy="3086100"/>
           </a:xfrm>
           <a:prstGeom prst="rect">
             <a:avLst/>
@@ -14571,8 +14571,8 @@
         </p:nvSpPr>
         <p:spPr>
           <a:xfrm>
-            <a:off x="10040112" y="4042791"/>
-            <a:ext cx="7635240" cy="699516"/>
+            <a:off x="10040112" y="3322701"/>
+            <a:ext cx="7635240" cy="740664"/>
           </a:xfrm>
           <a:prstGeom prst="rect">
             <a:avLst/>
@@ -14607,7 +14607,7 @@
         </p:nvSpPr>
         <p:spPr>
           <a:xfrm>
-            <a:off x="10040112" y="4762881"/>
+            <a:off x="10040112" y="4114800"/>
             <a:ext cx="7635240" cy="462915"/>
           </a:xfrm>
           <a:prstGeom prst="rect">
@@ -14642,7 +14642,7 @@
         </p:nvSpPr>
         <p:spPr>
           <a:xfrm>
-            <a:off x="10040112" y="5297805"/>
+            <a:off x="10040112" y="4577715"/>
             <a:ext cx="7635240" cy="329184"/>
           </a:xfrm>
           <a:prstGeom prst="rect">
@@ -14677,7 +14677,7 @@
         </p:nvSpPr>
         <p:spPr>
           <a:xfrm>
-            <a:off x="10040112" y="5637276"/>
+            <a:off x="10040112" y="4917186"/>
             <a:ext cx="7635240" cy="329184"/>
           </a:xfrm>
           <a:prstGeom prst="rect">
@@ -14712,7 +14712,7 @@
         </p:nvSpPr>
         <p:spPr>
           <a:xfrm>
-            <a:off x="10040112" y="5976747"/>
+            <a:off x="10040112" y="5256657"/>
             <a:ext cx="7635240" cy="329184"/>
           </a:xfrm>
           <a:prstGeom prst="rect">
@@ -14747,7 +14747,7 @@
         </p:nvSpPr>
         <p:spPr>
           <a:xfrm>
-            <a:off x="10040112" y="6316218"/>
+            <a:off x="10040112" y="5596128"/>
             <a:ext cx="7635240" cy="329184"/>
           </a:xfrm>
           <a:prstGeom prst="rect">
@@ -14782,8 +14782,8 @@
         </p:nvSpPr>
         <p:spPr>
           <a:xfrm>
-            <a:off x="1280160" y="6892290"/>
-            <a:ext cx="7863840" cy="2777490"/>
+            <a:off x="1280160" y="6480810"/>
+            <a:ext cx="7863840" cy="3086100"/>
           </a:xfrm>
           <a:prstGeom prst="rect">
             <a:avLst/>
@@ -14825,8 +14825,8 @@
         </p:nvSpPr>
         <p:spPr>
           <a:xfrm>
-            <a:off x="1280160" y="6892290"/>
-            <a:ext cx="50292" cy="2777490"/>
+            <a:off x="1280160" y="6480810"/>
+            <a:ext cx="50292" cy="3086100"/>
           </a:xfrm>
           <a:prstGeom prst="rect">
             <a:avLst/>
@@ -14868,8 +14868,8 @@
         </p:nvSpPr>
         <p:spPr>
           <a:xfrm>
-            <a:off x="1444752" y="7026021"/>
-            <a:ext cx="7635240" cy="699516"/>
+            <a:off x="1444752" y="6614541"/>
+            <a:ext cx="7635240" cy="740664"/>
           </a:xfrm>
           <a:prstGeom prst="rect">
             <a:avLst/>
@@ -14904,7 +14904,7 @@
         </p:nvSpPr>
         <p:spPr>
           <a:xfrm>
-            <a:off x="1444752" y="7746111"/>
+            <a:off x="1444752" y="7406640"/>
             <a:ext cx="7635240" cy="462915"/>
           </a:xfrm>
           <a:prstGeom prst="rect">
@@ -14939,7 +14939,7 @@
         </p:nvSpPr>
         <p:spPr>
           <a:xfrm>
-            <a:off x="1444752" y="8281035"/>
+            <a:off x="1444752" y="7869555"/>
             <a:ext cx="7635240" cy="329184"/>
           </a:xfrm>
           <a:prstGeom prst="rect">
@@ -14974,7 +14974,7 @@
         </p:nvSpPr>
         <p:spPr>
           <a:xfrm>
-            <a:off x="1444752" y="8620506"/>
+            <a:off x="1444752" y="8209026"/>
             <a:ext cx="7635240" cy="329184"/>
           </a:xfrm>
           <a:prstGeom prst="rect">
@@ -15009,7 +15009,7 @@
         </p:nvSpPr>
         <p:spPr>
           <a:xfrm>
-            <a:off x="1444752" y="8959977"/>
+            <a:off x="1444752" y="8548497"/>
             <a:ext cx="7635240" cy="329184"/>
           </a:xfrm>
           <a:prstGeom prst="rect">
@@ -15044,7 +15044,7 @@
         </p:nvSpPr>
         <p:spPr>
           <a:xfrm>
-            <a:off x="1444752" y="9299448"/>
+            <a:off x="1444752" y="8887968"/>
             <a:ext cx="7635240" cy="329184"/>
           </a:xfrm>
           <a:prstGeom prst="rect">
@@ -15079,8 +15079,8 @@
         </p:nvSpPr>
         <p:spPr>
           <a:xfrm>
-            <a:off x="9875520" y="6892290"/>
-            <a:ext cx="7863840" cy="2777490"/>
+            <a:off x="9875520" y="6480810"/>
+            <a:ext cx="7863840" cy="3086100"/>
           </a:xfrm>
           <a:prstGeom prst="rect">
             <a:avLst/>
@@ -15122,8 +15122,8 @@
         </p:nvSpPr>
         <p:spPr>
           <a:xfrm>
-            <a:off x="9875520" y="6892290"/>
-            <a:ext cx="50292" cy="2777490"/>
+            <a:off x="9875520" y="6480810"/>
+            <a:ext cx="50292" cy="3086100"/>
           </a:xfrm>
           <a:prstGeom prst="rect">
             <a:avLst/>
@@ -15165,8 +15165,8 @@
         </p:nvSpPr>
         <p:spPr>
           <a:xfrm>
-            <a:off x="10040112" y="7026021"/>
-            <a:ext cx="7635240" cy="699516"/>
+            <a:off x="10040112" y="6614541"/>
+            <a:ext cx="7635240" cy="740664"/>
           </a:xfrm>
           <a:prstGeom prst="rect">
             <a:avLst/>
@@ -15201,7 +15201,7 @@
         </p:nvSpPr>
         <p:spPr>
           <a:xfrm>
-            <a:off x="10040112" y="7746111"/>
+            <a:off x="10040112" y="7406640"/>
             <a:ext cx="7635240" cy="462915"/>
           </a:xfrm>
           <a:prstGeom prst="rect">
@@ -15236,7 +15236,7 @@
         </p:nvSpPr>
         <p:spPr>
           <a:xfrm>
-            <a:off x="10040112" y="8281035"/>
+            <a:off x="10040112" y="7869555"/>
             <a:ext cx="7635240" cy="329184"/>
           </a:xfrm>
           <a:prstGeom prst="rect">
@@ -15271,7 +15271,7 @@
         </p:nvSpPr>
         <p:spPr>
           <a:xfrm>
-            <a:off x="10040112" y="8620506"/>
+            <a:off x="10040112" y="8209026"/>
             <a:ext cx="7635240" cy="329184"/>
           </a:xfrm>
           <a:prstGeom prst="rect">
@@ -15306,7 +15306,7 @@
         </p:nvSpPr>
         <p:spPr>
           <a:xfrm>
-            <a:off x="10040112" y="8959977"/>
+            <a:off x="10040112" y="8548497"/>
             <a:ext cx="7635240" cy="329184"/>
           </a:xfrm>
           <a:prstGeom prst="rect">
@@ -15341,7 +15341,7 @@
         </p:nvSpPr>
         <p:spPr>
           <a:xfrm>
-            <a:off x="10040112" y="9299448"/>
+            <a:off x="10040112" y="8887968"/>
             <a:ext cx="7635240" cy="329184"/>
           </a:xfrm>
           <a:prstGeom prst="rect">
@@ -15480,7 +15480,7 @@
         </p:nvSpPr>
         <p:spPr>
           <a:xfrm>
-            <a:off x="1280160" y="1440180"/>
+            <a:off x="1280160" y="1028700"/>
             <a:ext cx="15727680" cy="1234440"/>
           </a:xfrm>
           <a:prstGeom prst="rect">
@@ -15515,8 +15515,8 @@
         </p:nvSpPr>
         <p:spPr>
           <a:xfrm>
-            <a:off x="1280160" y="2880360"/>
-            <a:ext cx="15727680" cy="617220"/>
+            <a:off x="1280160" y="2160270"/>
+            <a:ext cx="15727680" cy="565785"/>
           </a:xfrm>
           <a:prstGeom prst="rect">
             <a:avLst/>
@@ -15550,7 +15550,7 @@
         </p:nvCxnSpPr>
         <p:spPr>
           <a:xfrm>
-            <a:off x="1280160" y="3703320"/>
+            <a:off x="1280160" y="2880360"/>
             <a:ext cx="15727680" cy="0"/>
           </a:xfrm>
           <a:prstGeom prst="line">
@@ -15585,8 +15585,8 @@
         </p:nvSpPr>
         <p:spPr>
           <a:xfrm>
-            <a:off x="1280160" y="3909060"/>
-            <a:ext cx="7680960" cy="2571750"/>
+            <a:off x="1280160" y="3188970"/>
+            <a:ext cx="7680960" cy="2777490"/>
           </a:xfrm>
           <a:prstGeom prst="rect">
             <a:avLst/>
@@ -15628,8 +15628,8 @@
         </p:nvSpPr>
         <p:spPr>
           <a:xfrm>
-            <a:off x="1280160" y="3909060"/>
-            <a:ext cx="50292" cy="2571750"/>
+            <a:off x="1280160" y="3188970"/>
+            <a:ext cx="50292" cy="2777490"/>
           </a:xfrm>
           <a:prstGeom prst="rect">
             <a:avLst/>
@@ -15671,7 +15671,7 @@
         </p:nvSpPr>
         <p:spPr>
           <a:xfrm>
-            <a:off x="1444752" y="4032504"/>
+            <a:off x="1444752" y="3312414"/>
             <a:ext cx="822960" cy="925830"/>
           </a:xfrm>
           <a:prstGeom prst="rect">
@@ -15706,7 +15706,7 @@
         </p:nvSpPr>
         <p:spPr>
           <a:xfrm>
-            <a:off x="2130552" y="4032504"/>
+            <a:off x="2130552" y="3312414"/>
             <a:ext cx="6675120" cy="720090"/>
           </a:xfrm>
           <a:prstGeom prst="rect">
@@ -15741,7 +15741,7 @@
         </p:nvSpPr>
         <p:spPr>
           <a:xfrm>
-            <a:off x="1444752" y="5040630"/>
+            <a:off x="1444752" y="4320540"/>
             <a:ext cx="7452360" cy="617220"/>
           </a:xfrm>
           <a:prstGeom prst="rect">
@@ -15776,7 +15776,7 @@
         </p:nvSpPr>
         <p:spPr>
           <a:xfrm>
-            <a:off x="1444752" y="5657850"/>
+            <a:off x="1444752" y="4937760"/>
             <a:ext cx="7452360" cy="720090"/>
           </a:xfrm>
           <a:prstGeom prst="rect">
@@ -15811,8 +15811,8 @@
         </p:nvSpPr>
         <p:spPr>
           <a:xfrm>
-            <a:off x="9875520" y="3909060"/>
-            <a:ext cx="7680960" cy="2571750"/>
+            <a:off x="9875520" y="3188970"/>
+            <a:ext cx="7680960" cy="2777490"/>
           </a:xfrm>
           <a:prstGeom prst="rect">
             <a:avLst/>
@@ -15854,8 +15854,8 @@
         </p:nvSpPr>
         <p:spPr>
           <a:xfrm>
-            <a:off x="9875520" y="3909060"/>
-            <a:ext cx="50292" cy="2571750"/>
+            <a:off x="9875520" y="3188970"/>
+            <a:ext cx="50292" cy="2777490"/>
           </a:xfrm>
           <a:prstGeom prst="rect">
             <a:avLst/>
@@ -15897,7 +15897,7 @@
         </p:nvSpPr>
         <p:spPr>
           <a:xfrm>
-            <a:off x="10040112" y="4032504"/>
+            <a:off x="10040112" y="3312414"/>
             <a:ext cx="822960" cy="925830"/>
           </a:xfrm>
           <a:prstGeom prst="rect">
@@ -15932,7 +15932,7 @@
         </p:nvSpPr>
         <p:spPr>
           <a:xfrm>
-            <a:off x="10725912" y="4032504"/>
+            <a:off x="10725912" y="3312414"/>
             <a:ext cx="6675120" cy="720090"/>
           </a:xfrm>
           <a:prstGeom prst="rect">
@@ -15967,7 +15967,7 @@
         </p:nvSpPr>
         <p:spPr>
           <a:xfrm>
-            <a:off x="10040112" y="5040630"/>
+            <a:off x="10040112" y="4320540"/>
             <a:ext cx="7452360" cy="617220"/>
           </a:xfrm>
           <a:prstGeom prst="rect">
@@ -16002,7 +16002,7 @@
         </p:nvSpPr>
         <p:spPr>
           <a:xfrm>
-            <a:off x="10040112" y="5657850"/>
+            <a:off x="10040112" y="4937760"/>
             <a:ext cx="7452360" cy="720090"/>
           </a:xfrm>
           <a:prstGeom prst="rect">
@@ -16037,8 +16037,8 @@
         </p:nvSpPr>
         <p:spPr>
           <a:xfrm>
-            <a:off x="1280160" y="6686550"/>
-            <a:ext cx="7680960" cy="2571750"/>
+            <a:off x="1280160" y="6172200"/>
+            <a:ext cx="7680960" cy="2777490"/>
           </a:xfrm>
           <a:prstGeom prst="rect">
             <a:avLst/>
@@ -16080,8 +16080,8 @@
         </p:nvSpPr>
         <p:spPr>
           <a:xfrm>
-            <a:off x="1280160" y="6686550"/>
-            <a:ext cx="50292" cy="2571750"/>
+            <a:off x="1280160" y="6172200"/>
+            <a:ext cx="50292" cy="2777490"/>
           </a:xfrm>
           <a:prstGeom prst="rect">
             <a:avLst/>
@@ -16123,7 +16123,7 @@
         </p:nvSpPr>
         <p:spPr>
           <a:xfrm>
-            <a:off x="1444752" y="6809994"/>
+            <a:off x="1444752" y="6295644"/>
             <a:ext cx="822960" cy="925830"/>
           </a:xfrm>
           <a:prstGeom prst="rect">
@@ -16158,7 +16158,7 @@
         </p:nvSpPr>
         <p:spPr>
           <a:xfrm>
-            <a:off x="2130552" y="6809994"/>
+            <a:off x="2130552" y="6295644"/>
             <a:ext cx="6675120" cy="720090"/>
           </a:xfrm>
           <a:prstGeom prst="rect">
@@ -16193,7 +16193,7 @@
         </p:nvSpPr>
         <p:spPr>
           <a:xfrm>
-            <a:off x="1444752" y="7818120"/>
+            <a:off x="1444752" y="7303770"/>
             <a:ext cx="7452360" cy="617220"/>
           </a:xfrm>
           <a:prstGeom prst="rect">
@@ -16228,7 +16228,7 @@
         </p:nvSpPr>
         <p:spPr>
           <a:xfrm>
-            <a:off x="1444752" y="8435340"/>
+            <a:off x="1444752" y="7920990"/>
             <a:ext cx="7452360" cy="720090"/>
           </a:xfrm>
           <a:prstGeom prst="rect">
@@ -16263,8 +16263,8 @@
         </p:nvSpPr>
         <p:spPr>
           <a:xfrm>
-            <a:off x="9875520" y="6686550"/>
-            <a:ext cx="7680960" cy="2571750"/>
+            <a:off x="9875520" y="6172200"/>
+            <a:ext cx="7680960" cy="2777490"/>
           </a:xfrm>
           <a:prstGeom prst="rect">
             <a:avLst/>
@@ -16306,8 +16306,8 @@
         </p:nvSpPr>
         <p:spPr>
           <a:xfrm>
-            <a:off x="9875520" y="6686550"/>
-            <a:ext cx="50292" cy="2571750"/>
+            <a:off x="9875520" y="6172200"/>
+            <a:ext cx="50292" cy="2777490"/>
           </a:xfrm>
           <a:prstGeom prst="rect">
             <a:avLst/>
@@ -16349,7 +16349,7 @@
         </p:nvSpPr>
         <p:spPr>
           <a:xfrm>
-            <a:off x="10040112" y="6809994"/>
+            <a:off x="10040112" y="6295644"/>
             <a:ext cx="822960" cy="925830"/>
           </a:xfrm>
           <a:prstGeom prst="rect">
@@ -16384,7 +16384,7 @@
         </p:nvSpPr>
         <p:spPr>
           <a:xfrm>
-            <a:off x="10725912" y="6809994"/>
+            <a:off x="10725912" y="6295644"/>
             <a:ext cx="6675120" cy="720090"/>
           </a:xfrm>
           <a:prstGeom prst="rect">
@@ -16419,7 +16419,7 @@
         </p:nvSpPr>
         <p:spPr>
           <a:xfrm>
-            <a:off x="10040112" y="7818120"/>
+            <a:off x="10040112" y="7303770"/>
             <a:ext cx="7452360" cy="617220"/>
           </a:xfrm>
           <a:prstGeom prst="rect">
@@ -16454,7 +16454,7 @@
         </p:nvSpPr>
         <p:spPr>
           <a:xfrm>
-            <a:off x="10040112" y="8435340"/>
+            <a:off x="10040112" y="7920990"/>
             <a:ext cx="7452360" cy="720090"/>
           </a:xfrm>
           <a:prstGeom prst="rect">
@@ -17781,7 +17781,7 @@
         </p:nvSpPr>
         <p:spPr>
           <a:xfrm>
-            <a:off x="1280160" y="1440180"/>
+            <a:off x="1280160" y="1028700"/>
             <a:ext cx="15727680" cy="1234440"/>
           </a:xfrm>
           <a:prstGeom prst="rect">
@@ -18629,7 +18629,7 @@
         </p:nvSpPr>
         <p:spPr>
           <a:xfrm>
-            <a:off x="1280160" y="1440180"/>
+            <a:off x="1280160" y="1028700"/>
             <a:ext cx="15727680" cy="1234440"/>
           </a:xfrm>
           <a:prstGeom prst="rect">
@@ -18664,8 +18664,8 @@
         </p:nvSpPr>
         <p:spPr>
           <a:xfrm>
-            <a:off x="1280160" y="2880360"/>
-            <a:ext cx="15727680" cy="617220"/>
+            <a:off x="1280160" y="2160270"/>
+            <a:ext cx="15727680" cy="565785"/>
           </a:xfrm>
           <a:prstGeom prst="rect">
             <a:avLst/>
@@ -19822,7 +19822,7 @@
         </p:nvSpPr>
         <p:spPr>
           <a:xfrm>
-            <a:off x="1280160" y="1440180"/>
+            <a:off x="1280160" y="1028700"/>
             <a:ext cx="15727680" cy="1131570"/>
           </a:xfrm>
           <a:prstGeom prst="rect">
@@ -20005,8 +20005,8 @@
         </p:nvSpPr>
         <p:spPr>
           <a:xfrm>
-            <a:off x="1280160" y="4937760"/>
-            <a:ext cx="50292" cy="3909060"/>
+            <a:off x="1280160" y="4217670"/>
+            <a:ext cx="50292" cy="4834890"/>
           </a:xfrm>
           <a:prstGeom prst="rect">
             <a:avLst/>
@@ -20048,7 +20048,7 @@
         </p:nvSpPr>
         <p:spPr>
           <a:xfrm>
-            <a:off x="1444752" y="5040630"/>
+            <a:off x="1444752" y="4320540"/>
             <a:ext cx="1005840" cy="1131570"/>
           </a:xfrm>
           <a:prstGeom prst="rect">
@@ -20083,7 +20083,7 @@
         </p:nvSpPr>
         <p:spPr>
           <a:xfrm>
-            <a:off x="1444752" y="6275070"/>
+            <a:off x="1444752" y="5554980"/>
             <a:ext cx="4572000" cy="720090"/>
           </a:xfrm>
           <a:prstGeom prst="rect">
@@ -20118,8 +20118,8 @@
         </p:nvSpPr>
         <p:spPr>
           <a:xfrm>
-            <a:off x="1444752" y="7098029"/>
-            <a:ext cx="4572000" cy="1543050"/>
+            <a:off x="1444752" y="6377940"/>
+            <a:ext cx="4572000" cy="2263140"/>
           </a:xfrm>
           <a:prstGeom prst="rect">
             <a:avLst/>
@@ -20196,8 +20196,8 @@
         </p:nvSpPr>
         <p:spPr>
           <a:xfrm>
-            <a:off x="6949440" y="4937760"/>
-            <a:ext cx="50292" cy="3909060"/>
+            <a:off x="6949440" y="4217670"/>
+            <a:ext cx="50292" cy="4834890"/>
           </a:xfrm>
           <a:prstGeom prst="rect">
             <a:avLst/>
@@ -20239,7 +20239,7 @@
         </p:nvSpPr>
         <p:spPr>
           <a:xfrm>
-            <a:off x="7114032" y="5040630"/>
+            <a:off x="7114032" y="4320540"/>
             <a:ext cx="1005840" cy="1131570"/>
           </a:xfrm>
           <a:prstGeom prst="rect">
@@ -20274,7 +20274,7 @@
         </p:nvSpPr>
         <p:spPr>
           <a:xfrm>
-            <a:off x="7114032" y="6275070"/>
+            <a:off x="7114032" y="5554980"/>
             <a:ext cx="4572000" cy="720090"/>
           </a:xfrm>
           <a:prstGeom prst="rect">
@@ -20309,8 +20309,8 @@
         </p:nvSpPr>
         <p:spPr>
           <a:xfrm>
-            <a:off x="7114032" y="7098029"/>
-            <a:ext cx="4572000" cy="1543050"/>
+            <a:off x="7114032" y="6377940"/>
+            <a:ext cx="4572000" cy="2263140"/>
           </a:xfrm>
           <a:prstGeom prst="rect">
             <a:avLst/>
@@ -20387,8 +20387,8 @@
         </p:nvSpPr>
         <p:spPr>
           <a:xfrm>
-            <a:off x="12618720" y="4937760"/>
-            <a:ext cx="50292" cy="3909060"/>
+            <a:off x="12618720" y="4217670"/>
+            <a:ext cx="50292" cy="4834890"/>
           </a:xfrm>
           <a:prstGeom prst="rect">
             <a:avLst/>
@@ -20430,7 +20430,7 @@
         </p:nvSpPr>
         <p:spPr>
           <a:xfrm>
-            <a:off x="12783312" y="5040630"/>
+            <a:off x="12783312" y="4320540"/>
             <a:ext cx="1005840" cy="1131570"/>
           </a:xfrm>
           <a:prstGeom prst="rect">
@@ -20465,7 +20465,7 @@
         </p:nvSpPr>
         <p:spPr>
           <a:xfrm>
-            <a:off x="12783312" y="6275070"/>
+            <a:off x="12783312" y="5554980"/>
             <a:ext cx="4572000" cy="720090"/>
           </a:xfrm>
           <a:prstGeom prst="rect">
@@ -20500,8 +20500,8 @@
         </p:nvSpPr>
         <p:spPr>
           <a:xfrm>
-            <a:off x="12783312" y="7098029"/>
-            <a:ext cx="4572000" cy="1543050"/>
+            <a:off x="12783312" y="6377940"/>
+            <a:ext cx="4572000" cy="2263140"/>
           </a:xfrm>
           <a:prstGeom prst="rect">
             <a:avLst/>
@@ -20717,7 +20717,7 @@
         </p:nvSpPr>
         <p:spPr>
           <a:xfrm>
-            <a:off x="1280160" y="1440180"/>
+            <a:off x="1280160" y="1028700"/>
             <a:ext cx="15727680" cy="1234440"/>
           </a:xfrm>
           <a:prstGeom prst="rect">
@@ -20752,8 +20752,8 @@
         </p:nvSpPr>
         <p:spPr>
           <a:xfrm>
-            <a:off x="1280160" y="2880360"/>
-            <a:ext cx="15727680" cy="617220"/>
+            <a:off x="1280160" y="2160270"/>
+            <a:ext cx="15727680" cy="565785"/>
           </a:xfrm>
           <a:prstGeom prst="rect">
             <a:avLst/>
@@ -20787,7 +20787,7 @@
         </p:nvCxnSpPr>
         <p:spPr>
           <a:xfrm>
-            <a:off x="1280160" y="3703320"/>
+            <a:off x="1280160" y="2880360"/>
             <a:ext cx="15727680" cy="0"/>
           </a:xfrm>
           <a:prstGeom prst="line">
@@ -20822,7 +20822,7 @@
         </p:nvSpPr>
         <p:spPr>
           <a:xfrm>
-            <a:off x="1280160" y="4011930"/>
+            <a:off x="1280160" y="3188970"/>
             <a:ext cx="7498080" cy="565785"/>
           </a:xfrm>
           <a:prstGeom prst="rect">
@@ -20865,7 +20865,7 @@
         </p:nvSpPr>
         <p:spPr>
           <a:xfrm>
-            <a:off x="1280160" y="4011930"/>
+            <a:off x="1280160" y="3188970"/>
             <a:ext cx="7498080" cy="565785"/>
           </a:xfrm>
           <a:prstGeom prst="rect">
@@ -20900,8 +20900,8 @@
         </p:nvSpPr>
         <p:spPr>
           <a:xfrm>
-            <a:off x="1280160" y="4608576"/>
-            <a:ext cx="7498080" cy="4526280"/>
+            <a:off x="1280160" y="3785616"/>
+            <a:ext cx="7498080" cy="5349240"/>
           </a:xfrm>
           <a:prstGeom prst="rect">
             <a:avLst/>
@@ -20943,8 +20943,8 @@
         </p:nvSpPr>
         <p:spPr>
           <a:xfrm>
-            <a:off x="1280160" y="4608576"/>
-            <a:ext cx="50292" cy="4526280"/>
+            <a:off x="1280160" y="3785616"/>
+            <a:ext cx="50292" cy="5349240"/>
           </a:xfrm>
           <a:prstGeom prst="rect">
             <a:avLst/>
@@ -20986,7 +20986,7 @@
         </p:nvSpPr>
         <p:spPr>
           <a:xfrm>
-            <a:off x="1463040" y="4711446"/>
+            <a:off x="1463040" y="3888486"/>
             <a:ext cx="6949440" cy="720090"/>
           </a:xfrm>
           <a:prstGeom prst="rect">
@@ -21021,7 +21021,7 @@
         </p:nvSpPr>
         <p:spPr>
           <a:xfrm>
-            <a:off x="1463040" y="5513832"/>
+            <a:off x="1463040" y="4762881"/>
             <a:ext cx="6949440" cy="720090"/>
           </a:xfrm>
           <a:prstGeom prst="rect">
@@ -21056,7 +21056,7 @@
         </p:nvSpPr>
         <p:spPr>
           <a:xfrm>
-            <a:off x="1463040" y="6316218"/>
+            <a:off x="1463040" y="5637276"/>
             <a:ext cx="6949440" cy="720090"/>
           </a:xfrm>
           <a:prstGeom prst="rect">
@@ -21091,7 +21091,7 @@
         </p:nvSpPr>
         <p:spPr>
           <a:xfrm>
-            <a:off x="1463040" y="7118604"/>
+            <a:off x="1463040" y="6511671"/>
             <a:ext cx="6949440" cy="720090"/>
           </a:xfrm>
           <a:prstGeom prst="rect">
@@ -21126,7 +21126,7 @@
         </p:nvSpPr>
         <p:spPr>
           <a:xfrm>
-            <a:off x="1463040" y="7920990"/>
+            <a:off x="1463040" y="7386066"/>
             <a:ext cx="6949440" cy="720090"/>
           </a:xfrm>
           <a:prstGeom prst="rect">
@@ -21161,7 +21161,7 @@
         </p:nvSpPr>
         <p:spPr>
           <a:xfrm>
-            <a:off x="9509760" y="4011930"/>
+            <a:off x="9509760" y="3188970"/>
             <a:ext cx="7498080" cy="565785"/>
           </a:xfrm>
           <a:prstGeom prst="rect">
@@ -21204,7 +21204,7 @@
         </p:nvSpPr>
         <p:spPr>
           <a:xfrm>
-            <a:off x="9509760" y="4011930"/>
+            <a:off x="9509760" y="3188970"/>
             <a:ext cx="7498080" cy="565785"/>
           </a:xfrm>
           <a:prstGeom prst="rect">
@@ -21239,8 +21239,8 @@
         </p:nvSpPr>
         <p:spPr>
           <a:xfrm>
-            <a:off x="9509760" y="4608576"/>
-            <a:ext cx="7498080" cy="4526280"/>
+            <a:off x="9509760" y="3785616"/>
+            <a:ext cx="7498080" cy="5349240"/>
           </a:xfrm>
           <a:prstGeom prst="rect">
             <a:avLst/>
@@ -21282,8 +21282,8 @@
         </p:nvSpPr>
         <p:spPr>
           <a:xfrm>
-            <a:off x="9509760" y="4608576"/>
-            <a:ext cx="50292" cy="4526280"/>
+            <a:off x="9509760" y="3785616"/>
+            <a:ext cx="50292" cy="5349240"/>
           </a:xfrm>
           <a:prstGeom prst="rect">
             <a:avLst/>
@@ -21325,7 +21325,7 @@
         </p:nvSpPr>
         <p:spPr>
           <a:xfrm>
-            <a:off x="9692640" y="4711446"/>
+            <a:off x="9692640" y="3888486"/>
             <a:ext cx="6949440" cy="720090"/>
           </a:xfrm>
           <a:prstGeom prst="rect">
@@ -21360,7 +21360,7 @@
         </p:nvSpPr>
         <p:spPr>
           <a:xfrm>
-            <a:off x="9692640" y="5513832"/>
+            <a:off x="9692640" y="4762881"/>
             <a:ext cx="6949440" cy="720090"/>
           </a:xfrm>
           <a:prstGeom prst="rect">
@@ -21395,7 +21395,7 @@
         </p:nvSpPr>
         <p:spPr>
           <a:xfrm>
-            <a:off x="9692640" y="6316218"/>
+            <a:off x="9692640" y="5637276"/>
             <a:ext cx="6949440" cy="720090"/>
           </a:xfrm>
           <a:prstGeom prst="rect">
@@ -21430,7 +21430,7 @@
         </p:nvSpPr>
         <p:spPr>
           <a:xfrm>
-            <a:off x="9692640" y="7118604"/>
+            <a:off x="9692640" y="6511671"/>
             <a:ext cx="6949440" cy="720090"/>
           </a:xfrm>
           <a:prstGeom prst="rect">
@@ -21465,7 +21465,7 @@
         </p:nvSpPr>
         <p:spPr>
           <a:xfrm>
-            <a:off x="9692640" y="7920990"/>
+            <a:off x="9692640" y="7386066"/>
             <a:ext cx="6949440" cy="720090"/>
           </a:xfrm>
           <a:prstGeom prst="rect">
@@ -21682,7 +21682,7 @@
         </p:nvSpPr>
         <p:spPr>
           <a:xfrm>
-            <a:off x="1280160" y="1440180"/>
+            <a:off x="1280160" y="1028700"/>
             <a:ext cx="15727680" cy="1234440"/>
           </a:xfrm>
           <a:prstGeom prst="rect">
@@ -21717,8 +21717,8 @@
         </p:nvSpPr>
         <p:spPr>
           <a:xfrm>
-            <a:off x="1280160" y="2880360"/>
-            <a:ext cx="15727680" cy="617220"/>
+            <a:off x="1280160" y="2160270"/>
+            <a:ext cx="15727680" cy="565785"/>
           </a:xfrm>
           <a:prstGeom prst="rect">
             <a:avLst/>
@@ -21752,7 +21752,7 @@
         </p:nvCxnSpPr>
         <p:spPr>
           <a:xfrm>
-            <a:off x="1280160" y="3703320"/>
+            <a:off x="1280160" y="2880360"/>
             <a:ext cx="15727680" cy="0"/>
           </a:xfrm>
           <a:prstGeom prst="line">
@@ -21787,7 +21787,7 @@
         </p:nvSpPr>
         <p:spPr>
           <a:xfrm>
-            <a:off x="1280160" y="4011930"/>
+            <a:off x="1280160" y="3188970"/>
             <a:ext cx="7315200" cy="565785"/>
           </a:xfrm>
           <a:prstGeom prst="rect">
@@ -21830,7 +21830,7 @@
         </p:nvSpPr>
         <p:spPr>
           <a:xfrm>
-            <a:off x="1280160" y="4011930"/>
+            <a:off x="1280160" y="3188970"/>
             <a:ext cx="7315200" cy="565785"/>
           </a:xfrm>
           <a:prstGeom prst="rect">
@@ -21865,8 +21865,8 @@
         </p:nvSpPr>
         <p:spPr>
           <a:xfrm>
-            <a:off x="1280160" y="4608576"/>
-            <a:ext cx="7315200" cy="4423410"/>
+            <a:off x="1280160" y="3785616"/>
+            <a:ext cx="7315200" cy="5246370"/>
           </a:xfrm>
           <a:prstGeom prst="rect">
             <a:avLst/>
@@ -21908,8 +21908,8 @@
         </p:nvSpPr>
         <p:spPr>
           <a:xfrm>
-            <a:off x="1280160" y="4608576"/>
-            <a:ext cx="50292" cy="4423410"/>
+            <a:off x="1280160" y="3785616"/>
+            <a:ext cx="50292" cy="5246370"/>
           </a:xfrm>
           <a:prstGeom prst="rect">
             <a:avLst/>
@@ -21951,7 +21951,7 @@
         </p:nvSpPr>
         <p:spPr>
           <a:xfrm>
-            <a:off x="1463040" y="4732020"/>
+            <a:off x="1463040" y="3909060"/>
             <a:ext cx="6583680" cy="720090"/>
           </a:xfrm>
           <a:prstGeom prst="rect">
@@ -21986,7 +21986,7 @@
         </p:nvSpPr>
         <p:spPr>
           <a:xfrm>
-            <a:off x="1463040" y="5534406"/>
+            <a:off x="1463040" y="4680585"/>
             <a:ext cx="6583680" cy="720090"/>
           </a:xfrm>
           <a:prstGeom prst="rect">
@@ -22021,7 +22021,7 @@
         </p:nvSpPr>
         <p:spPr>
           <a:xfrm>
-            <a:off x="1463040" y="6305931"/>
+            <a:off x="1463040" y="5524119"/>
             <a:ext cx="6583680" cy="720090"/>
           </a:xfrm>
           <a:prstGeom prst="rect">
@@ -22056,7 +22056,7 @@
         </p:nvSpPr>
         <p:spPr>
           <a:xfrm>
-            <a:off x="1463040" y="7077456"/>
+            <a:off x="1463040" y="6367653"/>
             <a:ext cx="6583680" cy="720090"/>
           </a:xfrm>
           <a:prstGeom prst="rect">
@@ -22091,7 +22091,7 @@
         </p:nvSpPr>
         <p:spPr>
           <a:xfrm>
-            <a:off x="1463040" y="7848981"/>
+            <a:off x="1463040" y="7211187"/>
             <a:ext cx="6583680" cy="720090"/>
           </a:xfrm>
           <a:prstGeom prst="rect">
@@ -22126,7 +22126,7 @@
         </p:nvSpPr>
         <p:spPr>
           <a:xfrm>
-            <a:off x="9692640" y="4011930"/>
+            <a:off x="9692640" y="3188970"/>
             <a:ext cx="7315200" cy="565785"/>
           </a:xfrm>
           <a:prstGeom prst="rect">
@@ -22169,7 +22169,7 @@
         </p:nvSpPr>
         <p:spPr>
           <a:xfrm>
-            <a:off x="9692640" y="4011930"/>
+            <a:off x="9692640" y="3188970"/>
             <a:ext cx="7315200" cy="565785"/>
           </a:xfrm>
           <a:prstGeom prst="rect">
@@ -22204,8 +22204,8 @@
         </p:nvSpPr>
         <p:spPr>
           <a:xfrm>
-            <a:off x="9692640" y="4608576"/>
-            <a:ext cx="7315200" cy="4423410"/>
+            <a:off x="9692640" y="3785616"/>
+            <a:ext cx="7315200" cy="5246370"/>
           </a:xfrm>
           <a:prstGeom prst="rect">
             <a:avLst/>
@@ -22247,8 +22247,8 @@
         </p:nvSpPr>
         <p:spPr>
           <a:xfrm>
-            <a:off x="9692640" y="4608576"/>
-            <a:ext cx="50292" cy="4423410"/>
+            <a:off x="9692640" y="3785616"/>
+            <a:ext cx="50292" cy="5246370"/>
           </a:xfrm>
           <a:prstGeom prst="rect">
             <a:avLst/>
@@ -22290,7 +22290,7 @@
         </p:nvSpPr>
         <p:spPr>
           <a:xfrm>
-            <a:off x="9875520" y="4732020"/>
+            <a:off x="9875520" y="3909060"/>
             <a:ext cx="6583680" cy="720090"/>
           </a:xfrm>
           <a:prstGeom prst="rect">
@@ -22325,7 +22325,7 @@
         </p:nvSpPr>
         <p:spPr>
           <a:xfrm>
-            <a:off x="9875520" y="5534406"/>
+            <a:off x="9875520" y="4680585"/>
             <a:ext cx="6583680" cy="720090"/>
           </a:xfrm>
           <a:prstGeom prst="rect">
@@ -22360,7 +22360,7 @@
         </p:nvSpPr>
         <p:spPr>
           <a:xfrm>
-            <a:off x="9875520" y="6305931"/>
+            <a:off x="9875520" y="5524119"/>
             <a:ext cx="6583680" cy="720090"/>
           </a:xfrm>
           <a:prstGeom prst="rect">
@@ -22395,7 +22395,7 @@
         </p:nvSpPr>
         <p:spPr>
           <a:xfrm>
-            <a:off x="9875520" y="7077456"/>
+            <a:off x="9875520" y="6367653"/>
             <a:ext cx="6583680" cy="720090"/>
           </a:xfrm>
           <a:prstGeom prst="rect">
@@ -22430,7 +22430,7 @@
         </p:nvSpPr>
         <p:spPr>
           <a:xfrm>
-            <a:off x="9875520" y="7848981"/>
+            <a:off x="9875520" y="7211187"/>
             <a:ext cx="6583680" cy="720090"/>
           </a:xfrm>
           <a:prstGeom prst="rect">
@@ -22682,7 +22682,7 @@
         </p:nvSpPr>
         <p:spPr>
           <a:xfrm>
-            <a:off x="1280160" y="1440180"/>
+            <a:off x="1280160" y="1028700"/>
             <a:ext cx="15727680" cy="1234440"/>
           </a:xfrm>
           <a:prstGeom prst="rect">
@@ -22717,7 +22717,7 @@
         </p:nvCxnSpPr>
         <p:spPr>
           <a:xfrm>
-            <a:off x="1280160" y="2777490"/>
+            <a:off x="1280160" y="2468880"/>
             <a:ext cx="15727680" cy="0"/>
           </a:xfrm>
           <a:prstGeom prst="line">
@@ -22752,7 +22752,7 @@
         </p:nvSpPr>
         <p:spPr>
           <a:xfrm>
-            <a:off x="1280160" y="3086100"/>
+            <a:off x="1280160" y="2777490"/>
             <a:ext cx="7498080" cy="565785"/>
           </a:xfrm>
           <a:prstGeom prst="rect">
@@ -22830,8 +22830,8 @@
         </p:nvSpPr>
         <p:spPr>
           <a:xfrm>
-            <a:off x="1280160" y="3682746"/>
-            <a:ext cx="7498080" cy="2057400"/>
+            <a:off x="1280160" y="3374136"/>
+            <a:ext cx="7498080" cy="2160270"/>
           </a:xfrm>
           <a:prstGeom prst="rect">
             <a:avLst/>
@@ -22873,8 +22873,8 @@
         </p:nvSpPr>
         <p:spPr>
           <a:xfrm>
-            <a:off x="1280160" y="3682746"/>
-            <a:ext cx="50292" cy="2057400"/>
+            <a:off x="1280160" y="3374136"/>
+            <a:ext cx="50292" cy="2160270"/>
           </a:xfrm>
           <a:prstGeom prst="rect">
             <a:avLst/>
@@ -22916,8 +22916,8 @@
         </p:nvSpPr>
         <p:spPr>
           <a:xfrm>
-            <a:off x="1463040" y="3785616"/>
-            <a:ext cx="6766560" cy="1903095"/>
+            <a:off x="1463040" y="3477006"/>
+            <a:ext cx="6766560" cy="2005965"/>
           </a:xfrm>
           <a:prstGeom prst="rect">
             <a:avLst/>
@@ -22981,7 +22981,7 @@
         </p:nvSpPr>
         <p:spPr>
           <a:xfrm>
-            <a:off x="9509760" y="3086100"/>
+            <a:off x="9509760" y="2777490"/>
             <a:ext cx="7498080" cy="565785"/>
           </a:xfrm>
           <a:prstGeom prst="rect">
@@ -23059,8 +23059,8 @@
         </p:nvSpPr>
         <p:spPr>
           <a:xfrm>
-            <a:off x="9509760" y="3682746"/>
-            <a:ext cx="7498080" cy="2057400"/>
+            <a:off x="9509760" y="3374136"/>
+            <a:ext cx="7498080" cy="2160270"/>
           </a:xfrm>
           <a:prstGeom prst="rect">
             <a:avLst/>
@@ -23102,8 +23102,8 @@
         </p:nvSpPr>
         <p:spPr>
           <a:xfrm>
-            <a:off x="9509760" y="3682746"/>
-            <a:ext cx="50292" cy="2057400"/>
+            <a:off x="9509760" y="3374136"/>
+            <a:ext cx="50292" cy="2160270"/>
           </a:xfrm>
           <a:prstGeom prst="rect">
             <a:avLst/>
@@ -23145,8 +23145,8 @@
         </p:nvSpPr>
         <p:spPr>
           <a:xfrm>
-            <a:off x="9692640" y="3785616"/>
-            <a:ext cx="6766560" cy="1903095"/>
+            <a:off x="9692640" y="3477006"/>
+            <a:ext cx="6766560" cy="2005965"/>
           </a:xfrm>
           <a:prstGeom prst="rect">
             <a:avLst/>
@@ -23210,7 +23210,7 @@
         </p:nvCxnSpPr>
         <p:spPr>
           <a:xfrm>
-            <a:off x="1280160" y="5915025"/>
+            <a:off x="1280160" y="5637276"/>
             <a:ext cx="15727680" cy="0"/>
           </a:xfrm>
           <a:prstGeom prst="line">
@@ -23245,7 +23245,7 @@
         </p:nvSpPr>
         <p:spPr>
           <a:xfrm>
-            <a:off x="0" y="5966460"/>
+            <a:off x="0" y="5688711"/>
             <a:ext cx="82296" cy="565785"/>
           </a:xfrm>
           <a:prstGeom prst="rect">
@@ -23358,8 +23358,8 @@
         </p:nvSpPr>
         <p:spPr>
           <a:xfrm>
-            <a:off x="1280160" y="7046595"/>
-            <a:ext cx="5120640" cy="2880360"/>
+            <a:off x="1280160" y="6635115"/>
+            <a:ext cx="5120640" cy="3188970"/>
           </a:xfrm>
           <a:prstGeom prst="rect">
             <a:avLst/>
@@ -23401,8 +23401,8 @@
         </p:nvSpPr>
         <p:spPr>
           <a:xfrm>
-            <a:off x="1280160" y="7046595"/>
-            <a:ext cx="50292" cy="2880360"/>
+            <a:off x="1280160" y="6635115"/>
+            <a:ext cx="50292" cy="3188970"/>
           </a:xfrm>
           <a:prstGeom prst="rect">
             <a:avLst/>
@@ -23479,7 +23479,7 @@
         </p:nvSpPr>
         <p:spPr>
           <a:xfrm>
-            <a:off x="1444752" y="7540371"/>
+            <a:off x="1444752" y="7128890"/>
             <a:ext cx="4572000" cy="617220"/>
           </a:xfrm>
           <a:prstGeom prst="rect">
@@ -23514,7 +23514,7 @@
         </p:nvSpPr>
         <p:spPr>
           <a:xfrm>
-            <a:off x="1444752" y="8157591"/>
+            <a:off x="1444752" y="7694676"/>
             <a:ext cx="4572000" cy="822960"/>
           </a:xfrm>
           <a:prstGeom prst="rect">
@@ -23549,7 +23549,7 @@
         </p:nvSpPr>
         <p:spPr>
           <a:xfrm>
-            <a:off x="1444752" y="8980551"/>
+            <a:off x="1444752" y="8517636"/>
             <a:ext cx="4572000" cy="617220"/>
           </a:xfrm>
           <a:prstGeom prst="rect">
@@ -23584,8 +23584,8 @@
         </p:nvSpPr>
         <p:spPr>
           <a:xfrm>
-            <a:off x="6949440" y="7046595"/>
-            <a:ext cx="5120640" cy="2880360"/>
+            <a:off x="6949440" y="6635115"/>
+            <a:ext cx="5120640" cy="3188970"/>
           </a:xfrm>
           <a:prstGeom prst="rect">
             <a:avLst/>
@@ -23627,8 +23627,8 @@
         </p:nvSpPr>
         <p:spPr>
           <a:xfrm>
-            <a:off x="6949440" y="7046595"/>
-            <a:ext cx="50292" cy="2880360"/>
+            <a:off x="6949440" y="6635115"/>
+            <a:ext cx="50292" cy="3188970"/>
           </a:xfrm>
           <a:prstGeom prst="rect">
             <a:avLst/>
@@ -23705,7 +23705,7 @@
         </p:nvSpPr>
         <p:spPr>
           <a:xfrm>
-            <a:off x="7114032" y="7540371"/>
+            <a:off x="7114032" y="7128890"/>
             <a:ext cx="4572000" cy="617220"/>
           </a:xfrm>
           <a:prstGeom prst="rect">
@@ -23740,7 +23740,7 @@
         </p:nvSpPr>
         <p:spPr>
           <a:xfrm>
-            <a:off x="7114032" y="8157591"/>
+            <a:off x="7114032" y="7694676"/>
             <a:ext cx="4572000" cy="822960"/>
           </a:xfrm>
           <a:prstGeom prst="rect">
@@ -23775,7 +23775,7 @@
         </p:nvSpPr>
         <p:spPr>
           <a:xfrm>
-            <a:off x="7114032" y="8980551"/>
+            <a:off x="7114032" y="8517636"/>
             <a:ext cx="4572000" cy="617220"/>
           </a:xfrm>
           <a:prstGeom prst="rect">
@@ -23810,8 +23810,8 @@
         </p:nvSpPr>
         <p:spPr>
           <a:xfrm>
-            <a:off x="12618720" y="7046595"/>
-            <a:ext cx="5120640" cy="2880360"/>
+            <a:off x="12618720" y="6635115"/>
+            <a:ext cx="5120640" cy="3188970"/>
           </a:xfrm>
           <a:prstGeom prst="rect">
             <a:avLst/>
@@ -23853,8 +23853,8 @@
         </p:nvSpPr>
         <p:spPr>
           <a:xfrm>
-            <a:off x="12618720" y="7046595"/>
-            <a:ext cx="50292" cy="2880360"/>
+            <a:off x="12618720" y="6635115"/>
+            <a:ext cx="50292" cy="3188970"/>
           </a:xfrm>
           <a:prstGeom prst="rect">
             <a:avLst/>
@@ -23931,7 +23931,7 @@
         </p:nvSpPr>
         <p:spPr>
           <a:xfrm>
-            <a:off x="12783312" y="7540371"/>
+            <a:off x="12783312" y="7128890"/>
             <a:ext cx="4572000" cy="617220"/>
           </a:xfrm>
           <a:prstGeom prst="rect">
@@ -23966,7 +23966,7 @@
         </p:nvSpPr>
         <p:spPr>
           <a:xfrm>
-            <a:off x="12783312" y="8157591"/>
+            <a:off x="12783312" y="7694676"/>
             <a:ext cx="4572000" cy="822960"/>
           </a:xfrm>
           <a:prstGeom prst="rect">
@@ -24001,7 +24001,7 @@
         </p:nvSpPr>
         <p:spPr>
           <a:xfrm>
-            <a:off x="12783312" y="8980551"/>
+            <a:off x="12783312" y="8517636"/>
             <a:ext cx="4572000" cy="617220"/>
           </a:xfrm>
           <a:prstGeom prst="rect">

</xml_diff>